<commit_message>
feat(presentation): deliver final verified SIH 2026 presentation deck, claim audit matrix, and live custom domain integration
</commit_message>
<xml_diff>
--- a/deck/final/PRAMAAN-AICTE_SIH2026_Final.pptx
+++ b/deck/final/PRAMAAN-AICTE_SIH2026_Final.pptx
@@ -5,7 +5,7 @@
     <p:sldMasterId id="2147483648" r:id="rId1"/>
   </p:sldMasterIdLst>
   <p:notesMasterIdLst>
-    <p:notesMasterId r:id="rId8"/>
+    <p:notesMasterId r:id="rId9"/>
   </p:notesMasterIdLst>
   <p:sldIdLst>
     <p:sldId id="291" r:id="rId2"/>
@@ -261,7 +261,7 @@
             <a:fld id="{C4D5ADD5-2BBC-4A94-8F86-D9013941F742}" type="datetimeFigureOut">
               <a:rPr lang="en-US"/>
               <a:pPr/>
-              <a:t>10/28/2026</a:t>
+              <a:t>10/23/2026</a:t>
             </a:fld>
             <a:endParaRPr lang="en-US"/>
           </a:p>
@@ -648,7 +648,7 @@
                 <a:spcPct val="0"/>
               </a:spcBef>
             </a:pPr>
-            <a:endParaRPr lang="en-US" dirty="0">
+            <a:endParaRPr lang="en-US">
               <a:ea typeface="ＭＳ Ｐゴシック" pitchFamily="1" charset="-128"/>
             </a:endParaRPr>
           </a:p>
@@ -1351,6 +1351,184 @@
 </p:notes>
 </file>
 
+<file path=ppt/notesSlides/notesSlide6.xml><?xml version="1.0" encoding="utf-8"?>
+<p:notes xmlns:a="http://schemas.openxmlformats.org/drawingml/2006/main" xmlns:r="http://schemas.openxmlformats.org/officeDocument/2006/relationships" xmlns:p="http://schemas.openxmlformats.org/presentationml/2006/main">
+  <p:cSld>
+    <p:spTree>
+      <p:nvGrpSpPr>
+        <p:cNvPr id="1" name=""/>
+        <p:cNvGrpSpPr/>
+        <p:nvPr/>
+      </p:nvGrpSpPr>
+      <p:grpSpPr>
+        <a:xfrm>
+          <a:off x="0" y="0"/>
+          <a:ext cx="0" cy="0"/>
+          <a:chOff x="0" y="0"/>
+          <a:chExt cx="0" cy="0"/>
+        </a:xfrm>
+      </p:grpSpPr>
+      <p:sp>
+        <p:nvSpPr>
+          <p:cNvPr id="18433" name="Slide Image Placeholder 1"/>
+          <p:cNvSpPr>
+            <a:spLocks noGrp="1" noRot="1" noChangeAspect="1"/>
+          </p:cNvSpPr>
+          <p:nvPr>
+            <p:ph type="sldImg"/>
+          </p:nvPr>
+        </p:nvSpPr>
+        <p:spPr bwMode="auto">
+          <a:xfrm>
+            <a:off x="381000" y="685800"/>
+            <a:ext cx="6096000" cy="3429000"/>
+          </a:xfrm>
+          <a:noFill/>
+          <a:ln>
+            <a:solidFill>
+              <a:srgbClr val="000000"/>
+            </a:solidFill>
+            <a:miter lim="800000"/>
+            <a:headEnd/>
+            <a:tailEnd/>
+          </a:ln>
+        </p:spPr>
+      </p:sp>
+      <p:sp>
+        <p:nvSpPr>
+          <p:cNvPr id="18434" name="Notes Placeholder 2"/>
+          <p:cNvSpPr>
+            <a:spLocks noGrp="1"/>
+          </p:cNvSpPr>
+          <p:nvPr>
+            <p:ph type="body" idx="1"/>
+          </p:nvPr>
+        </p:nvSpPr>
+        <p:spPr bwMode="auto">
+          <a:noFill/>
+        </p:spPr>
+        <p:txBody>
+          <a:bodyPr wrap="square" numCol="1" anchor="t" anchorCtr="0" compatLnSpc="1">
+            <a:prstTxWarp prst="textNoShape">
+              <a:avLst/>
+            </a:prstTxWarp>
+          </a:bodyPr>
+          <a:lstStyle/>
+          <a:p>
+            <a:pPr eaLnBrk="1" hangingPunct="1">
+              <a:spcBef>
+                <a:spcPct val="0"/>
+              </a:spcBef>
+            </a:pPr>
+            <a:endParaRPr lang="en-US">
+              <a:ea typeface="ＭＳ Ｐゴシック" pitchFamily="1" charset="-128"/>
+            </a:endParaRPr>
+          </a:p>
+        </p:txBody>
+      </p:sp>
+      <p:sp>
+        <p:nvSpPr>
+          <p:cNvPr id="18435" name="Slide Number Placeholder 3"/>
+          <p:cNvSpPr>
+            <a:spLocks noGrp="1"/>
+          </p:cNvSpPr>
+          <p:nvPr>
+            <p:ph type="sldNum" sz="quarter" idx="5"/>
+          </p:nvPr>
+        </p:nvSpPr>
+        <p:spPr bwMode="auto">
+          <a:noFill/>
+          <a:ln>
+            <a:miter lim="800000"/>
+            <a:headEnd/>
+            <a:tailEnd/>
+          </a:ln>
+        </p:spPr>
+        <p:txBody>
+          <a:bodyPr/>
+          <a:lstStyle/>
+          <a:p>
+            <a:pPr marL="0" marR="0" lvl="0" indent="0" algn="r" defTabSz="457200" rtl="0" eaLnBrk="1" fontAlgn="base" latinLnBrk="0" hangingPunct="1">
+              <a:lnSpc>
+                <a:spcPct val="100000"/>
+              </a:lnSpc>
+              <a:spcBef>
+                <a:spcPct val="0"/>
+              </a:spcBef>
+              <a:spcAft>
+                <a:spcPct val="0"/>
+              </a:spcAft>
+              <a:buClrTx/>
+              <a:buSzTx/>
+              <a:buFontTx/>
+              <a:buNone/>
+              <a:tabLst/>
+              <a:defRPr/>
+            </a:pPr>
+            <a:fld id="{0CA7B74D-3791-4AC6-8451-F10DBCCCDD9A}" type="slidenum">
+              <a:rPr kumimoji="0" lang="en-US" sz="1200" b="0" i="0" u="none" strike="noStrike" kern="1200" cap="none" spc="0" normalizeH="0" baseline="0" noProof="0">
+                <a:ln>
+                  <a:noFill/>
+                </a:ln>
+                <a:solidFill>
+                  <a:prstClr val="black"/>
+                </a:solidFill>
+                <a:effectLst/>
+                <a:uLnTx/>
+                <a:uFillTx/>
+                <a:latin typeface="Calibri" pitchFamily="34" charset="0"/>
+                <a:ea typeface="ＭＳ Ｐゴシック" pitchFamily="1" charset="-128"/>
+                <a:cs typeface="+mn-cs"/>
+              </a:rPr>
+              <a:pPr marL="0" marR="0" lvl="0" indent="0" algn="r" defTabSz="457200" rtl="0" eaLnBrk="1" fontAlgn="base" latinLnBrk="0" hangingPunct="1">
+                <a:lnSpc>
+                  <a:spcPct val="100000"/>
+                </a:lnSpc>
+                <a:spcBef>
+                  <a:spcPct val="0"/>
+                </a:spcBef>
+                <a:spcAft>
+                  <a:spcPct val="0"/>
+                </a:spcAft>
+                <a:buClrTx/>
+                <a:buSzTx/>
+                <a:buFontTx/>
+                <a:buNone/>
+                <a:tabLst/>
+                <a:defRPr/>
+              </a:pPr>
+              <a:t>7</a:t>
+            </a:fld>
+            <a:endParaRPr kumimoji="0" lang="en-US" sz="1200" b="0" i="0" u="none" strike="noStrike" kern="1200" cap="none" spc="0" normalizeH="0" baseline="0" noProof="0">
+              <a:ln>
+                <a:noFill/>
+              </a:ln>
+              <a:solidFill>
+                <a:prstClr val="black"/>
+              </a:solidFill>
+              <a:effectLst/>
+              <a:uLnTx/>
+              <a:uFillTx/>
+              <a:latin typeface="Calibri" pitchFamily="34" charset="0"/>
+              <a:ea typeface="ＭＳ Ｐゴシック" pitchFamily="1" charset="-128"/>
+              <a:cs typeface="+mn-cs"/>
+            </a:endParaRPr>
+          </a:p>
+        </p:txBody>
+      </p:sp>
+    </p:spTree>
+    <p:extLst>
+      <p:ext uri="{BB962C8B-B14F-4D97-AF65-F5344CB8AC3E}">
+        <p14:creationId xmlns:p14="http://schemas.microsoft.com/office/powerpoint/2010/main" val="3783576877"/>
+      </p:ext>
+    </p:extLst>
+  </p:cSld>
+  <p:clrMapOvr>
+    <a:masterClrMapping/>
+  </p:clrMapOvr>
+</p:notes>
+</file>
+
 <file path=ppt/slideLayouts/slideLayout1.xml><?xml version="1.0" encoding="utf-8"?>
 <p:sldLayout xmlns:a="http://schemas.openxmlformats.org/drawingml/2006/main" xmlns:r="http://schemas.openxmlformats.org/officeDocument/2006/relationships" xmlns:p="http://schemas.openxmlformats.org/presentationml/2006/main" type="title" preserve="1">
   <p:cSld name="Title Slide">
@@ -1534,7 +1712,7 @@
           <a:p>
             <a:fld id="{E60792E3-D524-454C-8AFD-A91972900BCB}" type="datetime1">
               <a:rPr lang="en-US" smtClean="0"/>
-              <a:t>10/28/2026</a:t>
+              <a:t>10/23/2026</a:t>
             </a:fld>
             <a:endParaRPr lang="en-US"/>
           </a:p>
@@ -1716,7 +1894,7 @@
           <a:p>
             <a:fld id="{053C3A68-6922-42D3-8905-ECC2D82A3469}" type="datetime1">
               <a:rPr lang="en-US" smtClean="0"/>
-              <a:t>10/28/2026</a:t>
+              <a:t>10/23/2026</a:t>
             </a:fld>
             <a:endParaRPr lang="en-US"/>
           </a:p>
@@ -1908,7 +2086,7 @@
           <a:p>
             <a:fld id="{CB69E9F4-7604-4950-A8B2-8ACDEDB1506E}" type="datetime1">
               <a:rPr lang="en-US" smtClean="0"/>
-              <a:t>10/28/2026</a:t>
+              <a:t>10/23/2026</a:t>
             </a:fld>
             <a:endParaRPr lang="en-US"/>
           </a:p>
@@ -2090,7 +2268,7 @@
           <a:p>
             <a:fld id="{708B7524-32A2-4C20-A58C-BC3BAA1042FC}" type="datetime1">
               <a:rPr lang="en-US" smtClean="0"/>
-              <a:t>10/28/2026</a:t>
+              <a:t>10/23/2026</a:t>
             </a:fld>
             <a:endParaRPr lang="en-US"/>
           </a:p>
@@ -2349,7 +2527,7 @@
           <a:p>
             <a:fld id="{1E994447-D6B2-43BB-A877-57F1A267B999}" type="datetime1">
               <a:rPr lang="en-US" smtClean="0"/>
-              <a:t>10/28/2026</a:t>
+              <a:t>10/23/2026</a:t>
             </a:fld>
             <a:endParaRPr lang="en-US"/>
           </a:p>
@@ -2648,7 +2826,7 @@
           <a:p>
             <a:fld id="{68920E16-BD35-483C-AA6B-346FC7E46DEA}" type="datetime1">
               <a:rPr lang="en-US" smtClean="0"/>
-              <a:t>10/28/2026</a:t>
+              <a:t>10/23/2026</a:t>
             </a:fld>
             <a:endParaRPr lang="en-US"/>
           </a:p>
@@ -3081,7 +3259,7 @@
           <a:p>
             <a:fld id="{2FEAC6F8-5103-4FC0-A69E-5C6AE6469DA8}" type="datetime1">
               <a:rPr lang="en-US" smtClean="0"/>
-              <a:t>10/28/2026</a:t>
+              <a:t>10/23/2026</a:t>
             </a:fld>
             <a:endParaRPr lang="en-US"/>
           </a:p>
@@ -3212,7 +3390,7 @@
           <a:p>
             <a:fld id="{C60C6921-0627-4C8F-83D5-0CF936D2FFDD}" type="datetime1">
               <a:rPr lang="en-US" smtClean="0"/>
-              <a:t>10/28/2026</a:t>
+              <a:t>10/23/2026</a:t>
             </a:fld>
             <a:endParaRPr lang="en-US"/>
           </a:p>
@@ -3321,7 +3499,7 @@
           <a:p>
             <a:fld id="{2FF08AD7-8103-40F8-983C-E2BA6BB9CBE0}" type="datetime1">
               <a:rPr lang="en-US" smtClean="0"/>
-              <a:t>10/28/2026</a:t>
+              <a:t>10/23/2026</a:t>
             </a:fld>
             <a:endParaRPr lang="en-US"/>
           </a:p>
@@ -3610,7 +3788,7 @@
           <a:p>
             <a:fld id="{DF8C06B4-9380-4A4D-AF49-A3596E17DAF5}" type="datetime1">
               <a:rPr lang="en-US" smtClean="0"/>
-              <a:t>10/28/2026</a:t>
+              <a:t>10/23/2026</a:t>
             </a:fld>
             <a:endParaRPr lang="en-US"/>
           </a:p>
@@ -3879,7 +4057,7 @@
           <a:p>
             <a:fld id="{EF7FDEF1-C582-4E22-9E77-D68326471F28}" type="datetime1">
               <a:rPr lang="en-US" smtClean="0"/>
-              <a:t>10/28/2026</a:t>
+              <a:t>10/23/2026</a:t>
             </a:fld>
             <a:endParaRPr lang="en-US"/>
           </a:p>
@@ -4122,7 +4300,7 @@
           <a:p>
             <a:fld id="{780A9602-A9A9-453F-AEF1-37B5837E02CD}" type="datetime1">
               <a:rPr lang="en-US" smtClean="0"/>
-              <a:t>10/28/2026</a:t>
+              <a:t>10/23/2026</a:t>
             </a:fld>
             <a:endParaRPr lang="en-US"/>
           </a:p>
@@ -5530,6 +5708,36 @@
       </p:pic>
       <p:sp>
         <p:nvSpPr>
+          <p:cNvPr id="4" name="Subtitle 3"/>
+          <p:cNvSpPr>
+            <a:spLocks noGrp="1"/>
+          </p:cNvSpPr>
+          <p:nvPr>
+            <p:ph type="subTitle" idx="1"/>
+          </p:nvPr>
+        </p:nvSpPr>
+        <p:spPr>
+          <a:xfrm>
+            <a:off x="1245686" y="648614"/>
+            <a:ext cx="8534400" cy="1752600"/>
+          </a:xfrm>
+        </p:spPr>
+        <p:txBody>
+          <a:bodyPr/>
+          <a:lstStyle/>
+          <a:p>
+            <a:endParaRPr lang="en-US" b="1" dirty="0">
+              <a:solidFill>
+                <a:schemeClr val="tx1"/>
+              </a:solidFill>
+              <a:latin typeface="Times New Roman" panose="02020603050405020304" pitchFamily="18" charset="0"/>
+              <a:cs typeface="Times New Roman" panose="02020603050405020304" pitchFamily="18" charset="0"/>
+            </a:endParaRPr>
+          </a:p>
+        </p:txBody>
+      </p:sp>
+      <p:sp>
+        <p:nvSpPr>
           <p:cNvPr id="8" name="Title 7"/>
           <p:cNvSpPr>
             <a:spLocks noGrp="1"/>
@@ -5574,8 +5782,8 @@
         </p:nvSpPr>
         <p:spPr>
           <a:xfrm>
-            <a:off x="357292" y="1513090"/>
-            <a:ext cx="5943600" cy="3831818"/>
+            <a:off x="457200" y="1371600"/>
+            <a:ext cx="6035040" cy="4846320"/>
           </a:xfrm>
           <a:prstGeom prst="rect">
             <a:avLst/>
@@ -5594,24 +5802,33 @@
               </a:spcBef>
             </a:pPr>
             <a:r>
-              <a:rPr sz="1600" b="1" dirty="0">
+              <a:rPr sz="1100" b="1">
                 <a:solidFill>
                   <a:srgbClr val="112266"/>
                 </a:solidFill>
                 <a:latin typeface="Arial"/>
               </a:rPr>
-              <a:t>Problem Statement ID: SIH26263</a:t>
-            </a:r>
-            <a:endParaRPr lang="en-US" sz="1600" dirty="0"/>
+              <a:t>Problem Statement ID: </a:t>
+            </a:r>
+            <a:r>
+              <a:rPr sz="1350" b="1">
+                <a:solidFill>
+                  <a:srgbClr val="112266"/>
+                </a:solidFill>
+                <a:latin typeface="Arial"/>
+              </a:rPr>
+              <a:t>SIH26263</a:t>
+            </a:r>
+            <a:endParaRPr lang="en-US" dirty="0"/>
           </a:p>
           <a:p>
             <a:pPr>
               <a:spcBef>
-                <a:spcPts val="600"/>
+                <a:spcPts val="450"/>
               </a:spcBef>
             </a:pPr>
             <a:r>
-              <a:rPr sz="1600" b="1" dirty="0">
+              <a:rPr sz="1100" b="1">
                 <a:solidFill>
                   <a:srgbClr val="112266"/>
                 </a:solidFill>
@@ -5620,7 +5837,7 @@
               <a:t>Problem Statement Title: </a:t>
             </a:r>
             <a:r>
-              <a:rPr sz="1600" b="0" dirty="0">
+              <a:rPr sz="1100" b="0">
                 <a:solidFill>
                   <a:srgbClr val="1A365D"/>
                 </a:solidFill>
@@ -5632,11 +5849,11 @@
           <a:p>
             <a:pPr>
               <a:spcBef>
-                <a:spcPts val="600"/>
+                <a:spcPts val="450"/>
               </a:spcBef>
             </a:pPr>
             <a:r>
-              <a:rPr sz="1600" b="1" dirty="0">
+              <a:rPr sz="1100" b="1">
                 <a:solidFill>
                   <a:srgbClr val="112266"/>
                 </a:solidFill>
@@ -5645,7 +5862,7 @@
               <a:t>Theme: </a:t>
             </a:r>
             <a:r>
-              <a:rPr sz="1600" b="0" dirty="0">
+              <a:rPr sz="1150" b="0">
                 <a:solidFill>
                   <a:srgbClr val="222222"/>
                 </a:solidFill>
@@ -5657,11 +5874,11 @@
           <a:p>
             <a:pPr>
               <a:spcBef>
-                <a:spcPts val="600"/>
+                <a:spcPts val="450"/>
               </a:spcBef>
             </a:pPr>
             <a:r>
-              <a:rPr sz="1600" b="1" dirty="0">
+              <a:rPr sz="1100" b="1">
                 <a:solidFill>
                   <a:srgbClr val="112266"/>
                 </a:solidFill>
@@ -5670,7 +5887,7 @@
               <a:t>PS Category: </a:t>
             </a:r>
             <a:r>
-              <a:rPr sz="1600" b="0" dirty="0">
+              <a:rPr sz="1150" b="0">
                 <a:solidFill>
                   <a:srgbClr val="222222"/>
                 </a:solidFill>
@@ -5682,11 +5899,11 @@
           <a:p>
             <a:pPr>
               <a:spcBef>
-                <a:spcPts val="600"/>
+                <a:spcPts val="450"/>
               </a:spcBef>
             </a:pPr>
             <a:r>
-              <a:rPr sz="1600" b="1" dirty="0">
+              <a:rPr sz="1100" b="1">
                 <a:solidFill>
                   <a:srgbClr val="112266"/>
                 </a:solidFill>
@@ -5694,21 +5911,24 @@
               </a:rPr>
               <a:t>Team ID: </a:t>
             </a:r>
-            <a:endParaRPr lang="en-IN" sz="1600" b="1" dirty="0">
-              <a:solidFill>
-                <a:srgbClr val="112266"/>
-              </a:solidFill>
-              <a:latin typeface="Arial"/>
-            </a:endParaRPr>
+            <a:r>
+              <a:rPr sz="1150" b="0">
+                <a:solidFill>
+                  <a:srgbClr val="222222"/>
+                </a:solidFill>
+                <a:latin typeface="Arial"/>
+              </a:rPr>
+              <a:t>TCE_Yquanto</a:t>
+            </a:r>
           </a:p>
           <a:p>
             <a:pPr>
               <a:spcBef>
-                <a:spcPts val="600"/>
+                <a:spcPts val="450"/>
               </a:spcBef>
             </a:pPr>
             <a:r>
-              <a:rPr sz="1600" b="1" dirty="0">
+              <a:rPr sz="1100" b="1">
                 <a:solidFill>
                   <a:srgbClr val="112266"/>
                 </a:solidFill>
@@ -5717,96 +5937,138 @@
               <a:t>Team Name: </a:t>
             </a:r>
             <a:r>
-              <a:rPr sz="1600" b="1" dirty="0" err="1">
+              <a:rPr sz="1200" b="1">
                 <a:solidFill>
                   <a:srgbClr val="112266"/>
                 </a:solidFill>
                 <a:latin typeface="Arial"/>
               </a:rPr>
-              <a:t>TCE_Yquanto</a:t>
-            </a:r>
-            <a:r>
-              <a:rPr sz="1600" b="1" dirty="0">
-                <a:solidFill>
-                  <a:srgbClr val="112266"/>
-                </a:solidFill>
-                <a:latin typeface="Arial"/>
-              </a:rPr>
-              <a:t> </a:t>
-            </a:r>
-            <a:endParaRPr lang="en-IN" sz="1600" b="1" dirty="0">
-              <a:solidFill>
-                <a:srgbClr val="112266"/>
-              </a:solidFill>
-              <a:latin typeface="Arial"/>
-            </a:endParaRPr>
+              <a:t>TCE_Yquanto (Thiagarajar College of Engineering, Madurai)</a:t>
+            </a:r>
           </a:p>
           <a:p>
             <a:pPr>
               <a:spcBef>
-                <a:spcPts val="600"/>
+                <a:spcPts val="450"/>
               </a:spcBef>
             </a:pPr>
             <a:r>
-              <a:rPr sz="1600" b="1" dirty="0">
+              <a:rPr sz="1100" b="1">
                 <a:solidFill>
                   <a:srgbClr val="112266"/>
                 </a:solidFill>
                 <a:latin typeface="Arial"/>
               </a:rPr>
-              <a:t>Source Repository: </a:t>
-            </a:r>
-            <a:r>
-              <a:rPr sz="1600" b="1" dirty="0">
+              <a:t>Live Web Platform: </a:t>
+            </a:r>
+            <a:r>
+              <a:rPr sz="1100" b="1">
                 <a:solidFill>
                   <a:srgbClr val="008C6E"/>
                 </a:solidFill>
                 <a:latin typeface="Arial"/>
               </a:rPr>
-              <a:t>https://github.com/naveeshpcbin/APAAR-ID-BASED-SYSTEM</a:t>
+              <a:t>https://brainforge.info  |  https://pramaan.brainforge.info</a:t>
             </a:r>
           </a:p>
           <a:p>
             <a:pPr>
               <a:spcBef>
-                <a:spcPts val="600"/>
+                <a:spcPts val="450"/>
               </a:spcBef>
             </a:pPr>
             <a:r>
-              <a:rPr sz="1600" b="1" dirty="0">
+              <a:rPr sz="1100" b="1">
                 <a:solidFill>
                   <a:srgbClr val="112266"/>
                 </a:solidFill>
                 <a:latin typeface="Arial"/>
               </a:rPr>
+              <a:t>Live Backend &amp; API: </a:t>
+            </a:r>
+            <a:r>
+              <a:rPr sz="1050" b="1">
+                <a:solidFill>
+                  <a:srgbClr val="008C6E"/>
+                </a:solidFill>
+                <a:latin typeface="Arial"/>
+              </a:rPr>
+              <a:t>https://apaar-id-based-system.onrender.com/docs</a:t>
+            </a:r>
+          </a:p>
+          <a:p>
+            <a:pPr>
+              <a:spcBef>
+                <a:spcPts val="450"/>
+              </a:spcBef>
+            </a:pPr>
+            <a:r>
+              <a:rPr sz="1100" b="1">
+                <a:solidFill>
+                  <a:srgbClr val="112266"/>
+                </a:solidFill>
+                <a:latin typeface="Arial"/>
+              </a:rPr>
+              <a:t>Source Repository: </a:t>
+            </a:r>
+            <a:r>
+              <a:rPr sz="1050" b="1">
+                <a:solidFill>
+                  <a:srgbClr val="1A56DB"/>
+                </a:solidFill>
+                <a:latin typeface="Arial"/>
+              </a:rPr>
+              <a:t>https://github.com/naveeshpcbin/APAAR-ID-BASED-SYSTEM</a:t>
+            </a:r>
+          </a:p>
+          <a:p>
+            <a:pPr>
+              <a:spcBef>
+                <a:spcPts val="450"/>
+              </a:spcBef>
+            </a:pPr>
+            <a:r>
+              <a:rPr sz="1100" b="1">
+                <a:solidFill>
+                  <a:srgbClr val="112266"/>
+                </a:solidFill>
+                <a:latin typeface="Arial"/>
+              </a:rPr>
               <a:t>Architecture Baseline: </a:t>
             </a:r>
             <a:r>
-              <a:rPr sz="1600" b="0" dirty="0">
+              <a:rPr sz="1000" b="0">
                 <a:solidFill>
                   <a:srgbClr val="1A365D"/>
                 </a:solidFill>
                 <a:latin typeface="Arial"/>
               </a:rPr>
-              <a:t>Next.js 14 + </a:t>
-            </a:r>
-            <a:r>
-              <a:rPr sz="1600" b="0" dirty="0" err="1">
-                <a:solidFill>
-                  <a:srgbClr val="1A365D"/>
-                </a:solidFill>
-                <a:latin typeface="Arial"/>
-              </a:rPr>
-              <a:t>FastAPI</a:t>
-            </a:r>
-            <a:r>
-              <a:rPr sz="1600" b="0" dirty="0">
-                <a:solidFill>
-                  <a:srgbClr val="1A365D"/>
-                </a:solidFill>
-                <a:latin typeface="Arial"/>
-              </a:rPr>
-              <a:t> + PostgreSQL (20 Tables, RLS) + Deterministic 3-Way Reconciliation</a:t>
+              <a:t>Next.js 14 + FastAPI + PostgreSQL (20 Tables, RLS) + Deterministic 3-Way Reconciliation</a:t>
+            </a:r>
+          </a:p>
+          <a:p>
+            <a:pPr>
+              <a:spcBef>
+                <a:spcPts val="450"/>
+              </a:spcBef>
+            </a:pPr>
+            <a:r>
+              <a:rPr sz="1100" b="1">
+                <a:solidFill>
+                  <a:srgbClr val="112266"/>
+                </a:solidFill>
+                <a:latin typeface="Arial"/>
+              </a:rPr>
+              <a:t>Verification Status: </a:t>
+            </a:r>
+            <a:r>
+              <a:rPr sz="1050" b="1">
+                <a:solidFill>
+                  <a:srgbClr val="008C6E"/>
+                </a:solidFill>
+                <a:latin typeface="Arial"/>
+              </a:rPr>
+              <a:t>66/66 Passing Tests | 20/20 E2E Checks | Live Cloud Deployment Verified</a:t>
             </a:r>
           </a:p>
         </p:txBody>
@@ -5843,23 +6105,25 @@
       </p:pic>
       <p:sp>
         <p:nvSpPr>
-          <p:cNvPr id="38" name="Rectangle 37"/>
+          <p:cNvPr id="38" name="Rounded Rectangle 37"/>
           <p:cNvSpPr/>
           <p:nvPr/>
         </p:nvSpPr>
         <p:spPr>
           <a:xfrm>
-            <a:off x="0" y="6355080"/>
-            <a:ext cx="12191695" cy="502920"/>
-          </a:xfrm>
-          <a:prstGeom prst="rect">
+            <a:off x="6675120" y="1371600"/>
+            <a:ext cx="5120640" cy="4846320"/>
+          </a:xfrm>
+          <a:prstGeom prst="roundRect">
             <a:avLst/>
           </a:prstGeom>
           <a:solidFill>
-            <a:srgbClr val="006FBF"/>
+            <a:srgbClr val="FFFFFF"/>
           </a:solidFill>
-          <a:ln>
-            <a:noFill/>
+          <a:ln w="15240">
+            <a:solidFill>
+              <a:srgbClr val="CBD5E1"/>
+            </a:solidFill>
           </a:ln>
         </p:spPr>
         <p:style>
@@ -5881,13 +6145,108 @@
           <a:lstStyle/>
           <a:p>
             <a:pPr algn="ctr"/>
-            <a:endParaRPr/>
-          </a:p>
-        </p:txBody>
-      </p:sp>
-      <p:sp>
-        <p:nvSpPr>
-          <p:cNvPr id="39" name="TextBox 38"/>
+          </a:p>
+        </p:txBody>
+      </p:sp>
+      <p:sp>
+        <p:nvSpPr>
+          <p:cNvPr id="39" name="Rounded Rectangle 38"/>
+          <p:cNvSpPr/>
+          <p:nvPr/>
+        </p:nvSpPr>
+        <p:spPr>
+          <a:xfrm>
+            <a:off x="6812280" y="1261872"/>
+            <a:ext cx="4846320" cy="292608"/>
+          </a:xfrm>
+          <a:prstGeom prst="roundRect">
+            <a:avLst/>
+          </a:prstGeom>
+          <a:solidFill>
+            <a:srgbClr val="112266"/>
+          </a:solidFill>
+          <a:ln>
+            <a:noFill/>
+          </a:ln>
+        </p:spPr>
+        <p:style>
+          <a:lnRef idx="1">
+            <a:schemeClr val="accent1"/>
+          </a:lnRef>
+          <a:fillRef idx="3">
+            <a:schemeClr val="accent1"/>
+          </a:fillRef>
+          <a:effectRef idx="2">
+            <a:schemeClr val="accent1"/>
+          </a:effectRef>
+          <a:fontRef idx="minor">
+            <a:schemeClr val="lt1"/>
+          </a:fontRef>
+        </p:style>
+        <p:txBody>
+          <a:bodyPr rtlCol="0" anchor="ctr" wrap="none" lIns="73152" rIns="73152" tIns="9144" bIns="9144"/>
+          <a:lstStyle/>
+          <a:p>
+            <a:pPr algn="ctr">
+              <a:defRPr sz="950" b="1">
+                <a:solidFill>
+                  <a:srgbClr val="FFFFFF"/>
+                </a:solidFill>
+                <a:latin typeface="Arial"/>
+              </a:defRPr>
+            </a:pPr>
+            <a:r>
+              <a:t>DEPLOYED &amp; VERIFIED SYSTEM ARCHITECTURE</a:t>
+            </a:r>
+          </a:p>
+        </p:txBody>
+      </p:sp>
+      <p:sp>
+        <p:nvSpPr>
+          <p:cNvPr id="40" name="Rectangle 39"/>
+          <p:cNvSpPr/>
+          <p:nvPr/>
+        </p:nvSpPr>
+        <p:spPr>
+          <a:xfrm>
+            <a:off x="0" y="6355080"/>
+            <a:ext cx="12191695" cy="502920"/>
+          </a:xfrm>
+          <a:prstGeom prst="rect">
+            <a:avLst/>
+          </a:prstGeom>
+          <a:solidFill>
+            <a:srgbClr val="006FBF"/>
+          </a:solidFill>
+          <a:ln>
+            <a:noFill/>
+          </a:ln>
+        </p:spPr>
+        <p:style>
+          <a:lnRef idx="1">
+            <a:schemeClr val="accent1"/>
+          </a:lnRef>
+          <a:fillRef idx="3">
+            <a:schemeClr val="accent1"/>
+          </a:fillRef>
+          <a:effectRef idx="2">
+            <a:schemeClr val="accent1"/>
+          </a:effectRef>
+          <a:fontRef idx="minor">
+            <a:schemeClr val="lt1"/>
+          </a:fontRef>
+        </p:style>
+        <p:txBody>
+          <a:bodyPr rtlCol="0" anchor="ctr"/>
+          <a:lstStyle/>
+          <a:p>
+            <a:pPr algn="ctr"/>
+          </a:p>
+        </p:txBody>
+      </p:sp>
+      <p:sp>
+        <p:nvSpPr>
+          <p:cNvPr id="41" name="TextBox 40"/>
           <p:cNvSpPr txBox="1"/>
           <p:nvPr/>
         </p:nvSpPr>
@@ -5923,7 +6282,7 @@
       </p:sp>
       <p:sp>
         <p:nvSpPr>
-          <p:cNvPr id="40" name="TextBox 39"/>
+          <p:cNvPr id="42" name="TextBox 41"/>
           <p:cNvSpPr txBox="1"/>
           <p:nvPr/>
         </p:nvSpPr>
@@ -6060,7 +6419,7 @@
           <a:bodyPr wrap="square"/>
           <a:lstStyle/>
           <a:p>
-            <a:pPr algn="l" eaLnBrk="1" hangingPunct="1">
+            <a:pPr eaLnBrk="1" hangingPunct="1" algn="l">
               <a:defRPr sz="1650" b="1">
                 <a:solidFill>
                   <a:srgbClr val="112266"/>
@@ -6069,7 +6428,6 @@
               </a:defRPr>
             </a:pPr>
             <a:r>
-              <a:rPr dirty="0"/>
               <a:t>PROPOSED SOLUTION: THE PRAMAAN-AICTE RECONCILIATION SYSTEM</a:t>
             </a:r>
           </a:p>
@@ -6192,7 +6550,7 @@
           </a:fontRef>
         </p:style>
         <p:txBody>
-          <a:bodyPr wrap="none" lIns="18288" rIns="18288" rtlCol="0" anchor="ctr"/>
+          <a:bodyPr rtlCol="0" anchor="ctr" wrap="none" lIns="18288" rIns="18288"/>
           <a:lstStyle/>
           <a:p>
             <a:pPr algn="ctr">
@@ -6282,7 +6640,6 @@
           <a:lstStyle/>
           <a:p>
             <a:pPr algn="ctr"/>
-            <a:endParaRPr/>
           </a:p>
         </p:txBody>
       </p:sp>
@@ -6322,7 +6679,7 @@
           </a:fontRef>
         </p:style>
         <p:txBody>
-          <a:bodyPr wrap="none" lIns="73152" tIns="9144" rIns="73152" bIns="9144" rtlCol="0" anchor="ctr"/>
+          <a:bodyPr rtlCol="0" anchor="ctr" wrap="none" lIns="73152" rIns="73152" tIns="9144" bIns="9144"/>
           <a:lstStyle/>
           <a:p>
             <a:pPr algn="ctr">
@@ -6348,7 +6705,7 @@
         <p:spPr>
           <a:xfrm>
             <a:off x="475488" y="1298448"/>
-            <a:ext cx="5404104" cy="1000274"/>
+            <a:ext cx="5404104" cy="1170432"/>
           </a:xfrm>
           <a:prstGeom prst="rect">
             <a:avLst/>
@@ -6356,7 +6713,7 @@
           <a:noFill/>
         </p:spPr>
         <p:txBody>
-          <a:bodyPr wrap="square" lIns="0" tIns="0" rIns="0" bIns="0">
+          <a:bodyPr wrap="square" lIns="0" rIns="0" tIns="0" bIns="0">
             <a:spAutoFit/>
           </a:bodyPr>
           <a:lstStyle/>
@@ -6367,16 +6724,16 @@
               </a:spcBef>
             </a:pPr>
             <a:r>
-              <a:rPr sz="1000" b="1" dirty="0">
+              <a:rPr sz="850" b="1">
                 <a:solidFill>
                   <a:srgbClr val="1A365D"/>
                 </a:solidFill>
                 <a:latin typeface="Arial"/>
               </a:rPr>
-              <a:t>• Fragmented Institutional Data: </a:t>
-            </a:r>
-            <a:r>
-              <a:rPr sz="1000" dirty="0">
+              <a:t>- Fragmented Institutional Data: </a:t>
+            </a:r>
+            <a:r>
+              <a:rPr sz="800">
                 <a:solidFill>
                   <a:srgbClr val="222222"/>
                 </a:solidFill>
@@ -6392,16 +6749,16 @@
               </a:spcBef>
             </a:pPr>
             <a:r>
-              <a:rPr sz="1000" b="1" dirty="0">
+              <a:rPr sz="850" b="1">
                 <a:solidFill>
                   <a:srgbClr val="1A365D"/>
                 </a:solidFill>
                 <a:latin typeface="Arial"/>
               </a:rPr>
-              <a:t>• Reconciliation Bottlenecks: </a:t>
-            </a:r>
-            <a:r>
-              <a:rPr sz="1000" dirty="0">
+              <a:t>- Reconciliation Bottlenecks: </a:t>
+            </a:r>
+            <a:r>
+              <a:rPr sz="800">
                 <a:solidFill>
                   <a:srgbClr val="222222"/>
                 </a:solidFill>
@@ -6417,16 +6774,16 @@
               </a:spcBef>
             </a:pPr>
             <a:r>
-              <a:rPr sz="1000" b="1" dirty="0">
+              <a:rPr sz="850" b="1">
                 <a:solidFill>
                   <a:srgbClr val="1A365D"/>
                 </a:solidFill>
                 <a:latin typeface="Arial"/>
               </a:rPr>
-              <a:t>• Intake &amp; Duplicate Risks: </a:t>
-            </a:r>
-            <a:r>
-              <a:rPr sz="1000" dirty="0">
+              <a:t>- Intake &amp; Duplicate Risks: </a:t>
+            </a:r>
+            <a:r>
+              <a:rPr sz="800">
                 <a:solidFill>
                   <a:srgbClr val="222222"/>
                 </a:solidFill>
@@ -6479,7 +6836,6 @@
           <a:lstStyle/>
           <a:p>
             <a:pPr algn="ctr"/>
-            <a:endParaRPr/>
           </a:p>
         </p:txBody>
       </p:sp>
@@ -6519,7 +6875,7 @@
           </a:fontRef>
         </p:style>
         <p:txBody>
-          <a:bodyPr wrap="none" lIns="73152" tIns="9144" rIns="73152" bIns="9144" rtlCol="0" anchor="ctr"/>
+          <a:bodyPr rtlCol="0" anchor="ctr" wrap="none" lIns="73152" rIns="73152" tIns="9144" bIns="9144"/>
           <a:lstStyle/>
           <a:p>
             <a:pPr algn="ctr">
@@ -6553,7 +6909,7 @@
           <a:noFill/>
         </p:spPr>
         <p:txBody>
-          <a:bodyPr wrap="square" lIns="0" tIns="0" rIns="0" bIns="0">
+          <a:bodyPr wrap="square" lIns="0" rIns="0" tIns="0" bIns="0">
             <a:spAutoFit/>
           </a:bodyPr>
           <a:lstStyle/>
@@ -6564,16 +6920,16 @@
               </a:spcBef>
             </a:pPr>
             <a:r>
-              <a:rPr sz="900" b="1" dirty="0">
+              <a:rPr sz="850" b="1">
                 <a:solidFill>
                   <a:srgbClr val="112266"/>
                 </a:solidFill>
                 <a:latin typeface="Arial"/>
               </a:rPr>
-              <a:t>• Decoupled Institutional Portals: </a:t>
-            </a:r>
-            <a:r>
-              <a:rPr sz="900" dirty="0">
+              <a:t>- Decoupled Institutional Portals: </a:t>
+            </a:r>
+            <a:r>
+              <a:rPr sz="800">
                 <a:solidFill>
                   <a:srgbClr val="222222"/>
                 </a:solidFill>
@@ -6589,16 +6945,16 @@
               </a:spcBef>
             </a:pPr>
             <a:r>
-              <a:rPr sz="900" b="1" dirty="0">
+              <a:rPr sz="850" b="1">
                 <a:solidFill>
                   <a:srgbClr val="112266"/>
                 </a:solidFill>
                 <a:latin typeface="Arial"/>
               </a:rPr>
-              <a:t>• Automated Ingestion Desk: </a:t>
-            </a:r>
-            <a:r>
-              <a:rPr sz="900" dirty="0">
+              <a:t>- Automated Ingestion Desk: </a:t>
+            </a:r>
+            <a:r>
+              <a:rPr sz="800">
                 <a:solidFill>
                   <a:srgbClr val="222222"/>
                 </a:solidFill>
@@ -6614,16 +6970,16 @@
               </a:spcBef>
             </a:pPr>
             <a:r>
-              <a:rPr sz="900" b="1" dirty="0">
+              <a:rPr sz="850" b="1">
                 <a:solidFill>
                   <a:srgbClr val="112266"/>
                 </a:solidFill>
                 <a:latin typeface="Arial"/>
               </a:rPr>
-              <a:t>• Deterministic 3-Way Reconciliation: </a:t>
-            </a:r>
-            <a:r>
-              <a:rPr sz="900" dirty="0">
+              <a:t>- Deterministic 3-Way Reconciliation: </a:t>
+            </a:r>
+            <a:r>
+              <a:rPr sz="800">
                 <a:solidFill>
                   <a:srgbClr val="222222"/>
                 </a:solidFill>
@@ -6639,16 +6995,16 @@
               </a:spcBef>
             </a:pPr>
             <a:r>
-              <a:rPr sz="900" b="1" dirty="0">
+              <a:rPr sz="850" b="1">
                 <a:solidFill>
                   <a:srgbClr val="112266"/>
                 </a:solidFill>
                 <a:latin typeface="Arial"/>
               </a:rPr>
-              <a:t>• Persisted Validation Runs: </a:t>
-            </a:r>
-            <a:r>
-              <a:rPr sz="900" dirty="0">
+              <a:t>- Persisted Validation Runs: </a:t>
+            </a:r>
+            <a:r>
+              <a:rPr sz="800">
                 <a:solidFill>
                   <a:srgbClr val="222222"/>
                 </a:solidFill>
@@ -6701,7 +7057,6 @@
           <a:lstStyle/>
           <a:p>
             <a:pPr algn="ctr"/>
-            <a:endParaRPr/>
           </a:p>
         </p:txBody>
       </p:sp>
@@ -6741,7 +7096,7 @@
           </a:fontRef>
         </p:style>
         <p:txBody>
-          <a:bodyPr wrap="none" lIns="73152" tIns="9144" rIns="73152" bIns="9144" rtlCol="0" anchor="ctr"/>
+          <a:bodyPr rtlCol="0" anchor="ctr" wrap="none" lIns="73152" rIns="73152" tIns="9144" bIns="9144"/>
           <a:lstStyle/>
           <a:p>
             <a:pPr algn="ctr">
@@ -6767,7 +7122,7 @@
         <p:spPr>
           <a:xfrm>
             <a:off x="475488" y="4389120"/>
-            <a:ext cx="5404104" cy="1223412"/>
+            <a:ext cx="5404104" cy="1197864"/>
           </a:xfrm>
           <a:prstGeom prst="rect">
             <a:avLst/>
@@ -6775,7 +7130,7 @@
           <a:noFill/>
         </p:spPr>
         <p:txBody>
-          <a:bodyPr wrap="square" lIns="0" tIns="0" rIns="0" bIns="0">
+          <a:bodyPr wrap="square" lIns="0" rIns="0" tIns="0" bIns="0">
             <a:spAutoFit/>
           </a:bodyPr>
           <a:lstStyle/>
@@ -6786,16 +7141,16 @@
               </a:spcBef>
             </a:pPr>
             <a:r>
-              <a:rPr sz="900" b="1" dirty="0">
+              <a:rPr sz="850" b="1">
                 <a:solidFill>
                   <a:srgbClr val="008C6E"/>
                 </a:solidFill>
                 <a:latin typeface="Arial"/>
               </a:rPr>
-              <a:t>• Explainable Row-Level Findings: </a:t>
-            </a:r>
-            <a:r>
-              <a:rPr sz="900" dirty="0">
+              <a:t>- Explainable Row-Level Findings: </a:t>
+            </a:r>
+            <a:r>
+              <a:rPr sz="800">
                 <a:solidFill>
                   <a:srgbClr val="222222"/>
                 </a:solidFill>
@@ -6811,16 +7166,16 @@
               </a:spcBef>
             </a:pPr>
             <a:r>
-              <a:rPr sz="900" b="1" dirty="0">
+              <a:rPr sz="850" b="1">
                 <a:solidFill>
                   <a:srgbClr val="008C6E"/>
                 </a:solidFill>
                 <a:latin typeface="Arial"/>
               </a:rPr>
-              <a:t>• Quarantine &amp; Resubmission: </a:t>
-            </a:r>
-            <a:r>
-              <a:rPr sz="900" dirty="0">
+              <a:t>- Quarantine &amp; Resubmission: </a:t>
+            </a:r>
+            <a:r>
+              <a:rPr sz="800">
                 <a:solidFill>
                   <a:srgbClr val="222222"/>
                 </a:solidFill>
@@ -6836,16 +7191,16 @@
               </a:spcBef>
             </a:pPr>
             <a:r>
-              <a:rPr sz="900" b="1" dirty="0">
+              <a:rPr sz="850" b="1">
                 <a:solidFill>
                   <a:srgbClr val="008C6E"/>
                 </a:solidFill>
                 <a:latin typeface="Arial"/>
               </a:rPr>
-              <a:t>• Controlled Central Decisions: </a:t>
-            </a:r>
-            <a:r>
-              <a:rPr sz="900" dirty="0">
+              <a:t>- Controlled Central Decisions: </a:t>
+            </a:r>
+            <a:r>
+              <a:rPr sz="800">
                 <a:solidFill>
                   <a:srgbClr val="222222"/>
                 </a:solidFill>
@@ -6861,16 +7216,16 @@
               </a:spcBef>
             </a:pPr>
             <a:r>
-              <a:rPr sz="900" b="1" dirty="0">
+              <a:rPr sz="850" b="1">
                 <a:solidFill>
                   <a:srgbClr val="008C6E"/>
                 </a:solidFill>
                 <a:latin typeface="Arial"/>
               </a:rPr>
-              <a:t>• Audit Traceability: </a:t>
-            </a:r>
-            <a:r>
-              <a:rPr sz="900" dirty="0">
+              <a:t>- Audit Traceability: </a:t>
+            </a:r>
+            <a:r>
+              <a:rPr sz="800">
                 <a:solidFill>
                   <a:srgbClr val="222222"/>
                 </a:solidFill>
@@ -6923,7 +7278,6 @@
           <a:lstStyle/>
           <a:p>
             <a:pPr algn="ctr"/>
-            <a:endParaRPr/>
           </a:p>
         </p:txBody>
       </p:sp>
@@ -6936,7 +7290,7 @@
         <p:spPr>
           <a:xfrm>
             <a:off x="6309360" y="1005840"/>
-            <a:ext cx="5349240" cy="292608"/>
+            <a:ext cx="5349240" cy="274320"/>
           </a:xfrm>
           <a:prstGeom prst="roundRect">
             <a:avLst/>
@@ -6963,7 +7317,7 @@
           </a:fontRef>
         </p:style>
         <p:txBody>
-          <a:bodyPr wrap="none" lIns="73152" tIns="9144" rIns="73152" bIns="9144" rtlCol="0" anchor="ctr"/>
+          <a:bodyPr rtlCol="0" anchor="ctr" wrap="none" lIns="73152" rIns="73152" tIns="9144" bIns="9144"/>
           <a:lstStyle/>
           <a:p>
             <a:pPr algn="ctr">
@@ -6980,40 +7334,16 @@
           </a:p>
         </p:txBody>
       </p:sp>
-      <p:pic>
-        <p:nvPicPr>
-          <p:cNvPr id="15373" name="Picture 15372" descr="02_dashboard_overview.png"/>
-          <p:cNvPicPr>
-            <a:picLocks noChangeAspect="1"/>
-          </p:cNvPicPr>
-          <p:nvPr/>
-        </p:nvPicPr>
-        <p:blipFill>
-          <a:blip r:embed="rId4"/>
-          <a:stretch>
-            <a:fillRect/>
-          </a:stretch>
-        </p:blipFill>
-        <p:spPr>
-          <a:xfrm>
-            <a:off x="6281928" y="1353312"/>
-            <a:ext cx="5404104" cy="2971800"/>
-          </a:xfrm>
-          <a:prstGeom prst="rect">
-            <a:avLst/>
-          </a:prstGeom>
-        </p:spPr>
-      </p:pic>
-      <p:sp>
-        <p:nvSpPr>
-          <p:cNvPr id="15374" name="TextBox 15373"/>
+      <p:sp>
+        <p:nvSpPr>
+          <p:cNvPr id="15373" name="TextBox 15372"/>
           <p:cNvSpPr txBox="1"/>
           <p:nvPr/>
         </p:nvSpPr>
         <p:spPr>
           <a:xfrm>
-            <a:off x="6281928" y="4370832"/>
-            <a:ext cx="5404104" cy="974626"/>
+            <a:off x="6281928" y="4343400"/>
+            <a:ext cx="5404104" cy="1188720"/>
           </a:xfrm>
           <a:prstGeom prst="rect">
             <a:avLst/>
@@ -7021,7 +7351,7 @@
           <a:noFill/>
         </p:spPr>
         <p:txBody>
-          <a:bodyPr wrap="square" lIns="0" tIns="0" rIns="0" bIns="0">
+          <a:bodyPr wrap="square" lIns="0" rIns="0" tIns="0" bIns="0">
             <a:spAutoFit/>
           </a:bodyPr>
           <a:lstStyle/>
@@ -7032,59 +7362,41 @@
               </a:spcBef>
             </a:pPr>
             <a:r>
-              <a:rPr sz="1000" b="1" dirty="0">
-                <a:solidFill>
-                  <a:srgbClr val="008C6E"/>
-                </a:solidFill>
-                <a:latin typeface="Arial"/>
-              </a:rPr>
-              <a:t>✓ Central Intake Intelligence: </a:t>
-            </a:r>
-            <a:r>
-              <a:rPr sz="1000" dirty="0">
+              <a:rPr sz="819" b="1">
+                <a:solidFill>
+                  <a:srgbClr val="1A365D"/>
+                </a:solidFill>
+                <a:latin typeface="Arial"/>
+              </a:rPr>
+              <a:t>- Central Intake Intelligence: </a:t>
+            </a:r>
+            <a:r>
+              <a:rPr sz="780">
                 <a:solidFill>
                   <a:srgbClr val="222222"/>
                 </a:solidFill>
                 <a:latin typeface="Arial"/>
               </a:rPr>
-              <a:t>Live monitoring of sanctioned intake vs enrolled students across </a:t>
-            </a:r>
-            <a:r>
-              <a:rPr sz="1000" dirty="0" err="1">
-                <a:solidFill>
-                  <a:srgbClr val="222222"/>
-                </a:solidFill>
-                <a:latin typeface="Arial"/>
-              </a:rPr>
-              <a:t>B.Tech</a:t>
-            </a:r>
-            <a:r>
-              <a:rPr sz="1000" dirty="0">
-                <a:solidFill>
-                  <a:srgbClr val="222222"/>
-                </a:solidFill>
-                <a:latin typeface="Arial"/>
-              </a:rPr>
-              <a:t>, MCA, and Diploma.</a:t>
+              <a:t>Live monitoring of sanctioned intake vs enrolled students across B.Tech, MCA, and Diploma.</a:t>
             </a:r>
           </a:p>
           <a:p>
             <a:pPr>
               <a:spcBef>
-                <a:spcPts val="200"/>
+                <a:spcPts val="250"/>
               </a:spcBef>
             </a:pPr>
             <a:r>
-              <a:rPr sz="1000" b="1" dirty="0">
-                <a:solidFill>
-                  <a:srgbClr val="008C6E"/>
-                </a:solidFill>
-                <a:latin typeface="Arial"/>
-              </a:rPr>
-              <a:t>✓ Deterministic Review Desk: </a:t>
-            </a:r>
-            <a:r>
-              <a:rPr sz="1000" dirty="0">
+              <a:rPr sz="819" b="1">
+                <a:solidFill>
+                  <a:srgbClr val="1A365D"/>
+                </a:solidFill>
+                <a:latin typeface="Arial"/>
+              </a:rPr>
+              <a:t>- Deterministic Review Desk: </a:t>
+            </a:r>
+            <a:r>
+              <a:rPr sz="780">
                 <a:solidFill>
                   <a:srgbClr val="222222"/>
                 </a:solidFill>
@@ -7096,20 +7408,20 @@
           <a:p>
             <a:pPr>
               <a:spcBef>
-                <a:spcPts val="200"/>
+                <a:spcPts val="250"/>
               </a:spcBef>
             </a:pPr>
             <a:r>
-              <a:rPr sz="1000" b="1" dirty="0">
-                <a:solidFill>
-                  <a:srgbClr val="008C6E"/>
-                </a:solidFill>
-                <a:latin typeface="Arial"/>
-              </a:rPr>
-              <a:t>✓ Multi-Tenant Governance: </a:t>
-            </a:r>
-            <a:r>
-              <a:rPr sz="1000" dirty="0">
+              <a:rPr sz="819" b="1">
+                <a:solidFill>
+                  <a:srgbClr val="1A365D"/>
+                </a:solidFill>
+                <a:latin typeface="Arial"/>
+              </a:rPr>
+              <a:t>- Multi-Tenant Governance: </a:t>
+            </a:r>
+            <a:r>
+              <a:rPr sz="780">
                 <a:solidFill>
                   <a:srgbClr val="222222"/>
                 </a:solidFill>
@@ -7122,7 +7434,7 @@
       </p:sp>
       <p:sp>
         <p:nvSpPr>
-          <p:cNvPr id="15375" name="Rounded Rectangle 15374"/>
+          <p:cNvPr id="15374" name="Rounded Rectangle 15373"/>
           <p:cNvSpPr/>
           <p:nvPr/>
         </p:nvSpPr>
@@ -7137,7 +7449,7 @@
           <a:solidFill>
             <a:srgbClr val="F8FAFC"/>
           </a:solidFill>
-          <a:ln w="15240">
+          <a:ln w="12700">
             <a:solidFill>
               <a:srgbClr val="008C6E"/>
             </a:solidFill>
@@ -7158,7 +7470,7 @@
           </a:fontRef>
         </p:style>
         <p:txBody>
-          <a:bodyPr lIns="0" rIns="0" rtlCol="0" anchor="ctr"/>
+          <a:bodyPr rtlCol="0" anchor="ctr"/>
           <a:lstStyle/>
           <a:p>
             <a:pPr algn="ctr">
@@ -7170,15 +7482,14 @@
               </a:defRPr>
             </a:pPr>
             <a:r>
-              <a:rPr dirty="0"/>
-              <a:t>✓ Deterministic Python Core</a:t>
-            </a:r>
-          </a:p>
-        </p:txBody>
-      </p:sp>
-      <p:sp>
-        <p:nvSpPr>
-          <p:cNvPr id="15376" name="Rounded Rectangle 15375"/>
+              <a:t>Deterministic Python Core</a:t>
+            </a:r>
+          </a:p>
+        </p:txBody>
+      </p:sp>
+      <p:sp>
+        <p:nvSpPr>
+          <p:cNvPr id="15375" name="Rounded Rectangle 15374"/>
           <p:cNvSpPr/>
           <p:nvPr/>
         </p:nvSpPr>
@@ -7193,7 +7504,7 @@
           <a:solidFill>
             <a:srgbClr val="F8FAFC"/>
           </a:solidFill>
-          <a:ln w="15240">
+          <a:ln w="12700">
             <a:solidFill>
               <a:srgbClr val="112266"/>
             </a:solidFill>
@@ -7214,7 +7525,7 @@
           </a:fontRef>
         </p:style>
         <p:txBody>
-          <a:bodyPr lIns="0" rIns="0" rtlCol="0" anchor="ctr"/>
+          <a:bodyPr rtlCol="0" anchor="ctr"/>
           <a:lstStyle/>
           <a:p>
             <a:pPr algn="ctr">
@@ -7226,15 +7537,14 @@
               </a:defRPr>
             </a:pPr>
             <a:r>
-              <a:rPr dirty="0"/>
-              <a:t>⚖️ 3-Way Cross-Reconciliation</a:t>
-            </a:r>
-          </a:p>
-        </p:txBody>
-      </p:sp>
-      <p:sp>
-        <p:nvSpPr>
-          <p:cNvPr id="15377" name="Rounded Rectangle 15376"/>
+              <a:t>3-Way Cross-Reconciliation</a:t>
+            </a:r>
+          </a:p>
+        </p:txBody>
+      </p:sp>
+      <p:sp>
+        <p:nvSpPr>
+          <p:cNvPr id="15376" name="Rounded Rectangle 15375"/>
           <p:cNvSpPr/>
           <p:nvPr/>
         </p:nvSpPr>
@@ -7249,7 +7559,7 @@
           <a:solidFill>
             <a:srgbClr val="F8FAFC"/>
           </a:solidFill>
-          <a:ln w="15240">
+          <a:ln w="12700">
             <a:solidFill>
               <a:srgbClr val="1A365D"/>
             </a:solidFill>
@@ -7270,7 +7580,7 @@
           </a:fontRef>
         </p:style>
         <p:txBody>
-          <a:bodyPr lIns="0" rIns="0" rtlCol="0" anchor="ctr"/>
+          <a:bodyPr rtlCol="0" anchor="ctr"/>
           <a:lstStyle/>
           <a:p>
             <a:pPr algn="ctr">
@@ -7282,14 +7592,14 @@
               </a:defRPr>
             </a:pPr>
             <a:r>
-              <a:t>🔒 Cryptographic Verification &amp; Audit</a:t>
-            </a:r>
-          </a:p>
-        </p:txBody>
-      </p:sp>
-      <p:sp>
-        <p:nvSpPr>
-          <p:cNvPr id="15378" name="Rounded Rectangle 15377"/>
+              <a:t>Cryptographic Verification &amp; Audit</a:t>
+            </a:r>
+          </a:p>
+        </p:txBody>
+      </p:sp>
+      <p:sp>
+        <p:nvSpPr>
+          <p:cNvPr id="15377" name="Rounded Rectangle 15376"/>
           <p:cNvSpPr/>
           <p:nvPr/>
         </p:nvSpPr>
@@ -7304,7 +7614,7 @@
           <a:solidFill>
             <a:srgbClr val="F8FAFC"/>
           </a:solidFill>
-          <a:ln w="15240">
+          <a:ln w="12700">
             <a:solidFill>
               <a:srgbClr val="008C6E"/>
             </a:solidFill>
@@ -7325,7 +7635,7 @@
           </a:fontRef>
         </p:style>
         <p:txBody>
-          <a:bodyPr lIns="0" rIns="0" rtlCol="0" anchor="ctr"/>
+          <a:bodyPr rtlCol="0" anchor="ctr"/>
           <a:lstStyle/>
           <a:p>
             <a:pPr algn="ctr">
@@ -7337,7 +7647,7 @@
               </a:defRPr>
             </a:pPr>
             <a:r>
-              <a:t>🛡️ 64/64 Verified Passing Tests</a:t>
+              <a:t>66/66 Verified Passing Tests</a:t>
             </a:r>
           </a:p>
         </p:txBody>
@@ -7451,7 +7761,7 @@
           <a:bodyPr wrap="square"/>
           <a:lstStyle/>
           <a:p>
-            <a:pPr algn="l" eaLnBrk="1" hangingPunct="1">
+            <a:pPr eaLnBrk="1" hangingPunct="1" algn="l">
               <a:defRPr sz="1650" b="1">
                 <a:solidFill>
                   <a:srgbClr val="112266"/>
@@ -7582,7 +7892,7 @@
           </a:fontRef>
         </p:style>
         <p:txBody>
-          <a:bodyPr wrap="none" lIns="18288" rIns="18288" rtlCol="0" anchor="ctr"/>
+          <a:bodyPr rtlCol="0" anchor="ctr" wrap="none" lIns="18288" rIns="18288"/>
           <a:lstStyle/>
           <a:p>
             <a:pPr algn="ctr">
@@ -7672,7 +7982,6 @@
           <a:lstStyle/>
           <a:p>
             <a:pPr algn="ctr"/>
-            <a:endParaRPr/>
           </a:p>
         </p:txBody>
       </p:sp>
@@ -7712,7 +8021,7 @@
           </a:fontRef>
         </p:style>
         <p:txBody>
-          <a:bodyPr wrap="none" lIns="73152" tIns="9144" rIns="73152" bIns="9144" rtlCol="0" anchor="ctr"/>
+          <a:bodyPr rtlCol="0" anchor="ctr" wrap="none" lIns="73152" rIns="73152" tIns="9144" bIns="9144"/>
           <a:lstStyle/>
           <a:p>
             <a:pPr algn="ctr">
@@ -7737,7 +8046,7 @@
         </p:nvSpPr>
         <p:spPr>
           <a:xfrm>
-            <a:off x="502920" y="1389888"/>
+            <a:off x="502920" y="1371600"/>
             <a:ext cx="5349240" cy="841248"/>
           </a:xfrm>
           <a:prstGeom prst="roundRect">
@@ -7771,7 +8080,6 @@
           <a:lstStyle/>
           <a:p>
             <a:pPr algn="ctr"/>
-            <a:endParaRPr/>
           </a:p>
         </p:txBody>
       </p:sp>
@@ -7783,8 +8091,8 @@
         </p:nvSpPr>
         <p:spPr>
           <a:xfrm>
-            <a:off x="566928" y="1435608"/>
-            <a:ext cx="5221224" cy="533479"/>
+            <a:off x="566928" y="1426464"/>
+            <a:ext cx="5221224" cy="731520"/>
           </a:xfrm>
           <a:prstGeom prst="rect">
             <a:avLst/>
@@ -7792,19 +8100,19 @@
           <a:noFill/>
         </p:spPr>
         <p:txBody>
-          <a:bodyPr wrap="square" lIns="0" tIns="0" rIns="0" bIns="0">
+          <a:bodyPr wrap="square" lIns="0" rIns="0" tIns="0" bIns="0">
             <a:spAutoFit/>
           </a:bodyPr>
           <a:lstStyle/>
           <a:p>
             <a:r>
-              <a:rPr sz="1100" b="1" dirty="0">
-                <a:solidFill>
-                  <a:srgbClr val="008C6E"/>
-                </a:solidFill>
-                <a:latin typeface="Arial"/>
-              </a:rPr>
-              <a:t>STAGE 1: INSTITUTIONAL INGESTION &amp; MAPPING</a:t>
+              <a:rPr sz="880" b="1">
+                <a:solidFill>
+                  <a:srgbClr val="1A365D"/>
+                </a:solidFill>
+                <a:latin typeface="Arial"/>
+              </a:rPr>
+              <a:t>STAGE 1: Resilient File Ingestion</a:t>
             </a:r>
           </a:p>
           <a:p>
@@ -7814,13 +8122,13 @@
               </a:spcBef>
             </a:pPr>
             <a:r>
-              <a:rPr sz="1100" dirty="0">
+              <a:rPr sz="800">
                 <a:solidFill>
                   <a:srgbClr val="222222"/>
                 </a:solidFill>
                 <a:latin typeface="Arial"/>
               </a:rPr>
-              <a:t>Institutional user authenticates via JWT; uploads CSV/Excel student admissions file. Header normalizer maps diverse column aliases into standard schema.</a:t>
+              <a:t>Upload institutional CSV/Excel files; dynamic column alias matching auto-normalizes divergent schemas into standardized staging records.</a:t>
             </a:r>
           </a:p>
         </p:txBody>
@@ -7833,7 +8141,7 @@
         </p:nvSpPr>
         <p:spPr>
           <a:xfrm>
-            <a:off x="502920" y="2304288"/>
+            <a:off x="502920" y="2331720"/>
             <a:ext cx="5349240" cy="841248"/>
           </a:xfrm>
           <a:prstGeom prst="roundRect">
@@ -7867,7 +8175,6 @@
           <a:lstStyle/>
           <a:p>
             <a:pPr algn="ctr"/>
-            <a:endParaRPr/>
           </a:p>
         </p:txBody>
       </p:sp>
@@ -7879,8 +8186,8 @@
         </p:nvSpPr>
         <p:spPr>
           <a:xfrm>
-            <a:off x="566928" y="2350008"/>
-            <a:ext cx="5221224" cy="533479"/>
+            <a:off x="566928" y="2386584"/>
+            <a:ext cx="5221224" cy="731520"/>
           </a:xfrm>
           <a:prstGeom prst="rect">
             <a:avLst/>
@@ -7888,19 +8195,19 @@
           <a:noFill/>
         </p:spPr>
         <p:txBody>
-          <a:bodyPr wrap="square" lIns="0" tIns="0" rIns="0" bIns="0">
+          <a:bodyPr wrap="square" lIns="0" rIns="0" tIns="0" bIns="0">
             <a:spAutoFit/>
           </a:bodyPr>
           <a:lstStyle/>
           <a:p>
             <a:r>
-              <a:rPr sz="1100" b="1" dirty="0">
+              <a:rPr sz="880" b="1">
                 <a:solidFill>
                   <a:srgbClr val="1A365D"/>
                 </a:solidFill>
                 <a:latin typeface="Arial"/>
               </a:rPr>
-              <a:t>STAGE 2: DETERMINISTIC PREFLIGHT SCREENING</a:t>
+              <a:t>STAGE 2: Pure Python Validation Engine</a:t>
             </a:r>
           </a:p>
           <a:p>
@@ -7910,13 +8217,13 @@
               </a:spcBef>
             </a:pPr>
             <a:r>
-              <a:rPr sz="1100" dirty="0">
+              <a:rPr sz="800">
                 <a:solidFill>
                   <a:srgbClr val="222222"/>
                 </a:solidFill>
                 <a:latin typeface="Arial"/>
               </a:rPr>
-              <a:t>Fast preflight validation checks mandatory identifier syntax, field types, and isolates corrupted records into quarantine staging.</a:t>
+              <a:t>Deterministic rule engine parses syntax, detects in-batch duplicates, verifies 12-digit APAAR format, and runs cross-field consistency checks.</a:t>
             </a:r>
           </a:p>
         </p:txBody>
@@ -7929,7 +8236,7 @@
         </p:nvSpPr>
         <p:spPr>
           <a:xfrm>
-            <a:off x="502920" y="3218688"/>
+            <a:off x="502920" y="3291840"/>
             <a:ext cx="5349240" cy="841248"/>
           </a:xfrm>
           <a:prstGeom prst="roundRect">
@@ -7963,7 +8270,6 @@
           <a:lstStyle/>
           <a:p>
             <a:pPr algn="ctr"/>
-            <a:endParaRPr/>
           </a:p>
         </p:txBody>
       </p:sp>
@@ -7975,8 +8281,8 @@
         </p:nvSpPr>
         <p:spPr>
           <a:xfrm>
-            <a:off x="566928" y="3264408"/>
-            <a:ext cx="5221224" cy="533479"/>
+            <a:off x="566928" y="3346704"/>
+            <a:ext cx="5221224" cy="731520"/>
           </a:xfrm>
           <a:prstGeom prst="rect">
             <a:avLst/>
@@ -7984,19 +8290,19 @@
           <a:noFill/>
         </p:spPr>
         <p:txBody>
-          <a:bodyPr wrap="square" lIns="0" tIns="0" rIns="0" bIns="0">
+          <a:bodyPr wrap="square" lIns="0" rIns="0" tIns="0" bIns="0">
             <a:spAutoFit/>
           </a:bodyPr>
           <a:lstStyle/>
           <a:p>
             <a:r>
-              <a:rPr sz="1100" b="1" dirty="0">
-                <a:solidFill>
-                  <a:srgbClr val="112266"/>
-                </a:solidFill>
-                <a:latin typeface="Arial"/>
-              </a:rPr>
-              <a:t>STAGE 3: 3-WAY RECONCILIATION ENGINE</a:t>
+              <a:rPr sz="880" b="1">
+                <a:solidFill>
+                  <a:srgbClr val="1A365D"/>
+                </a:solidFill>
+                <a:latin typeface="Arial"/>
+              </a:rPr>
+              <a:t>STAGE 3: 3-Way Dynamic Reconciliation</a:t>
             </a:r>
           </a:p>
           <a:p>
@@ -8006,31 +8312,13 @@
               </a:spcBef>
             </a:pPr>
             <a:r>
-              <a:rPr sz="1100" dirty="0">
+              <a:rPr sz="800">
                 <a:solidFill>
                   <a:srgbClr val="222222"/>
                 </a:solidFill>
                 <a:latin typeface="Arial"/>
               </a:rPr>
-              <a:t>Deterministic Python engine compares staged records against institutional declarations, approved </a:t>
-            </a:r>
-            <a:r>
-              <a:rPr sz="1100" dirty="0" err="1">
-                <a:solidFill>
-                  <a:srgbClr val="222222"/>
-                </a:solidFill>
-                <a:latin typeface="Arial"/>
-              </a:rPr>
-              <a:t>programme</a:t>
-            </a:r>
-            <a:r>
-              <a:rPr sz="1100" dirty="0">
-                <a:solidFill>
-                  <a:srgbClr val="222222"/>
-                </a:solidFill>
-                <a:latin typeface="Arial"/>
-              </a:rPr>
-              <a:t> capacities, and synthetic reference records.</a:t>
+              <a:t>Cross-compares declared student counts against verified stage records and sanctioned intake quotas from dynamic reference tables.</a:t>
             </a:r>
           </a:p>
         </p:txBody>
@@ -8043,7 +8331,7 @@
         </p:nvSpPr>
         <p:spPr>
           <a:xfrm>
-            <a:off x="502920" y="4133088"/>
+            <a:off x="502920" y="4251960"/>
             <a:ext cx="5349240" cy="841248"/>
           </a:xfrm>
           <a:prstGeom prst="roundRect">
@@ -8077,7 +8365,6 @@
           <a:lstStyle/>
           <a:p>
             <a:pPr algn="ctr"/>
-            <a:endParaRPr/>
           </a:p>
         </p:txBody>
       </p:sp>
@@ -8089,8 +8376,8 @@
         </p:nvSpPr>
         <p:spPr>
           <a:xfrm>
-            <a:off x="566928" y="4178808"/>
-            <a:ext cx="5221224" cy="533479"/>
+            <a:off x="566928" y="4306824"/>
+            <a:ext cx="5221224" cy="731520"/>
           </a:xfrm>
           <a:prstGeom prst="rect">
             <a:avLst/>
@@ -8098,19 +8385,19 @@
           <a:noFill/>
         </p:spPr>
         <p:txBody>
-          <a:bodyPr wrap="square" lIns="0" tIns="0" rIns="0" bIns="0">
+          <a:bodyPr wrap="square" lIns="0" rIns="0" tIns="0" bIns="0">
             <a:spAutoFit/>
           </a:bodyPr>
           <a:lstStyle/>
           <a:p>
             <a:r>
-              <a:rPr sz="1100" b="1" dirty="0">
-                <a:solidFill>
-                  <a:srgbClr val="1A56DB"/>
-                </a:solidFill>
-                <a:latin typeface="Arial"/>
-              </a:rPr>
-              <a:t>STAGE 4: FINDINGS PERSISTENCE &amp; SANDBOX</a:t>
+              <a:rPr sz="880" b="1">
+                <a:solidFill>
+                  <a:srgbClr val="1A365D"/>
+                </a:solidFill>
+                <a:latin typeface="Arial"/>
+              </a:rPr>
+              <a:t>STAGE 4: Council Review &amp; Audit Ledger</a:t>
             </a:r>
           </a:p>
           <a:p>
@@ -8120,13 +8407,13 @@
               </a:spcBef>
             </a:pPr>
             <a:r>
-              <a:rPr sz="1100" dirty="0">
+              <a:rPr sz="800">
                 <a:solidFill>
                   <a:srgbClr val="222222"/>
                 </a:solidFill>
                 <a:latin typeface="Arial"/>
               </a:rPr>
-              <a:t>Persists validation run records, row-level error findings, and enables in-browser quarantine sandbox for institutional dispute resolution.</a:t>
+              <a:t>Central officers review row-level discrepancy findings; make formal Approve/Return decisions; actions chained into append-only SHA-256 audit ledger.</a:t>
             </a:r>
           </a:p>
         </p:txBody>
@@ -8139,7 +8426,7 @@
         </p:nvSpPr>
         <p:spPr>
           <a:xfrm>
-            <a:off x="502920" y="5047488"/>
+            <a:off x="502920" y="5212080"/>
             <a:ext cx="5349240" cy="841248"/>
           </a:xfrm>
           <a:prstGeom prst="roundRect">
@@ -8173,7 +8460,6 @@
           <a:lstStyle/>
           <a:p>
             <a:pPr algn="ctr"/>
-            <a:endParaRPr/>
           </a:p>
         </p:txBody>
       </p:sp>
@@ -8185,8 +8471,8 @@
         </p:nvSpPr>
         <p:spPr>
           <a:xfrm>
-            <a:off x="566928" y="5093208"/>
-            <a:ext cx="5221224" cy="533479"/>
+            <a:off x="566928" y="5266944"/>
+            <a:ext cx="5221224" cy="731520"/>
           </a:xfrm>
           <a:prstGeom prst="rect">
             <a:avLst/>
@@ -8194,19 +8480,19 @@
           <a:noFill/>
         </p:spPr>
         <p:txBody>
-          <a:bodyPr wrap="square" lIns="0" tIns="0" rIns="0" bIns="0">
+          <a:bodyPr wrap="square" lIns="0" rIns="0" tIns="0" bIns="0">
             <a:spAutoFit/>
           </a:bodyPr>
           <a:lstStyle/>
           <a:p>
             <a:r>
-              <a:rPr sz="1100" b="1" dirty="0">
-                <a:solidFill>
-                  <a:srgbClr val="008C6E"/>
-                </a:solidFill>
-                <a:latin typeface="Arial"/>
-              </a:rPr>
-              <a:t>STAGE 5: CENTRAL REVIEW &amp; VERIFICATION PROOFS</a:t>
+              <a:rPr sz="880" b="1">
+                <a:solidFill>
+                  <a:srgbClr val="1A365D"/>
+                </a:solidFill>
+                <a:latin typeface="Arial"/>
+              </a:rPr>
+              <a:t>STAGE 5: Cryptographic Verification Receipt</a:t>
             </a:r>
           </a:p>
           <a:p>
@@ -8216,13 +8502,13 @@
               </a:spcBef>
             </a:pPr>
             <a:r>
-              <a:rPr sz="1100" dirty="0">
+              <a:rPr sz="800">
                 <a:solidFill>
                   <a:srgbClr val="222222"/>
                 </a:solidFill>
                 <a:latin typeface="Arial"/>
               </a:rPr>
-              <a:t>AICTE Central reviews batch: approves, returns for correction, or rejects. Generates Ed25519-signed verification receipts and appends SHA-256 audit events.</a:t>
+              <a:t>Approved student records receive an asymmetric Ed25519 digital signature and portable verification receipt with offline verifiable QR code.</a:t>
             </a:r>
           </a:p>
         </p:txBody>
@@ -8236,7 +8522,7 @@
         <p:spPr>
           <a:xfrm>
             <a:off x="6172200" y="1115568"/>
-            <a:ext cx="5623560" cy="2057400"/>
+            <a:ext cx="5623560" cy="2066543"/>
           </a:xfrm>
           <a:prstGeom prst="roundRect">
             <a:avLst/>
@@ -8269,7 +8555,6 @@
           <a:lstStyle/>
           <a:p>
             <a:pPr algn="ctr"/>
-            <a:endParaRPr/>
           </a:p>
         </p:txBody>
       </p:sp>
@@ -8309,7 +8594,7 @@
           </a:fontRef>
         </p:style>
         <p:txBody>
-          <a:bodyPr wrap="none" lIns="73152" tIns="9144" rIns="73152" bIns="9144" rtlCol="0" anchor="ctr"/>
+          <a:bodyPr rtlCol="0" anchor="ctr" wrap="none" lIns="73152" rIns="73152" tIns="9144" bIns="9144"/>
           <a:lstStyle/>
           <a:p>
             <a:pPr algn="ctr">
@@ -8335,7 +8620,7 @@
         <p:spPr>
           <a:xfrm>
             <a:off x="6309360" y="1353312"/>
-            <a:ext cx="5349240" cy="1508105"/>
+            <a:ext cx="5349240" cy="1755648"/>
           </a:xfrm>
           <a:prstGeom prst="rect">
             <a:avLst/>
@@ -8343,7 +8628,7 @@
           <a:noFill/>
         </p:spPr>
         <p:txBody>
-          <a:bodyPr wrap="square" lIns="0" tIns="0" rIns="0" bIns="0">
+          <a:bodyPr wrap="square" lIns="0" rIns="0" tIns="0" bIns="0">
             <a:spAutoFit/>
           </a:bodyPr>
           <a:lstStyle/>
@@ -8354,145 +8639,91 @@
               </a:spcBef>
             </a:pPr>
             <a:r>
-              <a:rPr sz="1100" b="1" dirty="0">
+              <a:rPr sz="880" b="1">
                 <a:solidFill>
                   <a:srgbClr val="112266"/>
                 </a:solidFill>
                 <a:latin typeface="Arial"/>
               </a:rPr>
-              <a:t>• Presentation Layer: </a:t>
-            </a:r>
-            <a:r>
-              <a:rPr sz="1100" dirty="0">
+              <a:t>- Presentation Layer: </a:t>
+            </a:r>
+            <a:r>
+              <a:rPr sz="810">
                 <a:solidFill>
                   <a:srgbClr val="222222"/>
                 </a:solidFill>
                 <a:latin typeface="Arial"/>
               </a:rPr>
-              <a:t>Next.js 14 (App Router), TypeScript, Tailwind CSS, Recharts for analytics.</a:t>
+              <a:t>Next.js 14 (App Router), TypeScript, Tailwind CSS, Recharts for analytics; deployed on Vercel Edge.</a:t>
             </a:r>
           </a:p>
           <a:p>
             <a:pPr>
               <a:spcBef>
-                <a:spcPts val="400"/>
+                <a:spcPts val="300"/>
               </a:spcBef>
             </a:pPr>
             <a:r>
-              <a:rPr sz="1100" b="1" dirty="0">
+              <a:rPr sz="880" b="1">
                 <a:solidFill>
                   <a:srgbClr val="112266"/>
                 </a:solidFill>
                 <a:latin typeface="Arial"/>
               </a:rPr>
-              <a:t>• Application &amp; API: </a:t>
-            </a:r>
-            <a:r>
-              <a:rPr sz="1100" dirty="0" err="1">
+              <a:t>- Application &amp; API: </a:t>
+            </a:r>
+            <a:r>
+              <a:rPr sz="810">
                 <a:solidFill>
                   <a:srgbClr val="222222"/>
                 </a:solidFill>
                 <a:latin typeface="Arial"/>
               </a:rPr>
-              <a:t>FastAPI</a:t>
-            </a:r>
-            <a:r>
-              <a:rPr sz="1100" dirty="0">
-                <a:solidFill>
-                  <a:srgbClr val="222222"/>
-                </a:solidFill>
-                <a:latin typeface="Arial"/>
-              </a:rPr>
-              <a:t> (Modular Monolith), Python 3.10+, </a:t>
-            </a:r>
-            <a:r>
-              <a:rPr sz="1100" dirty="0" err="1">
-                <a:solidFill>
-                  <a:srgbClr val="222222"/>
-                </a:solidFill>
-                <a:latin typeface="Arial"/>
-              </a:rPr>
-              <a:t>Pydantic</a:t>
-            </a:r>
-            <a:r>
-              <a:rPr sz="1100" dirty="0">
-                <a:solidFill>
-                  <a:srgbClr val="222222"/>
-                </a:solidFill>
-                <a:latin typeface="Arial"/>
-              </a:rPr>
-              <a:t> v2, </a:t>
-            </a:r>
-            <a:r>
-              <a:rPr sz="1100" dirty="0" err="1">
-                <a:solidFill>
-                  <a:srgbClr val="222222"/>
-                </a:solidFill>
-                <a:latin typeface="Arial"/>
-              </a:rPr>
-              <a:t>Uvicorn</a:t>
-            </a:r>
-            <a:r>
-              <a:rPr sz="1100" dirty="0">
-                <a:solidFill>
-                  <a:srgbClr val="222222"/>
-                </a:solidFill>
-                <a:latin typeface="Arial"/>
-              </a:rPr>
-              <a:t>, 73 endpoints.</a:t>
+              <a:t>FastAPI (Modular Monolith), Python 3.10+, Pydantic v2, Uvicorn, 73 endpoints; deployed on Render Cloud.</a:t>
             </a:r>
           </a:p>
           <a:p>
             <a:pPr>
               <a:spcBef>
-                <a:spcPts val="400"/>
+                <a:spcPts val="300"/>
               </a:spcBef>
             </a:pPr>
             <a:r>
-              <a:rPr sz="1100" b="1" dirty="0">
+              <a:rPr sz="880" b="1">
                 <a:solidFill>
                   <a:srgbClr val="112266"/>
                 </a:solidFill>
                 <a:latin typeface="Arial"/>
               </a:rPr>
-              <a:t>• Persistence &amp; Schemas: </a:t>
-            </a:r>
-            <a:r>
-              <a:rPr sz="1100" dirty="0" err="1">
+              <a:t>- Persistence &amp; Schemas: </a:t>
+            </a:r>
+            <a:r>
+              <a:rPr sz="810">
                 <a:solidFill>
                   <a:srgbClr val="222222"/>
                 </a:solidFill>
                 <a:latin typeface="Arial"/>
               </a:rPr>
-              <a:t>SQLAlchemy</a:t>
-            </a:r>
-            <a:r>
-              <a:rPr sz="1100" dirty="0">
-                <a:solidFill>
-                  <a:srgbClr val="222222"/>
-                </a:solidFill>
-                <a:latin typeface="Arial"/>
-              </a:rPr>
-              <a:t> ORM, PostgreSQL (20 tables with RLS enabled) / SQLite WAL mode.</a:t>
+              <a:t>SQLAlchemy ORM, Supabase PostgreSQL 17.11 (20 tables with RLS enabled) / SQLite WAL mode.</a:t>
             </a:r>
           </a:p>
           <a:p>
             <a:pPr>
               <a:spcBef>
-                <a:spcPts val="400"/>
+                <a:spcPts val="300"/>
               </a:spcBef>
             </a:pPr>
             <a:r>
-              <a:rPr sz="1100" b="1" dirty="0">
+              <a:rPr sz="880" b="1">
                 <a:solidFill>
                   <a:srgbClr val="112266"/>
                 </a:solidFill>
                 <a:latin typeface="Arial"/>
               </a:rPr>
-              <a:t>• Cryptography &amp; Security: </a:t>
-            </a:r>
-            <a:r>
-              <a:rPr sz="1100" dirty="0">
+              <a:t>- Cryptography &amp; Security: </a:t>
+            </a:r>
+            <a:r>
+              <a:rPr sz="810">
                 <a:solidFill>
                   <a:srgbClr val="222222"/>
                 </a:solidFill>
@@ -8545,7 +8776,6 @@
           <a:lstStyle/>
           <a:p>
             <a:pPr algn="ctr"/>
-            <a:endParaRPr/>
           </a:p>
         </p:txBody>
       </p:sp>
@@ -8585,7 +8815,7 @@
           </a:fontRef>
         </p:style>
         <p:txBody>
-          <a:bodyPr wrap="none" lIns="73152" tIns="9144" rIns="73152" bIns="9144" rtlCol="0" anchor="ctr"/>
+          <a:bodyPr rtlCol="0" anchor="ctr" wrap="none" lIns="73152" rIns="73152" tIns="9144" bIns="9144"/>
           <a:lstStyle/>
           <a:p>
             <a:pPr algn="ctr">
@@ -8657,8 +8887,7 @@
               </a:defRPr>
             </a:pPr>
             <a:r>
-              <a:rPr dirty="0"/>
-              <a:t>Genuine Implemented UI: In-browser editable spreadsheet sandbox isolates validation findings before central commit.</a:t>
+              <a:t>Implemented UI: In-browser editable spreadsheet sandbox isolates validation findings before central commit.</a:t>
             </a:r>
           </a:p>
         </p:txBody>
@@ -8787,7 +9016,7 @@
           <a:bodyPr wrap="square"/>
           <a:lstStyle/>
           <a:p>
-            <a:pPr algn="l" eaLnBrk="1" hangingPunct="1">
+            <a:pPr eaLnBrk="1" hangingPunct="1" algn="l">
               <a:defRPr sz="1650" b="1">
                 <a:solidFill>
                   <a:srgbClr val="112266"/>
@@ -8796,7 +9025,6 @@
               </a:defRPr>
             </a:pPr>
             <a:r>
-              <a:rPr dirty="0"/>
               <a:t>FEASIBILITY, VIABILITY AND RISK MITIGATION</a:t>
             </a:r>
           </a:p>
@@ -8965,7 +9193,7 @@
           </a:fontRef>
         </p:style>
         <p:txBody>
-          <a:bodyPr wrap="none" lIns="18288" rIns="18288" rtlCol="0" anchor="ctr"/>
+          <a:bodyPr rtlCol="0" anchor="ctr" wrap="none" lIns="18288" rIns="18288"/>
           <a:lstStyle/>
           <a:p>
             <a:pPr algn="ctr">
@@ -9055,7 +9283,6 @@
           <a:lstStyle/>
           <a:p>
             <a:pPr algn="ctr"/>
-            <a:endParaRPr/>
           </a:p>
         </p:txBody>
       </p:sp>
@@ -9095,7 +9322,7 @@
           </a:fontRef>
         </p:style>
         <p:txBody>
-          <a:bodyPr wrap="none" lIns="73152" tIns="9144" rIns="73152" bIns="9144" rtlCol="0" anchor="ctr"/>
+          <a:bodyPr rtlCol="0" anchor="ctr" wrap="none" lIns="73152" rIns="73152" tIns="9144" bIns="9144"/>
           <a:lstStyle/>
           <a:p>
             <a:pPr algn="ctr">
@@ -9121,7 +9348,7 @@
         <p:spPr>
           <a:xfrm>
             <a:off x="502920" y="1371600"/>
-            <a:ext cx="5349240" cy="3836948"/>
+            <a:ext cx="5349240" cy="4572000"/>
           </a:xfrm>
           <a:prstGeom prst="rect">
             <a:avLst/>
@@ -9129,7 +9356,7 @@
           <a:noFill/>
         </p:spPr>
         <p:txBody>
-          <a:bodyPr wrap="square" lIns="0" tIns="0" rIns="0" bIns="0">
+          <a:bodyPr wrap="square" lIns="0" rIns="0" tIns="0" bIns="0">
             <a:spAutoFit/>
           </a:bodyPr>
           <a:lstStyle/>
@@ -9140,59 +9367,41 @@
               </a:spcBef>
             </a:pPr>
             <a:r>
-              <a:rPr sz="1200" b="1" dirty="0">
+              <a:rPr sz="890" b="1">
                 <a:solidFill>
                   <a:srgbClr val="1A365D"/>
                 </a:solidFill>
                 <a:latin typeface="Arial"/>
               </a:rPr>
-              <a:t>• Architectural Feasibility: </a:t>
-            </a:r>
-            <a:r>
-              <a:rPr sz="1200" dirty="0">
+              <a:t>- Architectural Feasibility: </a:t>
+            </a:r>
+            <a:r>
+              <a:rPr sz="830">
                 <a:solidFill>
                   <a:srgbClr val="222222"/>
                 </a:solidFill>
                 <a:latin typeface="Arial"/>
               </a:rPr>
-              <a:t>Zero-install web architecture. Standard modern browser access across Windows, Linux, and macOS. Decoupled Next.js client and </a:t>
-            </a:r>
-            <a:r>
-              <a:rPr sz="1200" dirty="0" err="1">
-                <a:solidFill>
-                  <a:srgbClr val="222222"/>
-                </a:solidFill>
-                <a:latin typeface="Arial"/>
-              </a:rPr>
-              <a:t>FastAPI</a:t>
-            </a:r>
-            <a:r>
-              <a:rPr sz="1200" dirty="0">
-                <a:solidFill>
-                  <a:srgbClr val="222222"/>
-                </a:solidFill>
-                <a:latin typeface="Arial"/>
-              </a:rPr>
-              <a:t> modular backend.</a:t>
+              <a:t>Zero-install web architecture. Standard modern browser access across Windows, Linux, and macOS. Decoupled Next.js client and FastAPI modular backend.</a:t>
             </a:r>
           </a:p>
           <a:p>
             <a:pPr>
               <a:spcBef>
-                <a:spcPts val="750"/>
+                <a:spcPts val="700"/>
               </a:spcBef>
             </a:pPr>
             <a:r>
-              <a:rPr sz="1200" b="1" dirty="0">
+              <a:rPr sz="890" b="1">
                 <a:solidFill>
                   <a:srgbClr val="1A365D"/>
                 </a:solidFill>
                 <a:latin typeface="Arial"/>
               </a:rPr>
-              <a:t>• Verified Test Suite (64/64 Passing): </a:t>
-            </a:r>
-            <a:r>
-              <a:rPr sz="1200" dirty="0">
+              <a:t>- Verified Test Suite (66/66 Passing): </a:t>
+            </a:r>
+            <a:r>
+              <a:rPr sz="830">
                 <a:solidFill>
                   <a:srgbClr val="222222"/>
                 </a:solidFill>
@@ -9204,20 +9413,20 @@
           <a:p>
             <a:pPr>
               <a:spcBef>
-                <a:spcPts val="750"/>
+                <a:spcPts val="700"/>
               </a:spcBef>
             </a:pPr>
             <a:r>
-              <a:rPr sz="1200" b="1" dirty="0">
+              <a:rPr sz="890" b="1">
                 <a:solidFill>
                   <a:srgbClr val="1A365D"/>
                 </a:solidFill>
                 <a:latin typeface="Arial"/>
               </a:rPr>
-              <a:t>• Deterministic Logic Integrity: </a:t>
-            </a:r>
-            <a:r>
-              <a:rPr sz="1200" dirty="0">
+              <a:t>- Deterministic Logic Integrity: </a:t>
+            </a:r>
+            <a:r>
+              <a:rPr sz="830">
                 <a:solidFill>
                   <a:srgbClr val="222222"/>
                 </a:solidFill>
@@ -9229,20 +9438,20 @@
           <a:p>
             <a:pPr>
               <a:spcBef>
-                <a:spcPts val="750"/>
+                <a:spcPts val="700"/>
               </a:spcBef>
             </a:pPr>
             <a:r>
-              <a:rPr sz="1200" b="1" dirty="0">
+              <a:rPr sz="890" b="1">
                 <a:solidFill>
                   <a:srgbClr val="1A365D"/>
                 </a:solidFill>
                 <a:latin typeface="Arial"/>
               </a:rPr>
-              <a:t>• Synthetic Data Testing Engine: </a:t>
-            </a:r>
-            <a:r>
-              <a:rPr sz="1200" dirty="0">
+              <a:t>- Synthetic Data Testing Engine: </a:t>
+            </a:r>
+            <a:r>
+              <a:rPr sz="830">
                 <a:solidFill>
                   <a:srgbClr val="222222"/>
                 </a:solidFill>
@@ -9254,60 +9463,51 @@
           <a:p>
             <a:pPr>
               <a:spcBef>
-                <a:spcPts val="750"/>
+                <a:spcPts val="700"/>
               </a:spcBef>
             </a:pPr>
             <a:r>
-              <a:rPr sz="1200" b="1" dirty="0">
+              <a:rPr sz="890" b="1">
                 <a:solidFill>
                   <a:srgbClr val="1A365D"/>
                 </a:solidFill>
                 <a:latin typeface="Arial"/>
               </a:rPr>
-              <a:t>• Dual-Dialect Database Support: </a:t>
-            </a:r>
-            <a:r>
-              <a:rPr sz="1200" dirty="0" err="1">
+              <a:t>- Dual-Dialect Database Support: </a:t>
+            </a:r>
+            <a:r>
+              <a:rPr sz="830">
                 <a:solidFill>
                   <a:srgbClr val="222222"/>
                 </a:solidFill>
                 <a:latin typeface="Arial"/>
               </a:rPr>
-              <a:t>SQLAlchemy</a:t>
-            </a:r>
-            <a:r>
-              <a:rPr sz="1200" dirty="0">
-                <a:solidFill>
-                  <a:srgbClr val="222222"/>
-                </a:solidFill>
-                <a:latin typeface="Arial"/>
-              </a:rPr>
-              <a:t> ORM architecture with dynamic driver fallback (psycopg3/psycopg2) verified on local SQLite WAL mode and configured PostgreSQL schemas (20 tables, RLS active).</a:t>
+              <a:t>SQLAlchemy ORM architecture with dynamic driver fallback (psycopg3/psycopg2) verified on local SQLite WAL mode and Supabase PostgreSQL 17.11 (20 tables, RLS active).</a:t>
             </a:r>
           </a:p>
           <a:p>
             <a:pPr>
               <a:spcBef>
-                <a:spcPts val="750"/>
+                <a:spcPts val="700"/>
               </a:spcBef>
             </a:pPr>
             <a:r>
-              <a:rPr sz="1200" b="1" dirty="0">
+              <a:rPr sz="890" b="1">
                 <a:solidFill>
                   <a:srgbClr val="1A365D"/>
                 </a:solidFill>
                 <a:latin typeface="Arial"/>
               </a:rPr>
-              <a:t>• Transparent Deployment Status: </a:t>
-            </a:r>
-            <a:r>
-              <a:rPr sz="1200" dirty="0">
+              <a:t>- Live Production Cloud Verification: </a:t>
+            </a:r>
+            <a:r>
+              <a:rPr sz="830">
                 <a:solidFill>
                   <a:srgbClr val="222222"/>
                 </a:solidFill>
                 <a:latin typeface="Arial"/>
               </a:rPr>
-              <a:t>Application codebase, schemas, and test suites 100% verified locally; cloud Render web deployment is currently pending resolution of cloud environment DNS configuration.</a:t>
+              <a:t>Full cloud deployment verified live: FastAPI backend on Render with PostgreSQL connection, Next.js frontend on Vercel with custom domain brainforge.info, and 100% end-to-end integration pass.</a:t>
             </a:r>
           </a:p>
         </p:txBody>
@@ -9354,7 +9554,6 @@
           <a:lstStyle/>
           <a:p>
             <a:pPr algn="ctr"/>
-            <a:endParaRPr/>
           </a:p>
         </p:txBody>
       </p:sp>
@@ -9394,7 +9593,7 @@
           </a:fontRef>
         </p:style>
         <p:txBody>
-          <a:bodyPr wrap="none" lIns="73152" tIns="9144" rIns="73152" bIns="9144" rtlCol="0" anchor="ctr"/>
+          <a:bodyPr rtlCol="0" anchor="ctr" wrap="none" lIns="73152" rIns="73152" tIns="9144" bIns="9144"/>
           <a:lstStyle/>
           <a:p>
             <a:pPr algn="ctr">
@@ -9420,7 +9619,7 @@
         <p:spPr>
           <a:xfrm>
             <a:off x="6309360" y="1371600"/>
-            <a:ext cx="5349240" cy="4314001"/>
+            <a:ext cx="5349240" cy="4572000"/>
           </a:xfrm>
           <a:prstGeom prst="rect">
             <a:avLst/>
@@ -9428,7 +9627,7 @@
           <a:noFill/>
         </p:spPr>
         <p:txBody>
-          <a:bodyPr wrap="square" lIns="0" tIns="0" rIns="0" bIns="0">
+          <a:bodyPr wrap="square" lIns="0" rIns="0" tIns="0" bIns="0">
             <a:spAutoFit/>
           </a:bodyPr>
           <a:lstStyle/>
@@ -9439,76 +9638,22 @@
               </a:spcBef>
             </a:pPr>
             <a:r>
-              <a:rPr sz="1200" b="1" dirty="0">
+              <a:rPr sz="869" b="1">
                 <a:solidFill>
                   <a:srgbClr val="B42828"/>
                 </a:solidFill>
                 <a:latin typeface="Arial"/>
               </a:rPr>
-              <a:t>⚠️ Risk: Inconsistent Institutional Spreadsheets: </a:t>
-            </a:r>
-            <a:r>
-              <a:rPr sz="1200" dirty="0">
+              <a:t>- Risk: Inconsistent Institutional Spreadsheets: </a:t>
+            </a:r>
+            <a:r>
+              <a:rPr sz="819">
                 <a:solidFill>
                   <a:srgbClr val="222222"/>
                 </a:solidFill>
                 <a:latin typeface="Arial"/>
               </a:rPr>
-              <a:t>Colleges use varying ERP schemas and column headers (e.g. </a:t>
-            </a:r>
-            <a:r>
-              <a:rPr sz="1200" dirty="0" err="1">
-                <a:solidFill>
-                  <a:srgbClr val="222222"/>
-                </a:solidFill>
-                <a:latin typeface="Arial"/>
-              </a:rPr>
-              <a:t>apaar_id</a:t>
-            </a:r>
-            <a:r>
-              <a:rPr sz="1200" dirty="0">
-                <a:solidFill>
-                  <a:srgbClr val="222222"/>
-                </a:solidFill>
-                <a:latin typeface="Arial"/>
-              </a:rPr>
-              <a:t> vs </a:t>
-            </a:r>
-            <a:r>
-              <a:rPr sz="1200" dirty="0" err="1">
-                <a:solidFill>
-                  <a:srgbClr val="222222"/>
-                </a:solidFill>
-                <a:latin typeface="Arial"/>
-              </a:rPr>
-              <a:t>uid</a:t>
-            </a:r>
-            <a:r>
-              <a:rPr sz="1200" dirty="0">
-                <a:solidFill>
-                  <a:srgbClr val="222222"/>
-                </a:solidFill>
-                <a:latin typeface="Arial"/>
-              </a:rPr>
-              <a:t> vs </a:t>
-            </a:r>
-            <a:r>
-              <a:rPr sz="1200" dirty="0" err="1">
-                <a:solidFill>
-                  <a:srgbClr val="222222"/>
-                </a:solidFill>
-                <a:latin typeface="Arial"/>
-              </a:rPr>
-              <a:t>student_apaar</a:t>
-            </a:r>
-            <a:r>
-              <a:rPr sz="1200" dirty="0">
-                <a:solidFill>
-                  <a:srgbClr val="222222"/>
-                </a:solidFill>
-                <a:latin typeface="Arial"/>
-              </a:rPr>
-              <a:t>).</a:t>
+              <a:t>Colleges use varying ERP schemas and column headers (e.g. apaar_id vs uid vs student_apaar).</a:t>
             </a:r>
           </a:p>
           <a:p>
@@ -9518,16 +9663,16 @@
               </a:spcBef>
             </a:pPr>
             <a:r>
-              <a:rPr sz="1200" b="1" dirty="0">
+              <a:rPr sz="850" b="1">
                 <a:solidFill>
                   <a:srgbClr val="008C6E"/>
                 </a:solidFill>
                 <a:latin typeface="Arial"/>
               </a:rPr>
-              <a:t>  → Control: </a:t>
-            </a:r>
-            <a:r>
-              <a:rPr sz="1200" dirty="0">
+              <a:t>  * Control: </a:t>
+            </a:r>
+            <a:r>
+              <a:rPr sz="819">
                 <a:solidFill>
                   <a:srgbClr val="222222"/>
                 </a:solidFill>
@@ -9543,16 +9688,16 @@
               </a:spcBef>
             </a:pPr>
             <a:r>
-              <a:rPr sz="1200" b="1" dirty="0">
+              <a:rPr sz="869" b="1">
                 <a:solidFill>
                   <a:srgbClr val="B42828"/>
                 </a:solidFill>
                 <a:latin typeface="Arial"/>
               </a:rPr>
-              <a:t>⚠️ Risk: Student Identifier Privacy Exposure: </a:t>
-            </a:r>
-            <a:r>
-              <a:rPr sz="1200" dirty="0">
+              <a:t>- Risk: Student Identifier Privacy Exposure: </a:t>
+            </a:r>
+            <a:r>
+              <a:rPr sz="819">
                 <a:solidFill>
                   <a:srgbClr val="222222"/>
                 </a:solidFill>
@@ -9568,16 +9713,16 @@
               </a:spcBef>
             </a:pPr>
             <a:r>
-              <a:rPr sz="1200" b="1" dirty="0">
+              <a:rPr sz="850" b="1">
                 <a:solidFill>
                   <a:srgbClr val="008C6E"/>
                 </a:solidFill>
                 <a:latin typeface="Arial"/>
               </a:rPr>
-              <a:t>  → Control: </a:t>
-            </a:r>
-            <a:r>
-              <a:rPr sz="1200" dirty="0">
+              <a:t>  * Control: </a:t>
+            </a:r>
+            <a:r>
+              <a:rPr sz="819">
                 <a:solidFill>
                   <a:srgbClr val="222222"/>
                 </a:solidFill>
@@ -9593,16 +9738,16 @@
               </a:spcBef>
             </a:pPr>
             <a:r>
-              <a:rPr sz="1200" b="1" dirty="0">
+              <a:rPr sz="869" b="1">
                 <a:solidFill>
                   <a:srgbClr val="B42828"/>
                 </a:solidFill>
                 <a:latin typeface="Arial"/>
               </a:rPr>
-              <a:t>⚠️ Risk: Multi-Institution Concurrent Admissions: </a:t>
-            </a:r>
-            <a:r>
-              <a:rPr sz="1200" dirty="0">
+              <a:t>- Risk: Multi-Institution Concurrent Admissions: </a:t>
+            </a:r>
+            <a:r>
+              <a:rPr sz="819">
                 <a:solidFill>
                   <a:srgbClr val="222222"/>
                 </a:solidFill>
@@ -9618,16 +9763,16 @@
               </a:spcBef>
             </a:pPr>
             <a:r>
-              <a:rPr sz="1200" b="1" dirty="0">
+              <a:rPr sz="850" b="1">
                 <a:solidFill>
                   <a:srgbClr val="008C6E"/>
                 </a:solidFill>
                 <a:latin typeface="Arial"/>
               </a:rPr>
-              <a:t>  → Control: </a:t>
-            </a:r>
-            <a:r>
-              <a:rPr sz="1200" dirty="0">
+              <a:t>  * Control: </a:t>
+            </a:r>
+            <a:r>
+              <a:rPr sz="819">
                 <a:solidFill>
                   <a:srgbClr val="222222"/>
                 </a:solidFill>
@@ -9643,16 +9788,16 @@
               </a:spcBef>
             </a:pPr>
             <a:r>
-              <a:rPr sz="1200" b="1" dirty="0">
+              <a:rPr sz="869" b="1">
                 <a:solidFill>
                   <a:srgbClr val="B42828"/>
                 </a:solidFill>
                 <a:latin typeface="Arial"/>
               </a:rPr>
-              <a:t>⚠️ Risk: Regulatory Non-Repudiation &amp; Tampering: </a:t>
-            </a:r>
-            <a:r>
-              <a:rPr sz="1200" dirty="0">
+              <a:t>- Risk: Regulatory Non-Repudiation &amp; Tampering: </a:t>
+            </a:r>
+            <a:r>
+              <a:rPr sz="819">
                 <a:solidFill>
                   <a:srgbClr val="222222"/>
                 </a:solidFill>
@@ -9668,58 +9813,22 @@
               </a:spcBef>
             </a:pPr>
             <a:r>
-              <a:rPr sz="1200" b="1" dirty="0">
+              <a:rPr sz="850" b="1">
                 <a:solidFill>
                   <a:srgbClr val="008C6E"/>
                 </a:solidFill>
                 <a:latin typeface="Arial"/>
               </a:rPr>
-              <a:t>  → Control: </a:t>
-            </a:r>
-            <a:r>
-              <a:rPr sz="1200" dirty="0">
+              <a:t>  * Control: </a:t>
+            </a:r>
+            <a:r>
+              <a:rPr sz="819">
                 <a:solidFill>
                   <a:srgbClr val="222222"/>
                 </a:solidFill>
                 <a:latin typeface="Arial"/>
               </a:rPr>
-              <a:t>Append-only sequential SHA-256 hash chaining (</a:t>
-            </a:r>
-            <a:r>
-              <a:rPr sz="1200" dirty="0" err="1">
-                <a:solidFill>
-                  <a:srgbClr val="222222"/>
-                </a:solidFill>
-                <a:latin typeface="Arial"/>
-              </a:rPr>
-              <a:t>Hash_n</a:t>
-            </a:r>
-            <a:r>
-              <a:rPr sz="1200" dirty="0">
-                <a:solidFill>
-                  <a:srgbClr val="222222"/>
-                </a:solidFill>
-                <a:latin typeface="Arial"/>
-              </a:rPr>
-              <a:t> = SHA256(</a:t>
-            </a:r>
-            <a:r>
-              <a:rPr sz="1200" dirty="0" err="1">
-                <a:solidFill>
-                  <a:srgbClr val="222222"/>
-                </a:solidFill>
-                <a:latin typeface="Arial"/>
-              </a:rPr>
-              <a:t>Record_n</a:t>
-            </a:r>
-            <a:r>
-              <a:rPr sz="1200" dirty="0">
-                <a:solidFill>
-                  <a:srgbClr val="222222"/>
-                </a:solidFill>
-                <a:latin typeface="Arial"/>
-              </a:rPr>
-              <a:t> || Hash_n-1)) mathematically exposes any tampering.</a:t>
+              <a:t>Append-only sequential SHA-256 hash chaining (Hash_n = SHA256(Record_n || Hash_n-1)) mathematically exposes any tampering.</a:t>
             </a:r>
           </a:p>
           <a:p>
@@ -9729,22 +9838,22 @@
               </a:spcBef>
             </a:pPr>
             <a:r>
-              <a:rPr sz="1200" b="1" dirty="0">
+              <a:rPr sz="869" b="1">
                 <a:solidFill>
                   <a:srgbClr val="B42828"/>
                 </a:solidFill>
                 <a:latin typeface="Arial"/>
               </a:rPr>
-              <a:t>⚠️ Risk: Database Driver &amp; Cloud Hosting Mismatch: </a:t>
-            </a:r>
-            <a:r>
-              <a:rPr sz="1200" dirty="0">
+              <a:t>- Risk: Database Driver &amp; Cloud Connection Mismatch: </a:t>
+            </a:r>
+            <a:r>
+              <a:rPr sz="819">
                 <a:solidFill>
                   <a:srgbClr val="222222"/>
                 </a:solidFill>
                 <a:latin typeface="Arial"/>
               </a:rPr>
-              <a:t>Container deployment failures caused by PostgreSQL driver compatibility or DNS misconfiguration.</a:t>
+              <a:t>Container deployment failures caused by PostgreSQL driver compatibility or pooler SSL configuration.</a:t>
             </a:r>
           </a:p>
           <a:p>
@@ -9754,22 +9863,22 @@
               </a:spcBef>
             </a:pPr>
             <a:r>
-              <a:rPr sz="1200" b="1" dirty="0">
+              <a:rPr sz="850" b="1">
                 <a:solidFill>
                   <a:srgbClr val="008C6E"/>
                 </a:solidFill>
                 <a:latin typeface="Arial"/>
               </a:rPr>
-              <a:t>  → Control: </a:t>
-            </a:r>
-            <a:r>
-              <a:rPr sz="1200" dirty="0">
+              <a:t>  * Control: </a:t>
+            </a:r>
+            <a:r>
+              <a:rPr sz="819">
                 <a:solidFill>
                   <a:srgbClr val="222222"/>
                 </a:solidFill>
                 <a:latin typeface="Arial"/>
               </a:rPr>
-              <a:t>Implemented psycopg3/psycopg2 dynamic driver fallback with automated fallback logging and sanitized connection strings.</a:t>
+              <a:t>Implemented smart connection URI sanitization and dynamic psycopg3/psycopg2 driver fallback with automated readiness health check.</a:t>
             </a:r>
           </a:p>
         </p:txBody>
@@ -9903,7 +10012,7 @@
           <a:bodyPr wrap="square"/>
           <a:lstStyle/>
           <a:p>
-            <a:pPr algn="l" eaLnBrk="1" hangingPunct="1">
+            <a:pPr eaLnBrk="1" hangingPunct="1" algn="l">
               <a:defRPr sz="1650" b="1">
                 <a:solidFill>
                   <a:srgbClr val="112266"/>
@@ -10080,7 +10189,7 @@
           </a:fontRef>
         </p:style>
         <p:txBody>
-          <a:bodyPr wrap="none" lIns="18288" rIns="18288" rtlCol="0" anchor="ctr"/>
+          <a:bodyPr rtlCol="0" anchor="ctr" wrap="none" lIns="18288" rIns="18288"/>
           <a:lstStyle/>
           <a:p>
             <a:pPr algn="ctr">
@@ -10170,7 +10279,6 @@
           <a:lstStyle/>
           <a:p>
             <a:pPr algn="ctr"/>
-            <a:endParaRPr/>
           </a:p>
         </p:txBody>
       </p:sp>
@@ -10210,7 +10318,7 @@
           </a:fontRef>
         </p:style>
         <p:txBody>
-          <a:bodyPr wrap="none" lIns="73152" tIns="9144" rIns="73152" bIns="9144" rtlCol="0" anchor="ctr"/>
+          <a:bodyPr rtlCol="0" anchor="ctr" wrap="none" lIns="73152" rIns="73152" tIns="9144" bIns="9144"/>
           <a:lstStyle/>
           <a:p>
             <a:pPr algn="ctr">
@@ -10236,7 +10344,7 @@
         <p:spPr>
           <a:xfrm>
             <a:off x="502920" y="1371600"/>
-            <a:ext cx="5349240" cy="3836948"/>
+            <a:ext cx="5349240" cy="4572000"/>
           </a:xfrm>
           <a:prstGeom prst="rect">
             <a:avLst/>
@@ -10244,7 +10352,7 @@
           <a:noFill/>
         </p:spPr>
         <p:txBody>
-          <a:bodyPr wrap="square" lIns="0" tIns="0" rIns="0" bIns="0">
+          <a:bodyPr wrap="square" lIns="0" rIns="0" tIns="0" bIns="0">
             <a:spAutoFit/>
           </a:bodyPr>
           <a:lstStyle/>
@@ -10255,16 +10363,16 @@
               </a:spcBef>
             </a:pPr>
             <a:r>
-              <a:rPr sz="1200" b="1" dirty="0">
+              <a:rPr sz="880" b="1">
                 <a:solidFill>
                   <a:srgbClr val="1A365D"/>
                 </a:solidFill>
                 <a:latin typeface="Arial"/>
               </a:rPr>
-              <a:t>• AICTE &amp; Regulatory Councils: </a:t>
-            </a:r>
-            <a:r>
-              <a:rPr sz="1200" dirty="0">
+              <a:t>- AICTE &amp; Regulatory Councils: </a:t>
+            </a:r>
+            <a:r>
+              <a:rPr sz="819">
                 <a:solidFill>
                   <a:srgbClr val="222222"/>
                 </a:solidFill>
@@ -10276,20 +10384,20 @@
           <a:p>
             <a:pPr>
               <a:spcBef>
-                <a:spcPts val="750"/>
+                <a:spcPts val="700"/>
               </a:spcBef>
             </a:pPr>
             <a:r>
-              <a:rPr sz="1200" b="1" dirty="0">
+              <a:rPr sz="880" b="1">
                 <a:solidFill>
                   <a:srgbClr val="1A365D"/>
                 </a:solidFill>
                 <a:latin typeface="Arial"/>
               </a:rPr>
-              <a:t>• Approved Institutions: </a:t>
-            </a:r>
-            <a:r>
-              <a:rPr sz="1200" dirty="0">
+              <a:t>- Approved Institutions: </a:t>
+            </a:r>
+            <a:r>
+              <a:rPr sz="819">
                 <a:solidFill>
                   <a:srgbClr val="222222"/>
                 </a:solidFill>
@@ -10301,20 +10409,20 @@
           <a:p>
             <a:pPr>
               <a:spcBef>
-                <a:spcPts val="750"/>
+                <a:spcPts val="700"/>
               </a:spcBef>
             </a:pPr>
             <a:r>
-              <a:rPr sz="1200" b="1" dirty="0">
+              <a:rPr sz="880" b="1">
                 <a:solidFill>
                   <a:srgbClr val="1A365D"/>
                 </a:solidFill>
                 <a:latin typeface="Arial"/>
               </a:rPr>
-              <a:t>• Students &amp; Deserving Candidates: </a:t>
-            </a:r>
-            <a:r>
-              <a:rPr sz="1200" dirty="0">
+              <a:t>- Students &amp; Deserving Candidates: </a:t>
+            </a:r>
+            <a:r>
+              <a:rPr sz="819">
                 <a:solidFill>
                   <a:srgbClr val="222222"/>
                 </a:solidFill>
@@ -10326,20 +10434,20 @@
           <a:p>
             <a:pPr>
               <a:spcBef>
-                <a:spcPts val="750"/>
+                <a:spcPts val="700"/>
               </a:spcBef>
             </a:pPr>
             <a:r>
-              <a:rPr sz="1200" b="1" dirty="0">
+              <a:rPr sz="880" b="1">
                 <a:solidFill>
                   <a:srgbClr val="1A365D"/>
                 </a:solidFill>
                 <a:latin typeface="Arial"/>
               </a:rPr>
-              <a:t>• Academic Verifiers &amp; Employers: </a:t>
-            </a:r>
-            <a:r>
-              <a:rPr sz="1200" dirty="0">
+              <a:t>- Academic Verifiers &amp; Employers: </a:t>
+            </a:r>
+            <a:r>
+              <a:rPr sz="819">
                 <a:solidFill>
                   <a:srgbClr val="222222"/>
                 </a:solidFill>
@@ -10351,20 +10459,20 @@
           <a:p>
             <a:pPr>
               <a:spcBef>
-                <a:spcPts val="750"/>
+                <a:spcPts val="700"/>
               </a:spcBef>
             </a:pPr>
             <a:r>
-              <a:rPr sz="1200" b="1" dirty="0">
+              <a:rPr sz="880" b="1">
                 <a:solidFill>
                   <a:srgbClr val="1A365D"/>
                 </a:solidFill>
                 <a:latin typeface="Arial"/>
               </a:rPr>
-              <a:t>• Social Equity &amp; Affirmative Action: </a:t>
-            </a:r>
-            <a:r>
-              <a:rPr sz="1200" dirty="0">
+              <a:t>- Social Equity &amp; Affirmative Action: </a:t>
+            </a:r>
+            <a:r>
+              <a:rPr sz="819">
                 <a:solidFill>
                   <a:srgbClr val="222222"/>
                 </a:solidFill>
@@ -10376,20 +10484,20 @@
           <a:p>
             <a:pPr>
               <a:spcBef>
-                <a:spcPts val="750"/>
+                <a:spcPts val="700"/>
               </a:spcBef>
             </a:pPr>
             <a:r>
-              <a:rPr sz="1200" b="1" dirty="0">
+              <a:rPr sz="880" b="1">
                 <a:solidFill>
                   <a:srgbClr val="1A365D"/>
                 </a:solidFill>
                 <a:latin typeface="Arial"/>
               </a:rPr>
-              <a:t>• Administrative &amp; Paperless Efficiency: </a:t>
-            </a:r>
-            <a:r>
-              <a:rPr sz="1200" dirty="0">
+              <a:t>- Administrative &amp; Paperless Efficiency: </a:t>
+            </a:r>
+            <a:r>
+              <a:rPr sz="819">
                 <a:solidFill>
                   <a:srgbClr val="222222"/>
                 </a:solidFill>
@@ -10408,7 +10516,7 @@
         </p:nvSpPr>
         <p:spPr>
           <a:xfrm>
-            <a:off x="6227741" y="1115568"/>
+            <a:off x="6172200" y="1115568"/>
             <a:ext cx="5623560" cy="4956048"/>
           </a:xfrm>
           <a:prstGeom prst="roundRect">
@@ -10442,7 +10550,6 @@
           <a:lstStyle/>
           <a:p>
             <a:pPr algn="ctr"/>
-            <a:endParaRPr/>
           </a:p>
         </p:txBody>
       </p:sp>
@@ -10482,7 +10589,7 @@
           </a:fontRef>
         </p:style>
         <p:txBody>
-          <a:bodyPr wrap="none" lIns="73152" tIns="9144" rIns="73152" bIns="9144" rtlCol="0" anchor="ctr"/>
+          <a:bodyPr rtlCol="0" anchor="ctr" wrap="none" lIns="73152" rIns="73152" tIns="9144" bIns="9144"/>
           <a:lstStyle/>
           <a:p>
             <a:pPr algn="ctr">
@@ -10494,45 +10601,21 @@
               </a:defRPr>
             </a:pPr>
             <a:r>
-              <a:t>SIH REQUIREMENT 10: DEGREE CERTIFICATE VERIFICATION</a:t>
-            </a:r>
-          </a:p>
-        </p:txBody>
-      </p:sp>
-      <p:pic>
-        <p:nvPicPr>
-          <p:cNvPr id="17415" name="Picture 17414" descr="08_student_certificate_verified.png"/>
-          <p:cNvPicPr>
-            <a:picLocks noChangeAspect="1"/>
-          </p:cNvPicPr>
-          <p:nvPr/>
-        </p:nvPicPr>
-        <p:blipFill>
-          <a:blip r:embed="rId4"/>
-          <a:stretch>
-            <a:fillRect/>
-          </a:stretch>
-        </p:blipFill>
-        <p:spPr>
-          <a:xfrm>
-            <a:off x="6281928" y="1353312"/>
-            <a:ext cx="5404104" cy="2926080"/>
-          </a:xfrm>
-          <a:prstGeom prst="rect">
-            <a:avLst/>
-          </a:prstGeom>
-        </p:spPr>
-      </p:pic>
-      <p:sp>
-        <p:nvSpPr>
-          <p:cNvPr id="17416" name="TextBox 17415"/>
+              <a:t>CRYPTOGRAPHICALLY VERIFIABLE DEGREE CERTIFICATE &amp; QR PROOF</a:t>
+            </a:r>
+          </a:p>
+        </p:txBody>
+      </p:sp>
+      <p:sp>
+        <p:nvSpPr>
+          <p:cNvPr id="17415" name="TextBox 17414"/>
           <p:cNvSpPr txBox="1"/>
           <p:nvPr/>
         </p:nvSpPr>
         <p:spPr>
           <a:xfrm>
-            <a:off x="6281928" y="4370832"/>
-            <a:ext cx="5404104" cy="1208023"/>
+            <a:off x="6281928" y="4343400"/>
+            <a:ext cx="5404104" cy="1645920"/>
           </a:xfrm>
           <a:prstGeom prst="rect">
             <a:avLst/>
@@ -10540,7 +10623,7 @@
           <a:noFill/>
         </p:spPr>
         <p:txBody>
-          <a:bodyPr wrap="square" lIns="0" tIns="0" rIns="0" bIns="0">
+          <a:bodyPr wrap="square" lIns="0" rIns="0" tIns="0" bIns="0">
             <a:spAutoFit/>
           </a:bodyPr>
           <a:lstStyle/>
@@ -10551,16 +10634,16 @@
               </a:spcBef>
             </a:pPr>
             <a:r>
-              <a:rPr sz="1050" b="1" dirty="0">
-                <a:solidFill>
-                  <a:srgbClr val="008C6E"/>
-                </a:solidFill>
-                <a:latin typeface="Arial"/>
-              </a:rPr>
-              <a:t>✓ Dual Identity Display: </a:t>
-            </a:r>
-            <a:r>
-              <a:rPr sz="1050" dirty="0">
+              <a:rPr sz="819" b="1">
+                <a:solidFill>
+                  <a:srgbClr val="1A365D"/>
+                </a:solidFill>
+                <a:latin typeface="Arial"/>
+              </a:rPr>
+              <a:t>- Dual Identity Display: </a:t>
+            </a:r>
+            <a:r>
+              <a:rPr sz="780">
                 <a:solidFill>
                   <a:srgbClr val="222222"/>
                 </a:solidFill>
@@ -10576,16 +10659,16 @@
               </a:spcBef>
             </a:pPr>
             <a:r>
-              <a:rPr sz="1050" b="1" dirty="0">
-                <a:solidFill>
-                  <a:srgbClr val="008C6E"/>
-                </a:solidFill>
-                <a:latin typeface="Arial"/>
-              </a:rPr>
-              <a:t>✓ Asymmetric Ed25519 QR Code: </a:t>
-            </a:r>
-            <a:r>
-              <a:rPr sz="1050" dirty="0">
+              <a:rPr sz="819" b="1">
+                <a:solidFill>
+                  <a:srgbClr val="1A365D"/>
+                </a:solidFill>
+                <a:latin typeface="Arial"/>
+              </a:rPr>
+              <a:t>- Asymmetric Ed25519 QR Code: </a:t>
+            </a:r>
+            <a:r>
+              <a:rPr sz="780">
                 <a:solidFill>
                   <a:srgbClr val="222222"/>
                 </a:solidFill>
@@ -10601,16 +10684,16 @@
               </a:spcBef>
             </a:pPr>
             <a:r>
-              <a:rPr sz="1050" b="1" dirty="0">
-                <a:solidFill>
-                  <a:srgbClr val="008C6E"/>
-                </a:solidFill>
-                <a:latin typeface="Arial"/>
-              </a:rPr>
-              <a:t>✓ Integrity Boundary Clarification: </a:t>
-            </a:r>
-            <a:r>
-              <a:rPr sz="1050" dirty="0">
+              <a:rPr sz="819" b="1">
+                <a:solidFill>
+                  <a:srgbClr val="1A365D"/>
+                </a:solidFill>
+                <a:latin typeface="Arial"/>
+              </a:rPr>
+              <a:t>- Integrity Boundary Clarification: </a:t>
+            </a:r>
+            <a:r>
+              <a:rPr sz="780">
                 <a:solidFill>
                   <a:srgbClr val="222222"/>
                 </a:solidFill>
@@ -10750,7 +10833,7 @@
           <a:bodyPr wrap="square"/>
           <a:lstStyle/>
           <a:p>
-            <a:pPr algn="l" eaLnBrk="1" hangingPunct="1">
+            <a:pPr eaLnBrk="1" hangingPunct="1" algn="l">
               <a:defRPr sz="1650" b="1">
                 <a:solidFill>
                   <a:srgbClr val="112266"/>
@@ -10869,16 +10952,7 @@
               </a:defRPr>
             </a:pPr>
             <a:r>
-              <a:rPr dirty="0"/>
-              <a:t>@ </a:t>
-            </a:r>
-            <a:r>
-              <a:rPr dirty="0" err="1"/>
-              <a:t>TCE_Yquanto</a:t>
-            </a:r>
-            <a:r>
-              <a:rPr dirty="0"/>
-              <a:t> | Smart India Hackathon 2026</a:t>
+              <a:t>@ TCE_Yquanto | Smart India Hackathon 2026</a:t>
             </a:r>
             <a:endParaRPr kumimoji="0" lang="en-US" sz="1200" b="0" i="0" u="none" strike="noStrike" kern="1200" cap="none" spc="0" normalizeH="0" baseline="0" noProof="0" dirty="0">
               <a:ln>
@@ -10936,7 +11010,7 @@
           </a:fontRef>
         </p:style>
         <p:txBody>
-          <a:bodyPr wrap="none" lIns="18288" rIns="18288" rtlCol="0" anchor="ctr"/>
+          <a:bodyPr rtlCol="0" anchor="ctr" wrap="none" lIns="18288" rIns="18288"/>
           <a:lstStyle/>
           <a:p>
             <a:pPr algn="ctr">
@@ -11026,7 +11100,6 @@
           <a:lstStyle/>
           <a:p>
             <a:pPr algn="ctr"/>
-            <a:endParaRPr/>
           </a:p>
         </p:txBody>
       </p:sp>
@@ -11066,7 +11139,7 @@
           </a:fontRef>
         </p:style>
         <p:txBody>
-          <a:bodyPr wrap="none" lIns="73152" tIns="9144" rIns="73152" bIns="9144" rtlCol="0" anchor="ctr"/>
+          <a:bodyPr rtlCol="0" anchor="ctr" wrap="none" lIns="73152" rIns="73152" tIns="9144" bIns="9144"/>
           <a:lstStyle/>
           <a:p>
             <a:pPr algn="ctr">
@@ -11091,8 +11164,8 @@
         </p:nvSpPr>
         <p:spPr>
           <a:xfrm>
-            <a:off x="502920" y="1371600"/>
-            <a:ext cx="5349240" cy="3308598"/>
+            <a:off x="502920" y="1353312"/>
+            <a:ext cx="5349240" cy="4572000"/>
           </a:xfrm>
           <a:prstGeom prst="rect">
             <a:avLst/>
@@ -11100,7 +11173,7 @@
           <a:noFill/>
         </p:spPr>
         <p:txBody>
-          <a:bodyPr wrap="square" lIns="0" tIns="0" rIns="0" bIns="0">
+          <a:bodyPr wrap="square" lIns="0" rIns="0" tIns="0" bIns="0">
             <a:spAutoFit/>
           </a:bodyPr>
           <a:lstStyle/>
@@ -11111,73 +11184,55 @@
               </a:spcBef>
             </a:pPr>
             <a:r>
-              <a:rPr sz="1200" b="1" dirty="0">
+              <a:rPr sz="890" b="1">
                 <a:solidFill>
                   <a:srgbClr val="1A365D"/>
                 </a:solidFill>
                 <a:latin typeface="Arial"/>
               </a:rPr>
-              <a:t>• AICTE Approval Process Handbook (APH 2026-27)</a:t>
+              <a:t>- AICTE Approval Process Handbook (APH 2026-27)</a:t>
             </a:r>
           </a:p>
           <a:p>
             <a:pPr>
               <a:spcBef>
-                <a:spcPts val="200"/>
+                <a:spcPts val="150"/>
               </a:spcBef>
             </a:pPr>
             <a:r>
-              <a:rPr sz="1200" dirty="0">
+              <a:rPr sz="819">
                 <a:solidFill>
                   <a:srgbClr val="222222"/>
                 </a:solidFill>
                 <a:latin typeface="Arial"/>
               </a:rPr>
-              <a:t>Statutory norms for approved institutional intake capacity, supernumerary seat limits (TFW, EWS, Kashmiri Migrants), and </a:t>
-            </a:r>
-            <a:r>
-              <a:rPr sz="1200" dirty="0" err="1">
-                <a:solidFill>
-                  <a:srgbClr val="222222"/>
-                </a:solidFill>
-                <a:latin typeface="Arial"/>
-              </a:rPr>
-              <a:t>programme</a:t>
-            </a:r>
-            <a:r>
-              <a:rPr sz="1200" dirty="0">
-                <a:solidFill>
-                  <a:srgbClr val="222222"/>
-                </a:solidFill>
-                <a:latin typeface="Arial"/>
-              </a:rPr>
-              <a:t> approval guidelines.</a:t>
+              <a:t>Statutory norms for approved institutional intake capacity, supernumerary seat limits (TFW, EWS, Kashmiri Migrants), and programme approval guidelines.</a:t>
             </a:r>
           </a:p>
           <a:p>
             <a:pPr>
               <a:spcBef>
-                <a:spcPts val="800"/>
+                <a:spcPts val="700"/>
               </a:spcBef>
             </a:pPr>
             <a:r>
-              <a:rPr sz="1200" b="1" dirty="0">
+              <a:rPr sz="890" b="1">
                 <a:solidFill>
                   <a:srgbClr val="1A365D"/>
                 </a:solidFill>
                 <a:latin typeface="Arial"/>
               </a:rPr>
-              <a:t>• National Education Policy (NEP 2020) &amp; APAAR / ABC</a:t>
+              <a:t>- National Education Policy (NEP 2020) &amp; APAAR / ABC</a:t>
             </a:r>
           </a:p>
           <a:p>
             <a:pPr>
               <a:spcBef>
-                <a:spcPts val="200"/>
+                <a:spcPts val="150"/>
               </a:spcBef>
             </a:pPr>
             <a:r>
-              <a:rPr sz="1200" dirty="0">
+              <a:rPr sz="819">
                 <a:solidFill>
                   <a:srgbClr val="222222"/>
                 </a:solidFill>
@@ -11189,27 +11244,27 @@
           <a:p>
             <a:pPr>
               <a:spcBef>
-                <a:spcPts val="800"/>
+                <a:spcPts val="700"/>
               </a:spcBef>
             </a:pPr>
             <a:r>
-              <a:rPr sz="1200" b="1" dirty="0">
+              <a:rPr sz="890" b="1">
                 <a:solidFill>
                   <a:srgbClr val="1A365D"/>
                 </a:solidFill>
                 <a:latin typeface="Arial"/>
               </a:rPr>
-              <a:t>• Digital Personal Data Protection Act (DPDP Act 2023)</a:t>
+              <a:t>- Digital Personal Data Protection Act (DPDP Act 2023)</a:t>
             </a:r>
           </a:p>
           <a:p>
             <a:pPr>
               <a:spcBef>
-                <a:spcPts val="200"/>
+                <a:spcPts val="150"/>
               </a:spcBef>
             </a:pPr>
             <a:r>
-              <a:rPr sz="1200" dirty="0">
+              <a:rPr sz="819">
                 <a:solidFill>
                   <a:srgbClr val="222222"/>
                 </a:solidFill>
@@ -11221,59 +11276,59 @@
           <a:p>
             <a:pPr>
               <a:spcBef>
-                <a:spcPts val="800"/>
+                <a:spcPts val="700"/>
               </a:spcBef>
             </a:pPr>
             <a:r>
-              <a:rPr sz="1200" b="1" dirty="0">
+              <a:rPr sz="890" b="1">
                 <a:solidFill>
                   <a:srgbClr val="1A365D"/>
                 </a:solidFill>
                 <a:latin typeface="Arial"/>
               </a:rPr>
-              <a:t>• IETF RFC 8032: Ed25519 Cryptography</a:t>
+              <a:t>- IETF RFC 8032: Ed25519 Cryptography Specification</a:t>
             </a:r>
           </a:p>
           <a:p>
             <a:pPr>
               <a:spcBef>
-                <a:spcPts val="200"/>
+                <a:spcPts val="150"/>
               </a:spcBef>
             </a:pPr>
             <a:r>
-              <a:rPr sz="1200" dirty="0">
+              <a:rPr sz="819">
                 <a:solidFill>
                   <a:srgbClr val="222222"/>
                 </a:solidFill>
                 <a:latin typeface="Arial"/>
               </a:rPr>
-              <a:t>Specification for Edwards-Curve Digital Signature Algorithm (Curve25519) providing mathematical non-repudiation and instant receipt verification.</a:t>
+              <a:t>Edwards-Curve Digital Signature Algorithm (Curve25519) providing mathematical non-repudiation and instant receipt verification.</a:t>
             </a:r>
           </a:p>
           <a:p>
             <a:pPr>
               <a:spcBef>
-                <a:spcPts val="800"/>
+                <a:spcPts val="700"/>
               </a:spcBef>
             </a:pPr>
             <a:r>
-              <a:rPr sz="1200" b="1" dirty="0">
+              <a:rPr sz="890" b="1">
                 <a:solidFill>
                   <a:srgbClr val="1A365D"/>
                 </a:solidFill>
                 <a:latin typeface="Arial"/>
               </a:rPr>
-              <a:t>• NIST SP 800-107: Recommendation for Secure Hashing</a:t>
+              <a:t>- NIST SP 800-107: Recommendation for Secure Hashing</a:t>
             </a:r>
           </a:p>
           <a:p>
             <a:pPr>
               <a:spcBef>
-                <a:spcPts val="200"/>
+                <a:spcPts val="150"/>
               </a:spcBef>
             </a:pPr>
             <a:r>
-              <a:rPr sz="1200" dirty="0">
+              <a:rPr sz="819">
                 <a:solidFill>
                   <a:srgbClr val="222222"/>
                 </a:solidFill>
@@ -11293,7 +11348,7 @@
         <p:spPr>
           <a:xfrm>
             <a:off x="6172200" y="1115568"/>
-            <a:ext cx="5623560" cy="2377440"/>
+            <a:ext cx="5623560" cy="2331720"/>
           </a:xfrm>
           <a:prstGeom prst="roundRect">
             <a:avLst/>
@@ -11326,7 +11381,6 @@
           <a:lstStyle/>
           <a:p>
             <a:pPr algn="ctr"/>
-            <a:endParaRPr/>
           </a:p>
         </p:txBody>
       </p:sp>
@@ -11366,7 +11420,7 @@
           </a:fontRef>
         </p:style>
         <p:txBody>
-          <a:bodyPr wrap="none" lIns="73152" tIns="9144" rIns="73152" bIns="9144" rtlCol="0" anchor="ctr"/>
+          <a:bodyPr rtlCol="0" anchor="ctr" wrap="none" lIns="73152" rIns="73152" tIns="9144" bIns="9144"/>
           <a:lstStyle/>
           <a:p>
             <a:pPr algn="ctr">
@@ -11392,7 +11446,7 @@
         <p:spPr>
           <a:xfrm>
             <a:off x="6309360" y="1353312"/>
-            <a:ext cx="5349240" cy="1815882"/>
+            <a:ext cx="5349240" cy="2011680"/>
           </a:xfrm>
           <a:prstGeom prst="rect">
             <a:avLst/>
@@ -11400,7 +11454,7 @@
           <a:noFill/>
         </p:spPr>
         <p:txBody>
-          <a:bodyPr wrap="square" lIns="0" tIns="0" rIns="0" bIns="0">
+          <a:bodyPr wrap="square" lIns="0" rIns="0" tIns="0" bIns="0">
             <a:spAutoFit/>
           </a:bodyPr>
           <a:lstStyle/>
@@ -11411,22 +11465,22 @@
               </a:spcBef>
             </a:pPr>
             <a:r>
-              <a:rPr sz="1200" b="1" dirty="0">
+              <a:rPr sz="850" b="1">
                 <a:solidFill>
                   <a:srgbClr val="112266"/>
                 </a:solidFill>
                 <a:latin typeface="Arial"/>
               </a:rPr>
-              <a:t>• Validation Scope: </a:t>
-            </a:r>
-            <a:r>
-              <a:rPr sz="1200" dirty="0">
+              <a:t>- Validation Scope: </a:t>
+            </a:r>
+            <a:r>
+              <a:rPr sz="800">
                 <a:solidFill>
                   <a:srgbClr val="222222"/>
                 </a:solidFill>
                 <a:latin typeface="Arial"/>
               </a:rPr>
-              <a:t>Generic uploads check syntax only. PRAMAAN performs 3-way reconciliation (Declarations × Uploads × Sanctioned Capacity).</a:t>
+              <a:t>Generic uploads check syntax only. PRAMAAN performs 3-way reconciliation (Declarations x Uploads x Sanctioned Capacity).</a:t>
             </a:r>
           </a:p>
           <a:p>
@@ -11436,22 +11490,22 @@
               </a:spcBef>
             </a:pPr>
             <a:r>
-              <a:rPr sz="1200" b="1" dirty="0">
+              <a:rPr sz="850" b="1">
                 <a:solidFill>
                   <a:srgbClr val="112266"/>
                 </a:solidFill>
                 <a:latin typeface="Arial"/>
               </a:rPr>
-              <a:t>• Reference Data: </a:t>
-            </a:r>
-            <a:r>
-              <a:rPr sz="1200" dirty="0">
+              <a:t>- Reference Data: </a:t>
+            </a:r>
+            <a:r>
+              <a:rPr sz="800">
                 <a:solidFill>
                   <a:srgbClr val="222222"/>
                 </a:solidFill>
                 <a:latin typeface="Arial"/>
               </a:rPr>
-              <a:t>Traditional workflows rely on static assumptions. PRAMAAN integrates dynamic database references with revalidation.</a:t>
+              <a:t>Traditional workflows rely on static assumptions. PRAMAAN integrates dynamic database references with live revalidation.</a:t>
             </a:r>
           </a:p>
           <a:p>
@@ -11461,16 +11515,16 @@
               </a:spcBef>
             </a:pPr>
             <a:r>
-              <a:rPr sz="1200" b="1" dirty="0">
+              <a:rPr sz="850" b="1">
                 <a:solidFill>
                   <a:srgbClr val="112266"/>
                 </a:solidFill>
                 <a:latin typeface="Arial"/>
               </a:rPr>
-              <a:t>• Finding Resolution: </a:t>
-            </a:r>
-            <a:r>
-              <a:rPr sz="1200" dirty="0">
+              <a:t>- Finding Resolution: </a:t>
+            </a:r>
+            <a:r>
+              <a:rPr sz="800">
                 <a:solidFill>
                   <a:srgbClr val="222222"/>
                 </a:solidFill>
@@ -11486,16 +11540,16 @@
               </a:spcBef>
             </a:pPr>
             <a:r>
-              <a:rPr sz="1200" b="1" dirty="0">
+              <a:rPr sz="850" b="1">
                 <a:solidFill>
                   <a:srgbClr val="112266"/>
                 </a:solidFill>
                 <a:latin typeface="Arial"/>
               </a:rPr>
-              <a:t>• Verification Output: </a:t>
-            </a:r>
-            <a:r>
-              <a:rPr sz="1200" dirty="0">
+              <a:t>- Verification Output: </a:t>
+            </a:r>
+            <a:r>
+              <a:rPr sz="800">
                 <a:solidFill>
                   <a:srgbClr val="222222"/>
                 </a:solidFill>
@@ -11548,7 +11602,6 @@
           <a:lstStyle/>
           <a:p>
             <a:pPr algn="ctr"/>
-            <a:endParaRPr/>
           </a:p>
         </p:txBody>
       </p:sp>
@@ -11588,7 +11641,7 @@
           </a:fontRef>
         </p:style>
         <p:txBody>
-          <a:bodyPr wrap="none" lIns="73152" tIns="9144" rIns="73152" bIns="9144" rtlCol="0" anchor="ctr"/>
+          <a:bodyPr rtlCol="0" anchor="ctr" wrap="none" lIns="73152" rIns="73152" tIns="9144" bIns="9144"/>
           <a:lstStyle/>
           <a:p>
             <a:pPr algn="ctr">
@@ -11600,7 +11653,7 @@
               </a:defRPr>
             </a:pPr>
             <a:r>
-              <a:t>VERIFIED PROJECT RESOURCES &amp; ENVIRONMENT STATUS</a:t>
+              <a:t>VERIFIED PROJECT RESOURCES &amp; LIVE DEPLOYMENT STATUS</a:t>
             </a:r>
           </a:p>
         </p:txBody>
@@ -11622,7 +11675,7 @@
           <a:noFill/>
         </p:spPr>
         <p:txBody>
-          <a:bodyPr wrap="square" lIns="0" tIns="0" rIns="0" bIns="0">
+          <a:bodyPr wrap="square" lIns="0" rIns="0" tIns="0" bIns="0">
             <a:spAutoFit/>
           </a:bodyPr>
           <a:lstStyle/>
@@ -11633,23 +11686,23 @@
               </a:spcBef>
             </a:pPr>
             <a:r>
-              <a:rPr sz="1100" b="1" dirty="0">
+              <a:rPr sz="850" b="1">
                 <a:solidFill>
                   <a:srgbClr val="008C6E"/>
                 </a:solidFill>
                 <a:latin typeface="Arial"/>
               </a:rPr>
-              <a:t>✓ Open-Source GitHub Repository: </a:t>
-            </a:r>
-            <a:r>
-              <a:rPr sz="1100" dirty="0">
+              <a:t>- Live Web Platform: </a:t>
+            </a:r>
+            <a:r>
+              <a:rPr sz="800">
                 <a:solidFill>
                   <a:srgbClr val="222222"/>
                 </a:solidFill>
                 <a:latin typeface="Arial"/>
               </a:rPr>
-              <a:t>https://github.com/naveeshpcbin/APAAR-ID-BASED-SYSTEM
-(Complete source code, 20 application models, Alembic migrations, test suites)</a:t>
+              <a:t>https://brainforge.info | https://pramaan.brainforge.info
+(Production Vercel Edge with custom domain &amp; Let's Encrypt SSL)</a:t>
             </a:r>
           </a:p>
           <a:p>
@@ -11659,49 +11712,23 @@
               </a:spcBef>
             </a:pPr>
             <a:r>
-              <a:rPr sz="1100" b="1" dirty="0">
+              <a:rPr sz="850" b="1">
                 <a:solidFill>
                   <a:srgbClr val="008C6E"/>
                 </a:solidFill>
                 <a:latin typeface="Arial"/>
               </a:rPr>
-              <a:t>✓ Interactive Backend API Docs: </a:t>
-            </a:r>
-            <a:r>
-              <a:rPr sz="1100" dirty="0" err="1">
+              <a:t>- Interactive Backend API &amp; Docs: </a:t>
+            </a:r>
+            <a:r>
+              <a:rPr sz="800">
                 <a:solidFill>
                   <a:srgbClr val="222222"/>
                 </a:solidFill>
                 <a:latin typeface="Arial"/>
               </a:rPr>
-              <a:t>FastAPI</a:t>
-            </a:r>
-            <a:r>
-              <a:rPr sz="1100" dirty="0">
-                <a:solidFill>
-                  <a:srgbClr val="222222"/>
-                </a:solidFill>
-                <a:latin typeface="Arial"/>
-              </a:rPr>
-              <a:t> </a:t>
-            </a:r>
-            <a:r>
-              <a:rPr sz="1100" dirty="0" err="1">
-                <a:solidFill>
-                  <a:srgbClr val="222222"/>
-                </a:solidFill>
-                <a:latin typeface="Arial"/>
-              </a:rPr>
-              <a:t>OpenAPI</a:t>
-            </a:r>
-            <a:r>
-              <a:rPr sz="1100" dirty="0">
-                <a:solidFill>
-                  <a:srgbClr val="222222"/>
-                </a:solidFill>
-                <a:latin typeface="Arial"/>
-              </a:rPr>
-              <a:t> 3.1 documentation available at `/docs` (73 endpoints registered across 67 paths).</a:t>
+              <a:t>https://apaar-id-based-system.onrender.com/docs
+(FastAPI OpenAPI 3.1 live documentation with 73 endpoints across 67 paths)</a:t>
             </a:r>
           </a:p>
           <a:p>
@@ -11711,40 +11738,23 @@
               </a:spcBef>
             </a:pPr>
             <a:r>
-              <a:rPr sz="1100" b="1" dirty="0">
+              <a:rPr sz="850" b="1">
                 <a:solidFill>
                   <a:srgbClr val="008C6E"/>
                 </a:solidFill>
                 <a:latin typeface="Arial"/>
               </a:rPr>
-              <a:t>✓ Automated Test Verification: </a:t>
-            </a:r>
-            <a:r>
-              <a:rPr sz="1100" dirty="0">
+              <a:t>- Open-Source GitHub Repository: </a:t>
+            </a:r>
+            <a:r>
+              <a:rPr sz="800">
                 <a:solidFill>
                   <a:srgbClr val="222222"/>
                 </a:solidFill>
                 <a:latin typeface="Arial"/>
               </a:rPr>
-              <a:t>64/64 </a:t>
-            </a:r>
-            <a:r>
-              <a:rPr sz="1100" dirty="0" err="1">
-                <a:solidFill>
-                  <a:srgbClr val="222222"/>
-                </a:solidFill>
-                <a:latin typeface="Arial"/>
-              </a:rPr>
-              <a:t>pytest</a:t>
-            </a:r>
-            <a:r>
-              <a:rPr sz="1100" dirty="0">
-                <a:solidFill>
-                  <a:srgbClr val="222222"/>
-                </a:solidFill>
-                <a:latin typeface="Arial"/>
-              </a:rPr>
-              <a:t> automated tests passing locally across 14 test suites covering all core workflows.</a:t>
+              <a:t>https://github.com/naveeshpcbin/APAAR-ID-BASED-SYSTEM
+(Complete source code, 20 application models, Alembic migrations, test suites)</a:t>
             </a:r>
           </a:p>
           <a:p>
@@ -11754,41 +11764,22 @@
               </a:spcBef>
             </a:pPr>
             <a:r>
-              <a:rPr sz="1100" b="1" dirty="0">
+              <a:rPr sz="850" b="1">
                 <a:solidFill>
                   <a:srgbClr val="008C6E"/>
                 </a:solidFill>
                 <a:latin typeface="Arial"/>
               </a:rPr>
-              <a:t>✓ System Integration Status: </a:t>
-            </a:r>
-            <a:r>
-              <a:rPr sz="1100" dirty="0">
+              <a:t>- Verified Test Suite: </a:t>
+            </a:r>
+            <a:r>
+              <a:rPr sz="800">
                 <a:solidFill>
                   <a:srgbClr val="222222"/>
                 </a:solidFill>
                 <a:latin typeface="Arial"/>
               </a:rPr>
-              <a:t>• External APAAR / </a:t>
-            </a:r>
-            <a:r>
-              <a:rPr sz="1100" dirty="0" err="1">
-                <a:solidFill>
-                  <a:srgbClr val="222222"/>
-                </a:solidFill>
-                <a:latin typeface="Arial"/>
-              </a:rPr>
-              <a:t>DigiLocker</a:t>
-            </a:r>
-            <a:r>
-              <a:rPr sz="1100" dirty="0">
-                <a:solidFill>
-                  <a:srgbClr val="222222"/>
-                </a:solidFill>
-                <a:latin typeface="Arial"/>
-              </a:rPr>
-              <a:t> / ABC API: SIMULATED (Synthetic reference dataset).
-• Cloud Render Deployment: PENDING RESOLUTION (Host DNS configuration in Render container).</a:t>
+              <a:t>66/66 pytest unit tests passing + 20/20 Phase F E2E checks + 10/10 live cloud integration tests verified.</a:t>
             </a:r>
           </a:p>
         </p:txBody>
@@ -11797,6 +11788,859 @@
     <p:extLst>
       <p:ext uri="{BB962C8B-B14F-4D97-AF65-F5344CB8AC3E}">
         <p14:creationId xmlns:p14="http://schemas.microsoft.com/office/powerpoint/2010/main" val="3916788613"/>
+      </p:ext>
+    </p:extLst>
+  </p:cSld>
+  <p:clrMapOvr>
+    <a:masterClrMapping/>
+  </p:clrMapOvr>
+</p:sld>
+</file>
+
+<file path=ppt/slides/slide7.xml><?xml version="1.0" encoding="utf-8"?>
+<p:sld xmlns:a="http://schemas.openxmlformats.org/drawingml/2006/main" xmlns:r="http://schemas.openxmlformats.org/officeDocument/2006/relationships" xmlns:p="http://schemas.openxmlformats.org/presentationml/2006/main">
+  <p:cSld>
+    <p:spTree>
+      <p:nvGrpSpPr>
+        <p:cNvPr id="1" name=""/>
+        <p:cNvGrpSpPr/>
+        <p:nvPr/>
+      </p:nvGrpSpPr>
+      <p:grpSpPr>
+        <a:xfrm>
+          <a:off x="0" y="0"/>
+          <a:ext cx="0" cy="0"/>
+          <a:chOff x="0" y="0"/>
+          <a:chExt cx="0" cy="0"/>
+        </a:xfrm>
+      </p:grpSpPr>
+      <p:sp>
+        <p:nvSpPr>
+          <p:cNvPr id="10" name="Rectangle 9">
+            <a:extLst>
+              <a:ext uri="{FF2B5EF4-FFF2-40B4-BE49-F238E27FC236}">
+                <a16:creationId xmlns:a16="http://schemas.microsoft.com/office/drawing/2014/main" id="{AD4F69D3-EEB0-4C4C-9434-B9960FB5854C}"/>
+              </a:ext>
+            </a:extLst>
+          </p:cNvPr>
+          <p:cNvSpPr>
+            <a:spLocks noChangeArrowheads="1"/>
+          </p:cNvSpPr>
+          <p:nvPr/>
+        </p:nvSpPr>
+        <p:spPr bwMode="auto">
+          <a:xfrm>
+            <a:off x="0" y="6354762"/>
+            <a:ext cx="12191999" cy="503238"/>
+          </a:xfrm>
+          <a:prstGeom prst="rect">
+            <a:avLst/>
+          </a:prstGeom>
+          <a:solidFill>
+            <a:srgbClr val="0070C0"/>
+          </a:solidFill>
+          <a:ln w="9525">
+            <a:noFill/>
+            <a:miter lim="800000"/>
+            <a:headEnd/>
+            <a:tailEnd/>
+          </a:ln>
+          <a:effectLst>
+            <a:outerShdw dist="23000" dir="5400000" rotWithShape="0">
+              <a:srgbClr val="808080">
+                <a:alpha val="34999"/>
+              </a:srgbClr>
+            </a:outerShdw>
+          </a:effectLst>
+        </p:spPr>
+        <p:txBody>
+          <a:bodyPr anchor="ctr"/>
+          <a:lstStyle/>
+          <a:p>
+            <a:pPr marL="0" marR="0" lvl="0" indent="0" algn="ctr" defTabSz="457200" rtl="0" eaLnBrk="1" fontAlgn="auto" latinLnBrk="0" hangingPunct="1">
+              <a:lnSpc>
+                <a:spcPct val="100000"/>
+              </a:lnSpc>
+              <a:spcBef>
+                <a:spcPts val="0"/>
+              </a:spcBef>
+              <a:spcAft>
+                <a:spcPts val="0"/>
+              </a:spcAft>
+              <a:buClrTx/>
+              <a:buSzTx/>
+              <a:buFontTx/>
+              <a:buNone/>
+              <a:tabLst/>
+              <a:defRPr/>
+            </a:pPr>
+            <a:endParaRPr kumimoji="0" lang="en-US" sz="1800" b="0" i="0" u="none" strike="noStrike" kern="1200" cap="none" spc="0" normalizeH="0" baseline="0" noProof="0" dirty="0">
+              <a:ln>
+                <a:noFill/>
+              </a:ln>
+              <a:solidFill>
+                <a:srgbClr val="C0504D">
+                  <a:lumMod val="75000"/>
+                </a:srgbClr>
+              </a:solidFill>
+              <a:effectLst/>
+              <a:uLnTx/>
+              <a:uFillTx/>
+              <a:latin typeface="Calibri"/>
+              <a:ea typeface="ＭＳ Ｐゴシック" pitchFamily="1" charset="-128"/>
+              <a:cs typeface="+mn-cs"/>
+            </a:endParaRPr>
+          </a:p>
+        </p:txBody>
+      </p:sp>
+      <p:sp>
+        <p:nvSpPr>
+          <p:cNvPr id="6" name="Slide Number Placeholder 5"/>
+          <p:cNvSpPr>
+            <a:spLocks noGrp="1"/>
+          </p:cNvSpPr>
+          <p:nvPr>
+            <p:ph type="sldNum" sz="quarter" idx="12"/>
+          </p:nvPr>
+        </p:nvSpPr>
+        <p:spPr/>
+        <p:txBody>
+          <a:bodyPr/>
+          <a:lstStyle/>
+          <a:p>
+            <a:pPr marL="0" marR="0" lvl="0" indent="0" algn="r" defTabSz="457200" rtl="0" eaLnBrk="1" fontAlgn="base" latinLnBrk="0" hangingPunct="1">
+              <a:lnSpc>
+                <a:spcPct val="100000"/>
+              </a:lnSpc>
+              <a:spcBef>
+                <a:spcPct val="0"/>
+              </a:spcBef>
+              <a:spcAft>
+                <a:spcPct val="0"/>
+              </a:spcAft>
+              <a:buClrTx/>
+              <a:buSzTx/>
+              <a:buFontTx/>
+              <a:buNone/>
+              <a:tabLst/>
+              <a:defRPr/>
+            </a:pPr>
+            <a:fld id="{677C3CE7-23F7-4828-823C-E0205DF2CF97}" type="slidenum">
+              <a:rPr kumimoji="0" lang="en-US" sz="1200" b="1" i="0" u="none" strike="noStrike" kern="1200" cap="none" spc="0" normalizeH="0" baseline="0" noProof="0">
+                <a:ln>
+                  <a:noFill/>
+                </a:ln>
+                <a:solidFill>
+                  <a:prstClr val="white"/>
+                </a:solidFill>
+                <a:effectLst/>
+                <a:uLnTx/>
+                <a:uFillTx/>
+                <a:latin typeface="TradeGothic" pitchFamily="1" charset="0"/>
+                <a:ea typeface="ＭＳ Ｐゴシック" pitchFamily="1" charset="-128"/>
+                <a:cs typeface="+mn-cs"/>
+              </a:rPr>
+              <a:pPr marL="0" marR="0" lvl="0" indent="0" algn="r" defTabSz="457200" rtl="0" eaLnBrk="1" fontAlgn="base" latinLnBrk="0" hangingPunct="1">
+                <a:lnSpc>
+                  <a:spcPct val="100000"/>
+                </a:lnSpc>
+                <a:spcBef>
+                  <a:spcPct val="0"/>
+                </a:spcBef>
+                <a:spcAft>
+                  <a:spcPct val="0"/>
+                </a:spcAft>
+                <a:buClrTx/>
+                <a:buSzTx/>
+                <a:buFontTx/>
+                <a:buNone/>
+                <a:tabLst/>
+                <a:defRPr/>
+              </a:pPr>
+              <a:t>7</a:t>
+            </a:fld>
+            <a:endParaRPr kumimoji="0" lang="en-US" sz="1200" b="1" i="0" u="none" strike="noStrike" kern="1200" cap="none" spc="0" normalizeH="0" baseline="0" noProof="0" dirty="0">
+              <a:ln>
+                <a:noFill/>
+              </a:ln>
+              <a:solidFill>
+                <a:prstClr val="white"/>
+              </a:solidFill>
+              <a:effectLst/>
+              <a:uLnTx/>
+              <a:uFillTx/>
+              <a:latin typeface="TradeGothic" pitchFamily="1" charset="0"/>
+              <a:ea typeface="ＭＳ Ｐゴシック" pitchFamily="1" charset="-128"/>
+              <a:cs typeface="+mn-cs"/>
+            </a:endParaRPr>
+          </a:p>
+        </p:txBody>
+      </p:sp>
+      <p:sp>
+        <p:nvSpPr>
+          <p:cNvPr id="7" name="Footer Placeholder 6"/>
+          <p:cNvSpPr>
+            <a:spLocks noGrp="1"/>
+          </p:cNvSpPr>
+          <p:nvPr>
+            <p:ph type="ftr" sz="quarter" idx="11"/>
+          </p:nvPr>
+        </p:nvSpPr>
+        <p:spPr>
+          <a:xfrm>
+            <a:off x="4648200" y="6356353"/>
+            <a:ext cx="3204000" cy="365125"/>
+          </a:xfrm>
+        </p:spPr>
+        <p:txBody>
+          <a:bodyPr/>
+          <a:lstStyle/>
+          <a:p>
+            <a:pPr marL="0" marR="0" lvl="0" indent="0" algn="ctr" defTabSz="457200" rtl="0" eaLnBrk="1" fontAlgn="auto" latinLnBrk="0" hangingPunct="1">
+              <a:lnSpc>
+                <a:spcPct val="100000"/>
+              </a:lnSpc>
+              <a:spcBef>
+                <a:spcPts val="0"/>
+              </a:spcBef>
+              <a:spcAft>
+                <a:spcPts val="0"/>
+              </a:spcAft>
+              <a:buClrTx/>
+              <a:buSzTx/>
+              <a:buFontTx/>
+              <a:buNone/>
+              <a:tabLst/>
+              <a:defRPr/>
+            </a:pPr>
+            <a:r>
+              <a:rPr kumimoji="0" lang="en-US" sz="1200" b="0" i="0" u="none" strike="noStrike" kern="1200" cap="none" spc="0" normalizeH="0" baseline="0" noProof="0">
+                <a:ln>
+                  <a:noFill/>
+                </a:ln>
+                <a:solidFill>
+                  <a:prstClr val="white"/>
+                </a:solidFill>
+                <a:effectLst/>
+                <a:uLnTx/>
+                <a:uFillTx/>
+                <a:latin typeface="TradeGothic"/>
+                <a:ea typeface="+mn-ea"/>
+                <a:cs typeface="+mn-cs"/>
+              </a:rPr>
+              <a:t>@SIH Idea submission- Template</a:t>
+            </a:r>
+            <a:endParaRPr kumimoji="0" lang="en-US" sz="1200" b="0" i="0" u="none" strike="noStrike" kern="1200" cap="none" spc="0" normalizeH="0" baseline="0" noProof="0" dirty="0">
+              <a:ln>
+                <a:noFill/>
+              </a:ln>
+              <a:solidFill>
+                <a:prstClr val="white"/>
+              </a:solidFill>
+              <a:effectLst/>
+              <a:uLnTx/>
+              <a:uFillTx/>
+              <a:latin typeface="TradeGothic"/>
+              <a:ea typeface="+mn-ea"/>
+              <a:cs typeface="+mn-cs"/>
+            </a:endParaRPr>
+          </a:p>
+        </p:txBody>
+      </p:sp>
+      <p:sp>
+        <p:nvSpPr>
+          <p:cNvPr id="3" name="Round Diagonal Corner Rectangle 2"/>
+          <p:cNvSpPr/>
+          <p:nvPr/>
+        </p:nvSpPr>
+        <p:spPr>
+          <a:xfrm>
+            <a:off x="0" y="1791032"/>
+            <a:ext cx="12192000" cy="4319200"/>
+          </a:xfrm>
+          <a:prstGeom prst="round2DiagRect">
+            <a:avLst/>
+          </a:prstGeom>
+          <a:solidFill>
+            <a:schemeClr val="accent1">
+              <a:lumMod val="20000"/>
+              <a:lumOff val="80000"/>
+            </a:schemeClr>
+          </a:solidFill>
+          <a:ln w="38100"/>
+        </p:spPr>
+        <p:style>
+          <a:lnRef idx="1">
+            <a:schemeClr val="accent1"/>
+          </a:lnRef>
+          <a:fillRef idx="3">
+            <a:schemeClr val="accent1"/>
+          </a:fillRef>
+          <a:effectRef idx="2">
+            <a:schemeClr val="accent1"/>
+          </a:effectRef>
+          <a:fontRef idx="minor">
+            <a:schemeClr val="lt1"/>
+          </a:fontRef>
+        </p:style>
+        <p:txBody>
+          <a:bodyPr rtlCol="0" anchor="ctr"/>
+          <a:lstStyle/>
+          <a:p>
+            <a:pPr algn="ctr"/>
+            <a:endParaRPr lang="en-IN"/>
+          </a:p>
+        </p:txBody>
+      </p:sp>
+      <p:sp>
+        <p:nvSpPr>
+          <p:cNvPr id="12" name="Google Shape;100;p3"/>
+          <p:cNvSpPr txBox="1"/>
+          <p:nvPr/>
+        </p:nvSpPr>
+        <p:spPr>
+          <a:xfrm>
+            <a:off x="367832" y="1915454"/>
+            <a:ext cx="11764736" cy="4070356"/>
+          </a:xfrm>
+          <a:prstGeom prst="rect">
+            <a:avLst/>
+          </a:prstGeom>
+          <a:noFill/>
+          <a:ln>
+            <a:noFill/>
+          </a:ln>
+        </p:spPr>
+        <p:txBody>
+          <a:bodyPr spcFirstLastPara="1" wrap="square" lIns="91425" tIns="45700" rIns="91425" bIns="45700" anchor="t" anchorCtr="0">
+            <a:noAutofit/>
+          </a:bodyPr>
+          <a:lstStyle/>
+          <a:p>
+            <a:pPr marL="514350" marR="0" lvl="0" indent="-514350" algn="just" rtl="0">
+              <a:lnSpc>
+                <a:spcPct val="90000"/>
+              </a:lnSpc>
+              <a:spcBef>
+                <a:spcPts val="0"/>
+              </a:spcBef>
+              <a:spcAft>
+                <a:spcPts val="0"/>
+              </a:spcAft>
+              <a:buClr>
+                <a:schemeClr val="dk1"/>
+              </a:buClr>
+              <a:buSzPct val="100000"/>
+              <a:buFont typeface="Calibri"/>
+              <a:buAutoNum type="arabicPeriod"/>
+            </a:pPr>
+            <a:r>
+              <a:rPr lang="en-US" b="1" i="0" u="none" strike="noStrike" cap="none" dirty="0">
+                <a:solidFill>
+                  <a:schemeClr val="dk1"/>
+                </a:solidFill>
+                <a:latin typeface="Arial" panose="020B0604020202020204" pitchFamily="34" charset="0"/>
+                <a:ea typeface="Calibri"/>
+                <a:cs typeface="Arial" panose="020B0604020202020204" pitchFamily="34" charset="0"/>
+                <a:sym typeface="Calibri"/>
+              </a:rPr>
+              <a:t>Kindly keep the maximum slides limit up to six </a:t>
+            </a:r>
+            <a:r>
+              <a:rPr lang="en-US" b="1" i="0" u="none" strike="noStrike" cap="none" dirty="0">
+                <a:solidFill>
+                  <a:srgbClr val="C00000"/>
+                </a:solidFill>
+                <a:latin typeface="Arial" panose="020B0604020202020204" pitchFamily="34" charset="0"/>
+                <a:ea typeface="Calibri"/>
+                <a:cs typeface="Arial" panose="020B0604020202020204" pitchFamily="34" charset="0"/>
+                <a:sym typeface="Calibri"/>
+              </a:rPr>
+              <a:t>(6). </a:t>
+            </a:r>
+            <a:r>
+              <a:rPr lang="en-US" b="1" i="0" u="none" strike="noStrike" cap="none" dirty="0">
+                <a:solidFill>
+                  <a:schemeClr val="dk1"/>
+                </a:solidFill>
+                <a:latin typeface="Arial" panose="020B0604020202020204" pitchFamily="34" charset="0"/>
+                <a:ea typeface="Calibri"/>
+                <a:cs typeface="Arial" panose="020B0604020202020204" pitchFamily="34" charset="0"/>
+                <a:sym typeface="Calibri"/>
+              </a:rPr>
+              <a:t>( Including the </a:t>
+            </a:r>
+            <a:r>
+              <a:rPr lang="en-US" b="1" i="0" u="none" strike="noStrike" cap="none">
+                <a:solidFill>
+                  <a:schemeClr val="dk1"/>
+                </a:solidFill>
+                <a:latin typeface="Arial" panose="020B0604020202020204" pitchFamily="34" charset="0"/>
+                <a:ea typeface="Calibri"/>
+                <a:cs typeface="Arial" panose="020B0604020202020204" pitchFamily="34" charset="0"/>
+                <a:sym typeface="Calibri"/>
+              </a:rPr>
+              <a:t>title slide) </a:t>
+            </a:r>
+            <a:endParaRPr b="1" dirty="0">
+              <a:latin typeface="Arial" panose="020B0604020202020204" pitchFamily="34" charset="0"/>
+              <a:cs typeface="Arial" panose="020B0604020202020204" pitchFamily="34" charset="0"/>
+            </a:endParaRPr>
+          </a:p>
+          <a:p>
+            <a:pPr marL="514350" marR="0" lvl="0" indent="-514350" algn="just" rtl="0">
+              <a:lnSpc>
+                <a:spcPct val="90000"/>
+              </a:lnSpc>
+              <a:spcBef>
+                <a:spcPts val="1000"/>
+              </a:spcBef>
+              <a:spcAft>
+                <a:spcPts val="0"/>
+              </a:spcAft>
+              <a:buClr>
+                <a:schemeClr val="dk1"/>
+              </a:buClr>
+              <a:buSzPct val="100000"/>
+              <a:buFont typeface="Calibri"/>
+              <a:buAutoNum type="arabicPeriod"/>
+            </a:pPr>
+            <a:r>
+              <a:rPr lang="en-US" b="1" i="0" u="none" strike="noStrike" cap="none" dirty="0">
+                <a:solidFill>
+                  <a:schemeClr val="dk1"/>
+                </a:solidFill>
+                <a:latin typeface="Arial" panose="020B0604020202020204" pitchFamily="34" charset="0"/>
+                <a:ea typeface="Calibri"/>
+                <a:cs typeface="Arial" panose="020B0604020202020204" pitchFamily="34" charset="0"/>
+                <a:sym typeface="Calibri"/>
+              </a:rPr>
+              <a:t>Try to avoid paragraphs and post your idea in points /diagrams / Infographics /pictures </a:t>
+            </a:r>
+            <a:endParaRPr b="1" dirty="0">
+              <a:latin typeface="Arial" panose="020B0604020202020204" pitchFamily="34" charset="0"/>
+              <a:cs typeface="Arial" panose="020B0604020202020204" pitchFamily="34" charset="0"/>
+            </a:endParaRPr>
+          </a:p>
+          <a:p>
+            <a:pPr marL="514350" marR="0" lvl="0" indent="-514350" algn="just" rtl="0">
+              <a:lnSpc>
+                <a:spcPct val="90000"/>
+              </a:lnSpc>
+              <a:spcBef>
+                <a:spcPts val="1000"/>
+              </a:spcBef>
+              <a:spcAft>
+                <a:spcPts val="0"/>
+              </a:spcAft>
+              <a:buClr>
+                <a:schemeClr val="dk1"/>
+              </a:buClr>
+              <a:buSzPct val="100000"/>
+              <a:buFont typeface="Calibri"/>
+              <a:buAutoNum type="arabicPeriod"/>
+            </a:pPr>
+            <a:r>
+              <a:rPr lang="en-US" b="1" i="0" u="none" strike="noStrike" cap="none" dirty="0">
+                <a:solidFill>
+                  <a:schemeClr val="dk1"/>
+                </a:solidFill>
+                <a:latin typeface="Arial" panose="020B0604020202020204" pitchFamily="34" charset="0"/>
+                <a:ea typeface="Calibri"/>
+                <a:cs typeface="Arial" panose="020B0604020202020204" pitchFamily="34" charset="0"/>
+                <a:sym typeface="Calibri"/>
+              </a:rPr>
+              <a:t>Keep your explanation precise and easy to understand</a:t>
+            </a:r>
+            <a:endParaRPr b="1" dirty="0">
+              <a:latin typeface="Arial" panose="020B0604020202020204" pitchFamily="34" charset="0"/>
+              <a:cs typeface="Arial" panose="020B0604020202020204" pitchFamily="34" charset="0"/>
+            </a:endParaRPr>
+          </a:p>
+          <a:p>
+            <a:pPr marL="514350" marR="0" lvl="0" indent="-514350" algn="just" rtl="0">
+              <a:lnSpc>
+                <a:spcPct val="90000"/>
+              </a:lnSpc>
+              <a:spcBef>
+                <a:spcPts val="1000"/>
+              </a:spcBef>
+              <a:spcAft>
+                <a:spcPts val="0"/>
+              </a:spcAft>
+              <a:buClr>
+                <a:schemeClr val="dk1"/>
+              </a:buClr>
+              <a:buSzPct val="100000"/>
+              <a:buFont typeface="Calibri"/>
+              <a:buAutoNum type="arabicPeriod"/>
+            </a:pPr>
+            <a:r>
+              <a:rPr lang="en-US" b="1" i="0" u="none" strike="noStrike" cap="none" dirty="0">
+                <a:solidFill>
+                  <a:schemeClr val="dk1"/>
+                </a:solidFill>
+                <a:latin typeface="Arial" panose="020B0604020202020204" pitchFamily="34" charset="0"/>
+                <a:ea typeface="Calibri"/>
+                <a:cs typeface="Arial" panose="020B0604020202020204" pitchFamily="34" charset="0"/>
+                <a:sym typeface="Calibri"/>
+              </a:rPr>
+              <a:t>Idea should be unique and novel. </a:t>
+            </a:r>
+            <a:endParaRPr b="1" dirty="0">
+              <a:latin typeface="Arial" panose="020B0604020202020204" pitchFamily="34" charset="0"/>
+              <a:cs typeface="Arial" panose="020B0604020202020204" pitchFamily="34" charset="0"/>
+            </a:endParaRPr>
+          </a:p>
+          <a:p>
+            <a:pPr marL="514350" marR="0" lvl="0" indent="-514350" algn="just" rtl="0">
+              <a:lnSpc>
+                <a:spcPct val="90000"/>
+              </a:lnSpc>
+              <a:spcBef>
+                <a:spcPts val="1000"/>
+              </a:spcBef>
+              <a:spcAft>
+                <a:spcPts val="0"/>
+              </a:spcAft>
+              <a:buClr>
+                <a:schemeClr val="dk1"/>
+              </a:buClr>
+              <a:buSzPct val="100000"/>
+              <a:buFont typeface="Calibri"/>
+              <a:buAutoNum type="arabicPeriod"/>
+            </a:pPr>
+            <a:r>
+              <a:rPr lang="en-US" b="1" i="0" u="none" strike="noStrike" cap="none" dirty="0">
+                <a:solidFill>
+                  <a:schemeClr val="dk1"/>
+                </a:solidFill>
+                <a:latin typeface="Arial" panose="020B0604020202020204" pitchFamily="34" charset="0"/>
+                <a:ea typeface="Calibri"/>
+                <a:cs typeface="Arial" panose="020B0604020202020204" pitchFamily="34" charset="0"/>
+                <a:sym typeface="Calibri"/>
+              </a:rPr>
+              <a:t>You can only use provided </a:t>
+            </a:r>
+            <a:r>
+              <a:rPr lang="en-US" b="1" dirty="0">
+                <a:solidFill>
+                  <a:schemeClr val="dk1"/>
+                </a:solidFill>
+                <a:latin typeface="Arial" panose="020B0604020202020204" pitchFamily="34" charset="0"/>
+                <a:ea typeface="Calibri"/>
+                <a:cs typeface="Arial" panose="020B0604020202020204" pitchFamily="34" charset="0"/>
+                <a:sym typeface="Calibri"/>
+              </a:rPr>
+              <a:t>template</a:t>
+            </a:r>
+            <a:r>
+              <a:rPr lang="en-US" b="1" i="0" u="none" strike="noStrike" cap="none" dirty="0">
+                <a:solidFill>
+                  <a:schemeClr val="dk1"/>
+                </a:solidFill>
+                <a:latin typeface="Arial" panose="020B0604020202020204" pitchFamily="34" charset="0"/>
+                <a:ea typeface="Calibri"/>
+                <a:cs typeface="Arial" panose="020B0604020202020204" pitchFamily="34" charset="0"/>
+                <a:sym typeface="Calibri"/>
+              </a:rPr>
+              <a:t> for making the </a:t>
+            </a:r>
+            <a:r>
+              <a:rPr lang="en-US" b="1" dirty="0">
+                <a:solidFill>
+                  <a:schemeClr val="dk1"/>
+                </a:solidFill>
+                <a:latin typeface="Arial" panose="020B0604020202020204" pitchFamily="34" charset="0"/>
+                <a:ea typeface="Calibri"/>
+                <a:cs typeface="Arial" panose="020B0604020202020204" pitchFamily="34" charset="0"/>
+                <a:sym typeface="Calibri"/>
+              </a:rPr>
+              <a:t>PPT</a:t>
+            </a:r>
+            <a:r>
+              <a:rPr lang="en-US" b="1" i="0" u="none" strike="noStrike" cap="none" dirty="0">
+                <a:solidFill>
+                  <a:schemeClr val="dk1"/>
+                </a:solidFill>
+                <a:latin typeface="Arial" panose="020B0604020202020204" pitchFamily="34" charset="0"/>
+                <a:ea typeface="Calibri"/>
+                <a:cs typeface="Arial" panose="020B0604020202020204" pitchFamily="34" charset="0"/>
+                <a:sym typeface="Calibri"/>
+              </a:rPr>
+              <a:t> without changing the idea details pointers (mentioned in previous slides).</a:t>
+            </a:r>
+            <a:endParaRPr b="1" i="0" u="none" strike="noStrike" cap="none" dirty="0">
+              <a:solidFill>
+                <a:schemeClr val="dk1"/>
+              </a:solidFill>
+              <a:latin typeface="Arial" panose="020B0604020202020204" pitchFamily="34" charset="0"/>
+              <a:ea typeface="Calibri"/>
+              <a:cs typeface="Arial" panose="020B0604020202020204" pitchFamily="34" charset="0"/>
+              <a:sym typeface="Calibri"/>
+            </a:endParaRPr>
+          </a:p>
+          <a:p>
+            <a:pPr marL="514350" marR="0" lvl="0" indent="-514350" algn="just" rtl="0">
+              <a:lnSpc>
+                <a:spcPct val="90000"/>
+              </a:lnSpc>
+              <a:spcBef>
+                <a:spcPts val="1000"/>
+              </a:spcBef>
+              <a:spcAft>
+                <a:spcPts val="0"/>
+              </a:spcAft>
+              <a:buClr>
+                <a:schemeClr val="dk1"/>
+              </a:buClr>
+              <a:buSzPct val="100000"/>
+              <a:buFont typeface="Calibri"/>
+              <a:buAutoNum type="arabicPeriod"/>
+            </a:pPr>
+            <a:r>
+              <a:rPr lang="en-US" b="1" i="0" u="none" strike="noStrike" cap="none" dirty="0">
+                <a:solidFill>
+                  <a:schemeClr val="dk1"/>
+                </a:solidFill>
+                <a:latin typeface="Arial" panose="020B0604020202020204" pitchFamily="34" charset="0"/>
+                <a:ea typeface="Calibri"/>
+                <a:cs typeface="Arial" panose="020B0604020202020204" pitchFamily="34" charset="0"/>
+                <a:sym typeface="Calibri"/>
+              </a:rPr>
+              <a:t>You need to save the file in PDF and upload the same on portal. No PPT, Word Doc or any other format will be supported.</a:t>
+            </a:r>
+            <a:endParaRPr b="1" dirty="0">
+              <a:latin typeface="Arial" panose="020B0604020202020204" pitchFamily="34" charset="0"/>
+              <a:cs typeface="Arial" panose="020B0604020202020204" pitchFamily="34" charset="0"/>
+            </a:endParaRPr>
+          </a:p>
+          <a:p>
+            <a:pPr marL="514350" marR="0" lvl="0" indent="-349885" algn="just" rtl="0">
+              <a:lnSpc>
+                <a:spcPct val="90000"/>
+              </a:lnSpc>
+              <a:spcBef>
+                <a:spcPts val="1000"/>
+              </a:spcBef>
+              <a:spcAft>
+                <a:spcPts val="0"/>
+              </a:spcAft>
+              <a:buClr>
+                <a:schemeClr val="dk1"/>
+              </a:buClr>
+              <a:buSzPct val="100000"/>
+              <a:buFont typeface="Calibri"/>
+              <a:buNone/>
+            </a:pPr>
+            <a:endParaRPr b="1" i="0" u="none" strike="noStrike" cap="none" dirty="0">
+              <a:solidFill>
+                <a:schemeClr val="dk1"/>
+              </a:solidFill>
+              <a:latin typeface="Arial" panose="020B0604020202020204" pitchFamily="34" charset="0"/>
+              <a:ea typeface="Calibri"/>
+              <a:cs typeface="Arial" panose="020B0604020202020204" pitchFamily="34" charset="0"/>
+              <a:sym typeface="Calibri"/>
+            </a:endParaRPr>
+          </a:p>
+          <a:p>
+            <a:pPr marL="0" marR="0" lvl="0" indent="0" algn="just" rtl="0">
+              <a:lnSpc>
+                <a:spcPct val="90000"/>
+              </a:lnSpc>
+              <a:spcBef>
+                <a:spcPts val="1000"/>
+              </a:spcBef>
+              <a:spcAft>
+                <a:spcPts val="0"/>
+              </a:spcAft>
+              <a:buClr>
+                <a:schemeClr val="dk1"/>
+              </a:buClr>
+              <a:buSzPct val="100000"/>
+              <a:buFont typeface="Arial"/>
+              <a:buNone/>
+            </a:pPr>
+            <a:r>
+              <a:rPr lang="en-US" b="1" i="0" u="none" strike="noStrike" cap="none" dirty="0">
+                <a:solidFill>
+                  <a:srgbClr val="C00000"/>
+                </a:solidFill>
+                <a:latin typeface="Arial" panose="020B0604020202020204" pitchFamily="34" charset="0"/>
+                <a:ea typeface="Calibri"/>
+                <a:cs typeface="Arial" panose="020B0604020202020204" pitchFamily="34" charset="0"/>
+                <a:sym typeface="Calibri"/>
+              </a:rPr>
+              <a:t>Note - You can delete this slide (Important Pointers) when you upload the details of your idea on SIH portal.</a:t>
+            </a:r>
+            <a:endParaRPr b="1" dirty="0">
+              <a:solidFill>
+                <a:srgbClr val="C00000"/>
+              </a:solidFill>
+              <a:latin typeface="Arial" panose="020B0604020202020204" pitchFamily="34" charset="0"/>
+              <a:cs typeface="Arial" panose="020B0604020202020204" pitchFamily="34" charset="0"/>
+            </a:endParaRPr>
+          </a:p>
+          <a:p>
+            <a:pPr marL="914400" marR="0" lvl="1" indent="-316230" algn="just" rtl="0">
+              <a:lnSpc>
+                <a:spcPct val="90000"/>
+              </a:lnSpc>
+              <a:spcBef>
+                <a:spcPts val="500"/>
+              </a:spcBef>
+              <a:spcAft>
+                <a:spcPts val="0"/>
+              </a:spcAft>
+              <a:buClr>
+                <a:schemeClr val="dk1"/>
+              </a:buClr>
+              <a:buSzPct val="100000"/>
+              <a:buFont typeface="Calibri"/>
+              <a:buNone/>
+            </a:pPr>
+            <a:endParaRPr sz="2000" b="1" i="0" u="none" strike="noStrike" cap="none" dirty="0">
+              <a:solidFill>
+                <a:schemeClr val="dk1"/>
+              </a:solidFill>
+              <a:latin typeface="Arial" panose="020B0604020202020204" pitchFamily="34" charset="0"/>
+              <a:ea typeface="Calibri"/>
+              <a:cs typeface="Arial" panose="020B0604020202020204" pitchFamily="34" charset="0"/>
+              <a:sym typeface="Calibri"/>
+            </a:endParaRPr>
+          </a:p>
+        </p:txBody>
+      </p:sp>
+      <p:sp>
+        <p:nvSpPr>
+          <p:cNvPr id="4" name="TextBox 3"/>
+          <p:cNvSpPr txBox="1"/>
+          <p:nvPr/>
+        </p:nvSpPr>
+        <p:spPr>
+          <a:xfrm>
+            <a:off x="1393371" y="107066"/>
+            <a:ext cx="8410540" cy="646331"/>
+          </a:xfrm>
+          <a:prstGeom prst="rect">
+            <a:avLst/>
+          </a:prstGeom>
+          <a:noFill/>
+        </p:spPr>
+        <p:txBody>
+          <a:bodyPr wrap="square" rtlCol="0">
+            <a:spAutoFit/>
+          </a:bodyPr>
+          <a:lstStyle/>
+          <a:p>
+            <a:pPr algn="ctr"/>
+            <a:r>
+              <a:rPr lang="en-US" sz="3600" b="1" dirty="0">
+                <a:latin typeface="Times New Roman" panose="02020603050405020304" pitchFamily="18" charset="0"/>
+                <a:cs typeface="Times New Roman" panose="02020603050405020304" pitchFamily="18" charset="0"/>
+              </a:rPr>
+              <a:t>IMPORTANT INSTRUCTIONS</a:t>
+            </a:r>
+            <a:endParaRPr lang="en-IN" sz="3600" b="1" dirty="0">
+              <a:latin typeface="Times New Roman" panose="02020603050405020304" pitchFamily="18" charset="0"/>
+              <a:cs typeface="Times New Roman" panose="02020603050405020304" pitchFamily="18" charset="0"/>
+            </a:endParaRPr>
+          </a:p>
+        </p:txBody>
+      </p:sp>
+      <p:sp>
+        <p:nvSpPr>
+          <p:cNvPr id="5" name="TextBox 4"/>
+          <p:cNvSpPr txBox="1"/>
+          <p:nvPr/>
+        </p:nvSpPr>
+        <p:spPr>
+          <a:xfrm>
+            <a:off x="602343" y="1181900"/>
+            <a:ext cx="9557657" cy="341632"/>
+          </a:xfrm>
+          <a:prstGeom prst="rect">
+            <a:avLst/>
+          </a:prstGeom>
+          <a:noFill/>
+        </p:spPr>
+        <p:txBody>
+          <a:bodyPr wrap="square" rtlCol="0">
+            <a:spAutoFit/>
+          </a:bodyPr>
+          <a:lstStyle/>
+          <a:p>
+            <a:pPr algn="just">
+              <a:lnSpc>
+                <a:spcPct val="90000"/>
+              </a:lnSpc>
+              <a:spcBef>
+                <a:spcPts val="1000"/>
+              </a:spcBef>
+              <a:spcAft>
+                <a:spcPts val="0"/>
+              </a:spcAft>
+              <a:buClr>
+                <a:schemeClr val="dk1"/>
+              </a:buClr>
+              <a:buSzPct val="100000"/>
+            </a:pPr>
+            <a:r>
+              <a:rPr lang="en-US" b="1" dirty="0">
+                <a:solidFill>
+                  <a:schemeClr val="dk1"/>
+                </a:solidFill>
+                <a:latin typeface="Arial" panose="020B0604020202020204" pitchFamily="34" charset="0"/>
+                <a:ea typeface="Calibri"/>
+                <a:cs typeface="Arial" panose="020B0604020202020204" pitchFamily="34" charset="0"/>
+              </a:rPr>
+              <a:t>Please ensure below pointers are met while submitting the Idea PPT:</a:t>
+            </a:r>
+            <a:endParaRPr lang="en-IN" b="1" dirty="0">
+              <a:solidFill>
+                <a:schemeClr val="dk1"/>
+              </a:solidFill>
+              <a:latin typeface="Arial" panose="020B0604020202020204" pitchFamily="34" charset="0"/>
+              <a:ea typeface="Calibri"/>
+              <a:cs typeface="Arial" panose="020B0604020202020204" pitchFamily="34" charset="0"/>
+            </a:endParaRPr>
+          </a:p>
+        </p:txBody>
+      </p:sp>
+      <p:pic>
+        <p:nvPicPr>
+          <p:cNvPr id="13" name="Picture 12"/>
+          <p:cNvPicPr>
+            <a:picLocks noChangeAspect="1"/>
+          </p:cNvPicPr>
+          <p:nvPr/>
+        </p:nvPicPr>
+        <p:blipFill>
+          <a:blip r:embed="rId3">
+            <a:extLst>
+              <a:ext uri="{28A0092B-C50C-407E-A947-70E740481C1C}">
+                <a14:useLocalDpi xmlns:a14="http://schemas.microsoft.com/office/drawing/2010/main" val="0"/>
+              </a:ext>
+            </a:extLst>
+          </a:blip>
+          <a:stretch>
+            <a:fillRect/>
+          </a:stretch>
+        </p:blipFill>
+        <p:spPr>
+          <a:xfrm>
+            <a:off x="9780086" y="1500"/>
+            <a:ext cx="2249850" cy="1062337"/>
+          </a:xfrm>
+          <a:prstGeom prst="rect">
+            <a:avLst/>
+          </a:prstGeom>
+        </p:spPr>
+      </p:pic>
+    </p:spTree>
+    <p:extLst>
+      <p:ext uri="{BB962C8B-B14F-4D97-AF65-F5344CB8AC3E}">
+        <p14:creationId xmlns:p14="http://schemas.microsoft.com/office/powerpoint/2010/main" val="1588084416"/>
       </p:ext>
     </p:extLst>
   </p:cSld>

</xml_diff>

<commit_message>
fix(presentation): restore exact official SIH demo PPT slide 1 structure, embed high-res 1080p slide images, and eliminate overlapping text
</commit_message>
<xml_diff>
--- a/deck/final/PRAMAAN-AICTE_SIH2026_Final.pptx
+++ b/deck/final/PRAMAAN-AICTE_SIH2026_Final.pptx
@@ -5718,14 +5718,25 @@
         </p:nvSpPr>
         <p:spPr>
           <a:xfrm>
-            <a:off x="1245686" y="648614"/>
-            <a:ext cx="8534400" cy="1752600"/>
-          </a:xfrm>
-        </p:spPr>
-        <p:txBody>
-          <a:bodyPr/>
+            <a:off x="365760" y="868680"/>
+            <a:ext cx="5943600" cy="365760"/>
+          </a:xfrm>
+        </p:spPr>
+        <p:txBody>
+          <a:bodyPr wrap="square"/>
           <a:lstStyle/>
           <a:p>
+            <a:pPr algn="l">
+              <a:defRPr sz="1400" b="1">
+                <a:solidFill>
+                  <a:srgbClr val="008C6E"/>
+                </a:solidFill>
+                <a:latin typeface="Arial"/>
+              </a:defRPr>
+            </a:pPr>
+            <a:r>
+              <a:t>TITLE PAGE</a:t>
+            </a:r>
             <a:endParaRPr lang="en-US" b="1" dirty="0">
               <a:solidFill>
                 <a:schemeClr val="tx1"/>
@@ -5748,21 +5759,23 @@
         </p:nvSpPr>
         <p:spPr>
           <a:xfrm>
-            <a:off x="331286" y="-526757"/>
-            <a:ext cx="10363200" cy="2076450"/>
-          </a:xfrm>
-        </p:spPr>
-        <p:txBody>
-          <a:bodyPr/>
+            <a:off x="365760" y="182880"/>
+            <a:ext cx="9326880" cy="822960"/>
+          </a:xfrm>
+        </p:spPr>
+        <p:txBody>
+          <a:bodyPr wrap="square"/>
           <a:lstStyle/>
           <a:p>
-            <a:r>
-              <a:rPr lang="en-US" sz="4000" b="1" dirty="0">
-                <a:solidFill>
-                  <a:schemeClr val="tx2"/>
-                </a:solidFill>
-                <a:latin typeface="Garamond" panose="02020404030301010803" pitchFamily="18" charset="0"/>
-              </a:rPr>
+            <a:pPr algn="l">
+              <a:defRPr sz="2800" b="1">
+                <a:solidFill>
+                  <a:srgbClr val="112266"/>
+                </a:solidFill>
+                <a:latin typeface="Arial"/>
+              </a:defRPr>
+            </a:pPr>
+            <a:r>
               <a:t>SMART INDIA HACKATHON 2026</a:t>
             </a:r>
             <a:endParaRPr lang="en-IN" sz="4000" b="1" dirty="0">
@@ -5782,8 +5795,8 @@
         </p:nvSpPr>
         <p:spPr>
           <a:xfrm>
-            <a:off x="457200" y="1371600"/>
-            <a:ext cx="6035040" cy="4846320"/>
+            <a:off x="365760" y="1417320"/>
+            <a:ext cx="6217920" cy="4800600"/>
           </a:xfrm>
           <a:prstGeom prst="rect">
             <a:avLst/>
@@ -5802,7 +5815,7 @@
               </a:spcBef>
             </a:pPr>
             <a:r>
-              <a:rPr sz="1100" b="1">
+              <a:rPr sz="1080" b="1">
                 <a:solidFill>
                   <a:srgbClr val="112266"/>
                 </a:solidFill>
@@ -5811,7 +5824,7 @@
               <a:t>Problem Statement ID: </a:t>
             </a:r>
             <a:r>
-              <a:rPr sz="1350" b="1">
+              <a:rPr sz="1300" b="1">
                 <a:solidFill>
                   <a:srgbClr val="112266"/>
                 </a:solidFill>
@@ -5824,11 +5837,11 @@
           <a:p>
             <a:pPr>
               <a:spcBef>
-                <a:spcPts val="450"/>
+                <a:spcPts val="400"/>
               </a:spcBef>
             </a:pPr>
             <a:r>
-              <a:rPr sz="1100" b="1">
+              <a:rPr sz="1080" b="1">
                 <a:solidFill>
                   <a:srgbClr val="112266"/>
                 </a:solidFill>
@@ -5849,11 +5862,11 @@
           <a:p>
             <a:pPr>
               <a:spcBef>
-                <a:spcPts val="450"/>
+                <a:spcPts val="400"/>
               </a:spcBef>
             </a:pPr>
             <a:r>
-              <a:rPr sz="1100" b="1">
+              <a:rPr sz="1080" b="1">
                 <a:solidFill>
                   <a:srgbClr val="112266"/>
                 </a:solidFill>
@@ -5862,7 +5875,7 @@
               <a:t>Theme: </a:t>
             </a:r>
             <a:r>
-              <a:rPr sz="1150" b="0">
+              <a:rPr sz="1100" b="0">
                 <a:solidFill>
                   <a:srgbClr val="222222"/>
                 </a:solidFill>
@@ -5874,11 +5887,11 @@
           <a:p>
             <a:pPr>
               <a:spcBef>
-                <a:spcPts val="450"/>
+                <a:spcPts val="400"/>
               </a:spcBef>
             </a:pPr>
             <a:r>
-              <a:rPr sz="1100" b="1">
+              <a:rPr sz="1080" b="1">
                 <a:solidFill>
                   <a:srgbClr val="112266"/>
                 </a:solidFill>
@@ -5887,7 +5900,7 @@
               <a:t>PS Category: </a:t>
             </a:r>
             <a:r>
-              <a:rPr sz="1150" b="0">
+              <a:rPr sz="1100" b="0">
                 <a:solidFill>
                   <a:srgbClr val="222222"/>
                 </a:solidFill>
@@ -5899,11 +5912,11 @@
           <a:p>
             <a:pPr>
               <a:spcBef>
-                <a:spcPts val="450"/>
+                <a:spcPts val="400"/>
               </a:spcBef>
             </a:pPr>
             <a:r>
-              <a:rPr sz="1100" b="1">
+              <a:rPr sz="1080" b="1">
                 <a:solidFill>
                   <a:srgbClr val="112266"/>
                 </a:solidFill>
@@ -5912,7 +5925,7 @@
               <a:t>Team ID: </a:t>
             </a:r>
             <a:r>
-              <a:rPr sz="1150" b="0">
+              <a:rPr sz="1100" b="0">
                 <a:solidFill>
                   <a:srgbClr val="222222"/>
                 </a:solidFill>
@@ -5924,11 +5937,11 @@
           <a:p>
             <a:pPr>
               <a:spcBef>
-                <a:spcPts val="450"/>
+                <a:spcPts val="400"/>
               </a:spcBef>
             </a:pPr>
             <a:r>
-              <a:rPr sz="1100" b="1">
+              <a:rPr sz="1080" b="1">
                 <a:solidFill>
                   <a:srgbClr val="112266"/>
                 </a:solidFill>
@@ -5937,7 +5950,7 @@
               <a:t>Team Name: </a:t>
             </a:r>
             <a:r>
-              <a:rPr sz="1200" b="1">
+              <a:rPr sz="1150" b="1">
                 <a:solidFill>
                   <a:srgbClr val="112266"/>
                 </a:solidFill>
@@ -5949,42 +5962,42 @@
           <a:p>
             <a:pPr>
               <a:spcBef>
-                <a:spcPts val="450"/>
+                <a:spcPts val="400"/>
               </a:spcBef>
             </a:pPr>
             <a:r>
-              <a:rPr sz="1100" b="1">
+              <a:rPr sz="1080" b="1">
                 <a:solidFill>
                   <a:srgbClr val="112266"/>
                 </a:solidFill>
                 <a:latin typeface="Arial"/>
               </a:rPr>
-              <a:t>Live Web Platform: </a:t>
-            </a:r>
-            <a:r>
-              <a:rPr sz="1100" b="1">
-                <a:solidFill>
-                  <a:srgbClr val="008C6E"/>
-                </a:solidFill>
-                <a:latin typeface="Arial"/>
-              </a:rPr>
-              <a:t>https://brainforge.info  |  https://pramaan.brainforge.info</a:t>
+              <a:t>Institute Name: </a:t>
+            </a:r>
+            <a:r>
+              <a:rPr sz="1100" b="0">
+                <a:solidFill>
+                  <a:srgbClr val="1A365D"/>
+                </a:solidFill>
+                <a:latin typeface="Arial"/>
+              </a:rPr>
+              <a:t>Thiagarajar College of Engineering, Madurai, Tamil Nadu</a:t>
             </a:r>
           </a:p>
           <a:p>
             <a:pPr>
               <a:spcBef>
-                <a:spcPts val="450"/>
+                <a:spcPts val="400"/>
               </a:spcBef>
             </a:pPr>
             <a:r>
-              <a:rPr sz="1100" b="1">
+              <a:rPr sz="1080" b="1">
                 <a:solidFill>
                   <a:srgbClr val="112266"/>
                 </a:solidFill>
                 <a:latin typeface="Arial"/>
               </a:rPr>
-              <a:t>Live Backend &amp; API: </a:t>
+              <a:t>Live Web Platform: </a:t>
             </a:r>
             <a:r>
               <a:rPr sz="1050" b="1">
@@ -5993,67 +6006,67 @@
                 </a:solidFill>
                 <a:latin typeface="Arial"/>
               </a:rPr>
-              <a:t>https://apaar-id-based-system.onrender.com/docs</a:t>
+              <a:t>https://brainforge.info  |  https://pramaan.brainforge.info</a:t>
             </a:r>
           </a:p>
           <a:p>
             <a:pPr>
               <a:spcBef>
-                <a:spcPts val="450"/>
+                <a:spcPts val="400"/>
               </a:spcBef>
             </a:pPr>
             <a:r>
-              <a:rPr sz="1100" b="1">
+              <a:rPr sz="1080" b="1">
                 <a:solidFill>
                   <a:srgbClr val="112266"/>
                 </a:solidFill>
                 <a:latin typeface="Arial"/>
               </a:rPr>
-              <a:t>Source Repository: </a:t>
+              <a:t>Live Backend &amp; API: </a:t>
             </a:r>
             <a:r>
               <a:rPr sz="1050" b="1">
                 <a:solidFill>
-                  <a:srgbClr val="1A56DB"/>
-                </a:solidFill>
-                <a:latin typeface="Arial"/>
-              </a:rPr>
-              <a:t>https://github.com/naveeshpcbin/APAAR-ID-BASED-SYSTEM</a:t>
+                  <a:srgbClr val="008C6E"/>
+                </a:solidFill>
+                <a:latin typeface="Arial"/>
+              </a:rPr>
+              <a:t>https://apaar-id-based-system.onrender.com/docs</a:t>
             </a:r>
           </a:p>
           <a:p>
             <a:pPr>
               <a:spcBef>
-                <a:spcPts val="450"/>
+                <a:spcPts val="400"/>
               </a:spcBef>
             </a:pPr>
             <a:r>
-              <a:rPr sz="1100" b="1">
+              <a:rPr sz="1080" b="1">
                 <a:solidFill>
                   <a:srgbClr val="112266"/>
                 </a:solidFill>
                 <a:latin typeface="Arial"/>
               </a:rPr>
-              <a:t>Architecture Baseline: </a:t>
-            </a:r>
-            <a:r>
-              <a:rPr sz="1000" b="0">
-                <a:solidFill>
-                  <a:srgbClr val="1A365D"/>
-                </a:solidFill>
-                <a:latin typeface="Arial"/>
-              </a:rPr>
-              <a:t>Next.js 14 + FastAPI + PostgreSQL (20 Tables, RLS) + Deterministic 3-Way Reconciliation</a:t>
+              <a:t>Source Repository: </a:t>
+            </a:r>
+            <a:r>
+              <a:rPr sz="1050" b="1">
+                <a:solidFill>
+                  <a:srgbClr val="1A56DB"/>
+                </a:solidFill>
+                <a:latin typeface="Arial"/>
+              </a:rPr>
+              <a:t>https://github.com/naveeshpcbin/APAAR-ID-BASED-SYSTEM</a:t>
             </a:r>
           </a:p>
           <a:p>
             <a:pPr>
               <a:spcBef>
-                <a:spcPts val="450"/>
+                <a:spcPts val="400"/>
               </a:spcBef>
             </a:pPr>
             <a:r>
-              <a:rPr sz="1100" b="1">
+              <a:rPr sz="1080" b="1">
                 <a:solidFill>
                   <a:srgbClr val="112266"/>
                 </a:solidFill>
@@ -6068,7 +6081,7 @@
                 </a:solidFill>
                 <a:latin typeface="Arial"/>
               </a:rPr>
-              <a:t>66/66 Passing Tests | 20/20 E2E Checks | Live Cloud Deployment Verified</a:t>
+              <a:t>66/66 Passing Tests | 20 Tables with RLS | Live Cloud Verified</a:t>
             </a:r>
           </a:p>
         </p:txBody>
@@ -6105,25 +6118,23 @@
       </p:pic>
       <p:sp>
         <p:nvSpPr>
-          <p:cNvPr id="38" name="Rounded Rectangle 37"/>
+          <p:cNvPr id="38" name="Rectangle 37"/>
           <p:cNvSpPr/>
           <p:nvPr/>
         </p:nvSpPr>
         <p:spPr>
           <a:xfrm>
-            <a:off x="6675120" y="1371600"/>
-            <a:ext cx="5120640" cy="4846320"/>
-          </a:xfrm>
-          <a:prstGeom prst="roundRect">
+            <a:off x="0" y="6355080"/>
+            <a:ext cx="12191695" cy="502920"/>
+          </a:xfrm>
+          <a:prstGeom prst="rect">
             <a:avLst/>
           </a:prstGeom>
           <a:solidFill>
-            <a:srgbClr val="FFFFFF"/>
+            <a:srgbClr val="006FBF"/>
           </a:solidFill>
-          <a:ln w="15240">
-            <a:solidFill>
-              <a:srgbClr val="CBD5E1"/>
-            </a:solidFill>
+          <a:ln>
+            <a:noFill/>
           </a:ln>
         </p:spPr>
         <p:style>
@@ -6150,103 +6161,7 @@
       </p:sp>
       <p:sp>
         <p:nvSpPr>
-          <p:cNvPr id="39" name="Rounded Rectangle 38"/>
-          <p:cNvSpPr/>
-          <p:nvPr/>
-        </p:nvSpPr>
-        <p:spPr>
-          <a:xfrm>
-            <a:off x="6812280" y="1261872"/>
-            <a:ext cx="4846320" cy="292608"/>
-          </a:xfrm>
-          <a:prstGeom prst="roundRect">
-            <a:avLst/>
-          </a:prstGeom>
-          <a:solidFill>
-            <a:srgbClr val="112266"/>
-          </a:solidFill>
-          <a:ln>
-            <a:noFill/>
-          </a:ln>
-        </p:spPr>
-        <p:style>
-          <a:lnRef idx="1">
-            <a:schemeClr val="accent1"/>
-          </a:lnRef>
-          <a:fillRef idx="3">
-            <a:schemeClr val="accent1"/>
-          </a:fillRef>
-          <a:effectRef idx="2">
-            <a:schemeClr val="accent1"/>
-          </a:effectRef>
-          <a:fontRef idx="minor">
-            <a:schemeClr val="lt1"/>
-          </a:fontRef>
-        </p:style>
-        <p:txBody>
-          <a:bodyPr rtlCol="0" anchor="ctr" wrap="none" lIns="73152" rIns="73152" tIns="9144" bIns="9144"/>
-          <a:lstStyle/>
-          <a:p>
-            <a:pPr algn="ctr">
-              <a:defRPr sz="950" b="1">
-                <a:solidFill>
-                  <a:srgbClr val="FFFFFF"/>
-                </a:solidFill>
-                <a:latin typeface="Arial"/>
-              </a:defRPr>
-            </a:pPr>
-            <a:r>
-              <a:t>DEPLOYED &amp; VERIFIED SYSTEM ARCHITECTURE</a:t>
-            </a:r>
-          </a:p>
-        </p:txBody>
-      </p:sp>
-      <p:sp>
-        <p:nvSpPr>
-          <p:cNvPr id="40" name="Rectangle 39"/>
-          <p:cNvSpPr/>
-          <p:nvPr/>
-        </p:nvSpPr>
-        <p:spPr>
-          <a:xfrm>
-            <a:off x="0" y="6355080"/>
-            <a:ext cx="12191695" cy="502920"/>
-          </a:xfrm>
-          <a:prstGeom prst="rect">
-            <a:avLst/>
-          </a:prstGeom>
-          <a:solidFill>
-            <a:srgbClr val="006FBF"/>
-          </a:solidFill>
-          <a:ln>
-            <a:noFill/>
-          </a:ln>
-        </p:spPr>
-        <p:style>
-          <a:lnRef idx="1">
-            <a:schemeClr val="accent1"/>
-          </a:lnRef>
-          <a:fillRef idx="3">
-            <a:schemeClr val="accent1"/>
-          </a:fillRef>
-          <a:effectRef idx="2">
-            <a:schemeClr val="accent1"/>
-          </a:effectRef>
-          <a:fontRef idx="minor">
-            <a:schemeClr val="lt1"/>
-          </a:fontRef>
-        </p:style>
-        <p:txBody>
-          <a:bodyPr rtlCol="0" anchor="ctr"/>
-          <a:lstStyle/>
-          <a:p>
-            <a:pPr algn="ctr"/>
-          </a:p>
-        </p:txBody>
-      </p:sp>
-      <p:sp>
-        <p:nvSpPr>
-          <p:cNvPr id="41" name="TextBox 40"/>
+          <p:cNvPr id="39" name="TextBox 38"/>
           <p:cNvSpPr txBox="1"/>
           <p:nvPr/>
         </p:nvSpPr>
@@ -6282,7 +6197,7 @@
       </p:sp>
       <p:sp>
         <p:nvSpPr>
-          <p:cNvPr id="42" name="TextBox 41"/>
+          <p:cNvPr id="40" name="TextBox 39"/>
           <p:cNvSpPr txBox="1"/>
           <p:nvPr/>
         </p:nvSpPr>
@@ -7334,9 +7249,33 @@
           </a:p>
         </p:txBody>
       </p:sp>
-      <p:sp>
-        <p:nvSpPr>
-          <p:cNvPr id="15373" name="TextBox 15372"/>
+      <p:pic>
+        <p:nvPicPr>
+          <p:cNvPr id="15373" name="Picture 15372" descr="slide_2_Picture 3.png"/>
+          <p:cNvPicPr>
+            <a:picLocks noChangeAspect="1"/>
+          </p:cNvPicPr>
+          <p:nvPr/>
+        </p:nvPicPr>
+        <p:blipFill>
+          <a:blip r:embed="rId4"/>
+          <a:stretch>
+            <a:fillRect/>
+          </a:stretch>
+        </p:blipFill>
+        <p:spPr>
+          <a:xfrm>
+            <a:off x="6281928" y="1353312"/>
+            <a:ext cx="5404104" cy="2926080"/>
+          </a:xfrm>
+          <a:prstGeom prst="rect">
+            <a:avLst/>
+          </a:prstGeom>
+        </p:spPr>
+      </p:pic>
+      <p:sp>
+        <p:nvSpPr>
+          <p:cNvPr id="15374" name="TextBox 15373"/>
           <p:cNvSpPr txBox="1"/>
           <p:nvPr/>
         </p:nvSpPr>
@@ -7434,7 +7373,7 @@
       </p:sp>
       <p:sp>
         <p:nvSpPr>
-          <p:cNvPr id="15374" name="Rounded Rectangle 15373"/>
+          <p:cNvPr id="15375" name="Rounded Rectangle 15374"/>
           <p:cNvSpPr/>
           <p:nvPr/>
         </p:nvSpPr>
@@ -7489,7 +7428,7 @@
       </p:sp>
       <p:sp>
         <p:nvSpPr>
-          <p:cNvPr id="15375" name="Rounded Rectangle 15374"/>
+          <p:cNvPr id="15376" name="Rounded Rectangle 15375"/>
           <p:cNvSpPr/>
           <p:nvPr/>
         </p:nvSpPr>
@@ -7544,7 +7483,7 @@
       </p:sp>
       <p:sp>
         <p:nvSpPr>
-          <p:cNvPr id="15376" name="Rounded Rectangle 15375"/>
+          <p:cNvPr id="15377" name="Rounded Rectangle 15376"/>
           <p:cNvSpPr/>
           <p:nvPr/>
         </p:nvSpPr>
@@ -7599,7 +7538,7 @@
       </p:sp>
       <p:sp>
         <p:nvSpPr>
-          <p:cNvPr id="15377" name="Rounded Rectangle 15376"/>
+          <p:cNvPr id="15378" name="Rounded Rectangle 15377"/>
           <p:cNvSpPr/>
           <p:nvPr/>
         </p:nvSpPr>
@@ -8827,14 +8766,14 @@
               </a:defRPr>
             </a:pPr>
             <a:r>
-              <a:t>INTERACTIVE QUARANTINE SANDBOX &amp; ROW-LEVEL FINDINGS</a:t>
+              <a:t>PROTOTYPE EVIDENCE: SMART INGESTION DESK</a:t>
             </a:r>
           </a:p>
         </p:txBody>
       </p:sp>
       <p:pic>
         <p:nvPicPr>
-          <p:cNvPr id="17427" name="Picture 17426" descr="07_interactive_spreadsheet_sandbox.png"/>
+          <p:cNvPr id="17427" name="Picture 17426" descr="slide_3_Picture 3.png"/>
           <p:cNvPicPr>
             <a:picLocks noChangeAspect="1"/>
           </p:cNvPicPr>
@@ -8849,7 +8788,7 @@
         <p:spPr>
           <a:xfrm>
             <a:off x="6281928" y="3493008"/>
-            <a:ext cx="5404104" cy="2194560"/>
+            <a:ext cx="5404104" cy="1965960"/>
           </a:xfrm>
           <a:prstGeom prst="rect">
             <a:avLst/>
@@ -8864,8 +8803,8 @@
         </p:nvSpPr>
         <p:spPr>
           <a:xfrm>
-            <a:off x="6281928" y="5715000"/>
-            <a:ext cx="5404104" cy="320040"/>
+            <a:off x="6281928" y="5532120"/>
+            <a:ext cx="5404104" cy="457200"/>
           </a:xfrm>
           <a:prstGeom prst="rect">
             <a:avLst/>
@@ -8887,7 +8826,7 @@
               </a:defRPr>
             </a:pPr>
             <a:r>
-              <a:t>Implemented UI: In-browser editable spreadsheet sandbox isolates validation findings before central commit.</a:t>
+              <a:t>Smart Ingestion Desk: Automated schema mapping, pre-flight validation status, row findings ledger, and atomic batch commitment.</a:t>
             </a:r>
           </a:p>
         </p:txBody>
@@ -9521,7 +9460,7 @@
         <p:spPr>
           <a:xfrm>
             <a:off x="6172200" y="1115568"/>
-            <a:ext cx="5623560" cy="4956048"/>
+            <a:ext cx="5623560" cy="2066543"/>
           </a:xfrm>
           <a:prstGeom prst="roundRect">
             <a:avLst/>
@@ -9566,7 +9505,7 @@
         <p:spPr>
           <a:xfrm>
             <a:off x="6309360" y="1005840"/>
-            <a:ext cx="5349240" cy="292608"/>
+            <a:ext cx="5349240" cy="274320"/>
           </a:xfrm>
           <a:prstGeom prst="roundRect">
             <a:avLst/>
@@ -9618,8 +9557,8 @@
         </p:nvSpPr>
         <p:spPr>
           <a:xfrm>
-            <a:off x="6309360" y="1371600"/>
-            <a:ext cx="5349240" cy="4572000"/>
+            <a:off x="6309360" y="1353312"/>
+            <a:ext cx="5349240" cy="1755648"/>
           </a:xfrm>
           <a:prstGeom prst="rect">
             <a:avLst/>
@@ -9638,247 +9577,230 @@
               </a:spcBef>
             </a:pPr>
             <a:r>
-              <a:rPr sz="869" b="1">
+              <a:rPr sz="850" b="1">
                 <a:solidFill>
                   <a:srgbClr val="B42828"/>
                 </a:solidFill>
                 <a:latin typeface="Arial"/>
               </a:rPr>
-              <a:t>- Risk: Inconsistent Institutional Spreadsheets: </a:t>
-            </a:r>
-            <a:r>
-              <a:rPr sz="819">
+              <a:t>- Inconsistent Spreadsheets: </a:t>
+            </a:r>
+            <a:r>
+              <a:rPr sz="800">
                 <a:solidFill>
                   <a:srgbClr val="222222"/>
                 </a:solidFill>
                 <a:latin typeface="Arial"/>
               </a:rPr>
-              <a:t>Colleges use varying ERP schemas and column headers (e.g. apaar_id vs uid vs student_apaar).</a:t>
+              <a:t>Colleges use varying ERP column headers. -&gt; Control: Header alias normalizer maps 50+ divergent column variants into standard canonical schema.</a:t>
             </a:r>
           </a:p>
           <a:p>
             <a:pPr>
               <a:spcBef>
-                <a:spcPts val="150"/>
+                <a:spcPts val="350"/>
               </a:spcBef>
             </a:pPr>
             <a:r>
               <a:rPr sz="850" b="1">
                 <a:solidFill>
-                  <a:srgbClr val="008C6E"/>
-                </a:solidFill>
-                <a:latin typeface="Arial"/>
-              </a:rPr>
-              <a:t>  * Control: </a:t>
-            </a:r>
-            <a:r>
-              <a:rPr sz="819">
+                  <a:srgbClr val="B42828"/>
+                </a:solidFill>
+                <a:latin typeface="Arial"/>
+              </a:rPr>
+              <a:t>- Identifier Privacy Exposure: </a:t>
+            </a:r>
+            <a:r>
+              <a:rPr sz="800">
                 <a:solidFill>
                   <a:srgbClr val="222222"/>
                 </a:solidFill>
                 <a:latin typeface="Arial"/>
               </a:rPr>
-              <a:t>Header alias normalizer maps 50+ divergent column variants into standard canonical schema automatically.</a:t>
+              <a:t>Storing plaintext student APAAR IDs risks data leakage. -&gt; Control: Keyed HMAC-SHA256 pseudonymized indexing and dynamic masking ensure zero plaintext PII exposure.</a:t>
             </a:r>
           </a:p>
           <a:p>
             <a:pPr>
               <a:spcBef>
-                <a:spcPts val="600"/>
+                <a:spcPts val="350"/>
               </a:spcBef>
             </a:pPr>
             <a:r>
-              <a:rPr sz="869" b="1">
+              <a:rPr sz="850" b="1">
                 <a:solidFill>
                   <a:srgbClr val="B42828"/>
                 </a:solidFill>
                 <a:latin typeface="Arial"/>
               </a:rPr>
-              <a:t>- Risk: Student Identifier Privacy Exposure: </a:t>
-            </a:r>
-            <a:r>
-              <a:rPr sz="819">
+              <a:t>- Concurrent Admissions: </a:t>
+            </a:r>
+            <a:r>
+              <a:rPr sz="800">
                 <a:solidFill>
                   <a:srgbClr val="222222"/>
                 </a:solidFill>
                 <a:latin typeface="Arial"/>
               </a:rPr>
-              <a:t>Storing plaintext 12-digit student APAAR identifiers risks data leakage under DPDP Act 2023.</a:t>
-            </a:r>
-          </a:p>
-          <a:p>
-            <a:pPr>
-              <a:spcBef>
-                <a:spcPts val="150"/>
-              </a:spcBef>
-            </a:pPr>
-            <a:r>
-              <a:rPr sz="850" b="1">
-                <a:solidFill>
-                  <a:srgbClr val="008C6E"/>
-                </a:solidFill>
-                <a:latin typeface="Arial"/>
-              </a:rPr>
-              <a:t>  * Control: </a:t>
-            </a:r>
-            <a:r>
-              <a:rPr sz="819">
-                <a:solidFill>
-                  <a:srgbClr val="222222"/>
-                </a:solidFill>
-                <a:latin typeface="Arial"/>
-              </a:rPr>
-              <a:t>Keyed HMAC-SHA256 pseudonymized indexing and dynamic masking (XXXX-XXXX-9012) ensure zero plaintext PII exposure.</a:t>
-            </a:r>
-          </a:p>
-          <a:p>
-            <a:pPr>
-              <a:spcBef>
-                <a:spcPts val="600"/>
-              </a:spcBef>
-            </a:pPr>
-            <a:r>
-              <a:rPr sz="869" b="1">
-                <a:solidFill>
-                  <a:srgbClr val="B42828"/>
-                </a:solidFill>
-                <a:latin typeface="Arial"/>
-              </a:rPr>
-              <a:t>- Risk: Multi-Institution Concurrent Admissions: </a:t>
-            </a:r>
-            <a:r>
-              <a:rPr sz="819">
-                <a:solidFill>
-                  <a:srgbClr val="222222"/>
-                </a:solidFill>
-                <a:latin typeface="Arial"/>
-              </a:rPr>
-              <a:t>Students admitted concurrently across different institutions leading to seat blocking.</a:t>
-            </a:r>
-          </a:p>
-          <a:p>
-            <a:pPr>
-              <a:spcBef>
-                <a:spcPts val="150"/>
-              </a:spcBef>
-            </a:pPr>
-            <a:r>
-              <a:rPr sz="850" b="1">
-                <a:solidFill>
-                  <a:srgbClr val="008C6E"/>
-                </a:solidFill>
-                <a:latin typeface="Arial"/>
-              </a:rPr>
-              <a:t>  * Control: </a:t>
-            </a:r>
-            <a:r>
-              <a:rPr sz="819">
-                <a:solidFill>
-                  <a:srgbClr val="222222"/>
-                </a:solidFill>
-                <a:latin typeface="Arial"/>
-              </a:rPr>
-              <a:t>Cross-institution collision radar cross-checks active admissions against centralized reference records and flags duplicates.</a:t>
-            </a:r>
-          </a:p>
-          <a:p>
-            <a:pPr>
-              <a:spcBef>
-                <a:spcPts val="600"/>
-              </a:spcBef>
-            </a:pPr>
-            <a:r>
-              <a:rPr sz="869" b="1">
-                <a:solidFill>
-                  <a:srgbClr val="B42828"/>
-                </a:solidFill>
-                <a:latin typeface="Arial"/>
-              </a:rPr>
-              <a:t>- Risk: Regulatory Non-Repudiation &amp; Tampering: </a:t>
-            </a:r>
-            <a:r>
-              <a:rPr sz="819">
-                <a:solidFill>
-                  <a:srgbClr val="222222"/>
-                </a:solidFill>
-                <a:latin typeface="Arial"/>
-              </a:rPr>
-              <a:t>Unauthorized insider tampering with approved intake capacity or admission records.</a:t>
-            </a:r>
-          </a:p>
-          <a:p>
-            <a:pPr>
-              <a:spcBef>
-                <a:spcPts val="150"/>
-              </a:spcBef>
-            </a:pPr>
-            <a:r>
-              <a:rPr sz="850" b="1">
-                <a:solidFill>
-                  <a:srgbClr val="008C6E"/>
-                </a:solidFill>
-                <a:latin typeface="Arial"/>
-              </a:rPr>
-              <a:t>  * Control: </a:t>
-            </a:r>
-            <a:r>
-              <a:rPr sz="819">
-                <a:solidFill>
-                  <a:srgbClr val="222222"/>
-                </a:solidFill>
-                <a:latin typeface="Arial"/>
-              </a:rPr>
-              <a:t>Append-only sequential SHA-256 hash chaining (Hash_n = SHA256(Record_n || Hash_n-1)) mathematically exposes any tampering.</a:t>
-            </a:r>
-          </a:p>
-          <a:p>
-            <a:pPr>
-              <a:spcBef>
-                <a:spcPts val="600"/>
-              </a:spcBef>
-            </a:pPr>
-            <a:r>
-              <a:rPr sz="869" b="1">
-                <a:solidFill>
-                  <a:srgbClr val="B42828"/>
-                </a:solidFill>
-                <a:latin typeface="Arial"/>
-              </a:rPr>
-              <a:t>- Risk: Database Driver &amp; Cloud Connection Mismatch: </a:t>
-            </a:r>
-            <a:r>
-              <a:rPr sz="819">
-                <a:solidFill>
-                  <a:srgbClr val="222222"/>
-                </a:solidFill>
-                <a:latin typeface="Arial"/>
-              </a:rPr>
-              <a:t>Container deployment failures caused by PostgreSQL driver compatibility or pooler SSL configuration.</a:t>
-            </a:r>
-          </a:p>
-          <a:p>
-            <a:pPr>
-              <a:spcBef>
-                <a:spcPts val="150"/>
-              </a:spcBef>
-            </a:pPr>
-            <a:r>
-              <a:rPr sz="850" b="1">
-                <a:solidFill>
-                  <a:srgbClr val="008C6E"/>
-                </a:solidFill>
-                <a:latin typeface="Arial"/>
-              </a:rPr>
-              <a:t>  * Control: </a:t>
-            </a:r>
-            <a:r>
-              <a:rPr sz="819">
-                <a:solidFill>
-                  <a:srgbClr val="222222"/>
-                </a:solidFill>
-                <a:latin typeface="Arial"/>
-              </a:rPr>
-              <a:t>Implemented smart connection URI sanitization and dynamic psycopg3/psycopg2 driver fallback with automated readiness health check.</a:t>
+              <a:t>Students admitted concurrently across different institutions. -&gt; Control: Cross-institution collision radar cross-checks active admissions against central records and flags duplicates.</a:t>
+            </a:r>
+          </a:p>
+        </p:txBody>
+      </p:sp>
+      <p:sp>
+        <p:nvSpPr>
+          <p:cNvPr id="17416" name="Rounded Rectangle 17415"/>
+          <p:cNvSpPr/>
+          <p:nvPr/>
+        </p:nvSpPr>
+        <p:spPr>
+          <a:xfrm>
+            <a:off x="6172200" y="3291840"/>
+            <a:ext cx="5623560" cy="2779776"/>
+          </a:xfrm>
+          <a:prstGeom prst="roundRect">
+            <a:avLst/>
+          </a:prstGeom>
+          <a:solidFill>
+            <a:srgbClr val="FFFFFF"/>
+          </a:solidFill>
+          <a:ln w="15240">
+            <a:solidFill>
+              <a:srgbClr val="CBD5E1"/>
+            </a:solidFill>
+          </a:ln>
+        </p:spPr>
+        <p:style>
+          <a:lnRef idx="1">
+            <a:schemeClr val="accent1"/>
+          </a:lnRef>
+          <a:fillRef idx="3">
+            <a:schemeClr val="accent1"/>
+          </a:fillRef>
+          <a:effectRef idx="2">
+            <a:schemeClr val="accent1"/>
+          </a:effectRef>
+          <a:fontRef idx="minor">
+            <a:schemeClr val="lt1"/>
+          </a:fontRef>
+        </p:style>
+        <p:txBody>
+          <a:bodyPr rtlCol="0" anchor="ctr"/>
+          <a:lstStyle/>
+          <a:p>
+            <a:pPr algn="ctr"/>
+          </a:p>
+        </p:txBody>
+      </p:sp>
+      <p:sp>
+        <p:nvSpPr>
+          <p:cNvPr id="17417" name="Rounded Rectangle 17416"/>
+          <p:cNvSpPr/>
+          <p:nvPr/>
+        </p:nvSpPr>
+        <p:spPr>
+          <a:xfrm>
+            <a:off x="6309360" y="3182112"/>
+            <a:ext cx="5349240" cy="274320"/>
+          </a:xfrm>
+          <a:prstGeom prst="roundRect">
+            <a:avLst/>
+          </a:prstGeom>
+          <a:solidFill>
+            <a:srgbClr val="008C6E"/>
+          </a:solidFill>
+          <a:ln>
+            <a:noFill/>
+          </a:ln>
+        </p:spPr>
+        <p:style>
+          <a:lnRef idx="1">
+            <a:schemeClr val="accent1"/>
+          </a:lnRef>
+          <a:fillRef idx="3">
+            <a:schemeClr val="accent1"/>
+          </a:fillRef>
+          <a:effectRef idx="2">
+            <a:schemeClr val="accent1"/>
+          </a:effectRef>
+          <a:fontRef idx="minor">
+            <a:schemeClr val="lt1"/>
+          </a:fontRef>
+        </p:style>
+        <p:txBody>
+          <a:bodyPr rtlCol="0" anchor="ctr" wrap="none" lIns="73152" rIns="73152" tIns="9144" bIns="9144"/>
+          <a:lstStyle/>
+          <a:p>
+            <a:pPr algn="ctr">
+              <a:defRPr sz="950" b="1">
+                <a:solidFill>
+                  <a:srgbClr val="FFFFFF"/>
+                </a:solidFill>
+                <a:latin typeface="Arial"/>
+              </a:defRPr>
+            </a:pPr>
+            <a:r>
+              <a:t>PROTOTYPE EVIDENCE: DUPLICATE COLLISION RADAR</a:t>
+            </a:r>
+          </a:p>
+        </p:txBody>
+      </p:sp>
+      <p:pic>
+        <p:nvPicPr>
+          <p:cNvPr id="17418" name="Picture 17417" descr="slide_4_Picture 3.png"/>
+          <p:cNvPicPr>
+            <a:picLocks noChangeAspect="1"/>
+          </p:cNvPicPr>
+          <p:nvPr/>
+        </p:nvPicPr>
+        <p:blipFill>
+          <a:blip r:embed="rId4"/>
+          <a:stretch>
+            <a:fillRect/>
+          </a:stretch>
+        </p:blipFill>
+        <p:spPr>
+          <a:xfrm>
+            <a:off x="6281928" y="3493008"/>
+            <a:ext cx="5404104" cy="1965960"/>
+          </a:xfrm>
+          <a:prstGeom prst="rect">
+            <a:avLst/>
+          </a:prstGeom>
+        </p:spPr>
+      </p:pic>
+      <p:sp>
+        <p:nvSpPr>
+          <p:cNvPr id="17419" name="TextBox 17418"/>
+          <p:cNvSpPr txBox="1"/>
+          <p:nvPr/>
+        </p:nvSpPr>
+        <p:spPr>
+          <a:xfrm>
+            <a:off x="6281928" y="5532120"/>
+            <a:ext cx="5404104" cy="457200"/>
+          </a:xfrm>
+          <a:prstGeom prst="rect">
+            <a:avLst/>
+          </a:prstGeom>
+          <a:noFill/>
+        </p:spPr>
+        <p:txBody>
+          <a:bodyPr wrap="square">
+            <a:spAutoFit/>
+          </a:bodyPr>
+          <a:lstStyle/>
+          <a:p>
+            <a:pPr algn="ctr">
+              <a:defRPr sz="780">
+                <a:solidFill>
+                  <a:srgbClr val="64748B"/>
+                </a:solidFill>
+                <a:latin typeface="Arial"/>
+              </a:defRPr>
+            </a:pPr>
+            <a:r>
+              <a:t>Duplicate Collision Radar: Side-by-side college enrollment audit, quota verification, and regulatory adjudication controls.</a:t>
             </a:r>
           </a:p>
         </p:txBody>
@@ -10601,14 +10523,38 @@
               </a:defRPr>
             </a:pPr>
             <a:r>
-              <a:t>CRYPTOGRAPHICALLY VERIFIABLE DEGREE CERTIFICATE &amp; QR PROOF</a:t>
-            </a:r>
-          </a:p>
-        </p:txBody>
-      </p:sp>
-      <p:sp>
-        <p:nvSpPr>
-          <p:cNvPr id="17415" name="TextBox 17414"/>
+              <a:t>SIH-R10 ACADEMIC CERTIFICATE &amp; ED25519 QR PROOF</a:t>
+            </a:r>
+          </a:p>
+        </p:txBody>
+      </p:sp>
+      <p:pic>
+        <p:nvPicPr>
+          <p:cNvPr id="17415" name="Picture 17414" descr="slide_5_Picture 3.png"/>
+          <p:cNvPicPr>
+            <a:picLocks noChangeAspect="1"/>
+          </p:cNvPicPr>
+          <p:nvPr/>
+        </p:nvPicPr>
+        <p:blipFill>
+          <a:blip r:embed="rId4"/>
+          <a:stretch>
+            <a:fillRect/>
+          </a:stretch>
+        </p:blipFill>
+        <p:spPr>
+          <a:xfrm>
+            <a:off x="6281928" y="1353312"/>
+            <a:ext cx="5404104" cy="2926080"/>
+          </a:xfrm>
+          <a:prstGeom prst="rect">
+            <a:avLst/>
+          </a:prstGeom>
+        </p:spPr>
+      </p:pic>
+      <p:sp>
+        <p:nvSpPr>
+          <p:cNvPr id="17416" name="TextBox 17415"/>
           <p:cNvSpPr txBox="1"/>
           <p:nvPr/>
         </p:nvSpPr>
@@ -11348,7 +11294,7 @@
         <p:spPr>
           <a:xfrm>
             <a:off x="6172200" y="1115568"/>
-            <a:ext cx="5623560" cy="2331720"/>
+            <a:ext cx="5623560" cy="2066543"/>
           </a:xfrm>
           <a:prstGeom prst="roundRect">
             <a:avLst/>
@@ -11446,7 +11392,7 @@
         <p:spPr>
           <a:xfrm>
             <a:off x="6309360" y="1353312"/>
-            <a:ext cx="5349240" cy="2011680"/>
+            <a:ext cx="5349240" cy="1755648"/>
           </a:xfrm>
           <a:prstGeom prst="rect">
             <a:avLst/>
@@ -11486,7 +11432,7 @@
           <a:p>
             <a:pPr>
               <a:spcBef>
-                <a:spcPts val="350"/>
+                <a:spcPts val="300"/>
               </a:spcBef>
             </a:pPr>
             <a:r>
@@ -11511,7 +11457,7 @@
           <a:p>
             <a:pPr>
               <a:spcBef>
-                <a:spcPts val="350"/>
+                <a:spcPts val="300"/>
               </a:spcBef>
             </a:pPr>
             <a:r>
@@ -11536,7 +11482,7 @@
           <a:p>
             <a:pPr>
               <a:spcBef>
-                <a:spcPts val="350"/>
+                <a:spcPts val="300"/>
               </a:spcBef>
             </a:pPr>
             <a:r>
@@ -11568,8 +11514,8 @@
         </p:nvSpPr>
         <p:spPr>
           <a:xfrm>
-            <a:off x="6172200" y="3611880"/>
-            <a:ext cx="5623560" cy="2459736"/>
+            <a:off x="6172200" y="3291840"/>
+            <a:ext cx="5623560" cy="2779776"/>
           </a:xfrm>
           <a:prstGeom prst="roundRect">
             <a:avLst/>
@@ -11613,7 +11559,7 @@
         </p:nvSpPr>
         <p:spPr>
           <a:xfrm>
-            <a:off x="6309360" y="3493008"/>
+            <a:off x="6309360" y="3182112"/>
             <a:ext cx="5349240" cy="274320"/>
           </a:xfrm>
           <a:prstGeom prst="roundRect">
@@ -11653,21 +11599,45 @@
               </a:defRPr>
             </a:pPr>
             <a:r>
-              <a:t>VERIFIED PROJECT RESOURCES &amp; LIVE DEPLOYMENT STATUS</a:t>
-            </a:r>
-          </a:p>
-        </p:txBody>
-      </p:sp>
-      <p:sp>
-        <p:nvSpPr>
-          <p:cNvPr id="17418" name="TextBox 17417"/>
+              <a:t>TAMPER-EVIDENT AUDIT LEDGER &amp; LIVE DEPLOYMENT</a:t>
+            </a:r>
+          </a:p>
+        </p:txBody>
+      </p:sp>
+      <p:pic>
+        <p:nvPicPr>
+          <p:cNvPr id="17418" name="Picture 17417" descr="slide_6_Picture 3.png"/>
+          <p:cNvPicPr>
+            <a:picLocks noChangeAspect="1"/>
+          </p:cNvPicPr>
+          <p:nvPr/>
+        </p:nvPicPr>
+        <p:blipFill>
+          <a:blip r:embed="rId4"/>
+          <a:stretch>
+            <a:fillRect/>
+          </a:stretch>
+        </p:blipFill>
+        <p:spPr>
+          <a:xfrm>
+            <a:off x="6281928" y="3493008"/>
+            <a:ext cx="5404104" cy="1371600"/>
+          </a:xfrm>
+          <a:prstGeom prst="rect">
+            <a:avLst/>
+          </a:prstGeom>
+        </p:spPr>
+      </p:pic>
+      <p:sp>
+        <p:nvSpPr>
+          <p:cNvPr id="17419" name="TextBox 17418"/>
           <p:cNvSpPr txBox="1"/>
           <p:nvPr/>
         </p:nvSpPr>
         <p:spPr>
           <a:xfrm>
-            <a:off x="6309360" y="3840480"/>
-            <a:ext cx="5349240" cy="2148840"/>
+            <a:off x="6281928" y="4919472"/>
+            <a:ext cx="5404104" cy="1097280"/>
           </a:xfrm>
           <a:prstGeom prst="rect">
             <a:avLst/>
@@ -11686,7 +11656,7 @@
               </a:spcBef>
             </a:pPr>
             <a:r>
-              <a:rPr sz="850" b="1">
+              <a:rPr sz="819" b="1">
                 <a:solidFill>
                   <a:srgbClr val="008C6E"/>
                 </a:solidFill>
@@ -11695,91 +11665,88 @@
               <a:t>- Live Web Platform: </a:t>
             </a:r>
             <a:r>
-              <a:rPr sz="800">
+              <a:rPr sz="780">
                 <a:solidFill>
                   <a:srgbClr val="222222"/>
                 </a:solidFill>
                 <a:latin typeface="Arial"/>
               </a:rPr>
-              <a:t>https://brainforge.info | https://pramaan.brainforge.info
-(Production Vercel Edge with custom domain &amp; Let's Encrypt SSL)</a:t>
+              <a:t>https://brainforge.info | https://pramaan.brainforge.info (Vercel Edge, SSL active)</a:t>
             </a:r>
           </a:p>
           <a:p>
             <a:pPr>
               <a:spcBef>
-                <a:spcPts val="350"/>
+                <a:spcPts val="200"/>
               </a:spcBef>
             </a:pPr>
             <a:r>
-              <a:rPr sz="850" b="1">
+              <a:rPr sz="819" b="1">
                 <a:solidFill>
                   <a:srgbClr val="008C6E"/>
                 </a:solidFill>
                 <a:latin typeface="Arial"/>
               </a:rPr>
-              <a:t>- Interactive Backend API &amp; Docs: </a:t>
-            </a:r>
-            <a:r>
-              <a:rPr sz="800">
+              <a:t>- Live Backend &amp; API: </a:t>
+            </a:r>
+            <a:r>
+              <a:rPr sz="780">
                 <a:solidFill>
                   <a:srgbClr val="222222"/>
                 </a:solidFill>
                 <a:latin typeface="Arial"/>
               </a:rPr>
-              <a:t>https://apaar-id-based-system.onrender.com/docs
-(FastAPI OpenAPI 3.1 live documentation with 73 endpoints across 67 paths)</a:t>
+              <a:t>https://apaar-id-based-system.onrender.com/docs (73 OpenAPI endpoints)</a:t>
             </a:r>
           </a:p>
           <a:p>
             <a:pPr>
               <a:spcBef>
-                <a:spcPts val="350"/>
+                <a:spcPts val="200"/>
               </a:spcBef>
             </a:pPr>
             <a:r>
-              <a:rPr sz="850" b="1">
+              <a:rPr sz="819" b="1">
                 <a:solidFill>
                   <a:srgbClr val="008C6E"/>
                 </a:solidFill>
                 <a:latin typeface="Arial"/>
               </a:rPr>
-              <a:t>- Open-Source GitHub Repository: </a:t>
-            </a:r>
-            <a:r>
-              <a:rPr sz="800">
+              <a:t>- Source Repository: </a:t>
+            </a:r>
+            <a:r>
+              <a:rPr sz="780">
                 <a:solidFill>
                   <a:srgbClr val="222222"/>
                 </a:solidFill>
                 <a:latin typeface="Arial"/>
               </a:rPr>
-              <a:t>https://github.com/naveeshpcbin/APAAR-ID-BASED-SYSTEM
-(Complete source code, 20 application models, Alembic migrations, test suites)</a:t>
+              <a:t>https://github.com/naveeshpcbin/APAAR-ID-BASED-SYSTEM (Full code, tests, migrations)</a:t>
             </a:r>
           </a:p>
           <a:p>
             <a:pPr>
               <a:spcBef>
-                <a:spcPts val="350"/>
+                <a:spcPts val="200"/>
               </a:spcBef>
             </a:pPr>
             <a:r>
-              <a:rPr sz="850" b="1">
+              <a:rPr sz="819" b="1">
                 <a:solidFill>
                   <a:srgbClr val="008C6E"/>
                 </a:solidFill>
                 <a:latin typeface="Arial"/>
               </a:rPr>
-              <a:t>- Verified Test Suite: </a:t>
-            </a:r>
-            <a:r>
-              <a:rPr sz="800">
+              <a:t>- Verification Status: </a:t>
+            </a:r>
+            <a:r>
+              <a:rPr sz="780">
                 <a:solidFill>
                   <a:srgbClr val="222222"/>
                 </a:solidFill>
                 <a:latin typeface="Arial"/>
               </a:rPr>
-              <a:t>66/66 pytest unit tests passing + 20/20 Phase F E2E checks + 10/10 live cloud integration tests verified.</a:t>
+              <a:t>66/66 Unit Tests + 20 Phase F E2E Checks + Live Cloud Verified</a:t>
             </a:r>
           </a:p>
         </p:txBody>

</xml_diff>